<commit_message>
update on 2026-03-23 16:05
</commit_message>
<xml_diff>
--- a/Presentations/Graphs/Parameters Scatter.pptx
+++ b/Presentations/Graphs/Parameters Scatter.pptx
@@ -8,7 +8,7 @@
     <p:notesMasterId r:id="rId5"/>
   </p:notesMasterIdLst>
   <p:handoutMasterIdLst>
-    <p:handoutMasterId r:id="rId20"/>
+    <p:handoutMasterId r:id="rId21"/>
   </p:handoutMasterIdLst>
   <p:sldIdLst>
     <p:sldId id="256" r:id="rId3"/>
@@ -25,8 +25,9 @@
     <p:sldId id="266" r:id="rId15"/>
     <p:sldId id="270" r:id="rId16"/>
     <p:sldId id="261" r:id="rId17"/>
-    <p:sldId id="265" r:id="rId18"/>
-    <p:sldId id="268" r:id="rId19"/>
+    <p:sldId id="272" r:id="rId18"/>
+    <p:sldId id="265" r:id="rId19"/>
+    <p:sldId id="268" r:id="rId20"/>
   </p:sldIdLst>
   <p:sldSz cx="14399895" cy="8099425"/>
   <p:notesSz cx="7103745" cy="10234295"/>
@@ -148,6 +149,7 @@
             <p14:sldId id="266"/>
             <p14:sldId id="270"/>
             <p14:sldId id="261"/>
+            <p14:sldId id="272"/>
             <p14:sldId id="265"/>
             <p14:sldId id="268"/>
           </p14:sldIdLst>
@@ -161,12 +163,12 @@
             <a:srgbClr val="A4A3A4"/>
           </p15:clr>
         </p15:guide>
-        <p15:guide id="2" pos="4560" userDrawn="1">
+        <p15:guide id="2" pos="4535" userDrawn="1">
           <p15:clr>
             <a:srgbClr val="A4A3A4"/>
           </p15:clr>
         </p15:guide>
-        <p15:guide id="3" orient="horz" pos="2601" userDrawn="1">
+        <p15:guide id="3" orient="horz" pos="2568" userDrawn="1">
           <p15:clr>
             <a:srgbClr val="A4A3A4"/>
           </p15:clr>
@@ -11185,16 +11187,16 @@
       <p:grpSpPr/>
       <p:grpSp>
         <p:nvGrpSpPr>
-          <p:cNvPr id="74" name="组合 73"/>
+          <p:cNvPr id="3" name="组合 2"/>
           <p:cNvGrpSpPr/>
           <p:nvPr/>
         </p:nvGrpSpPr>
         <p:grpSpPr>
           <a:xfrm>
-            <a:off x="658495" y="692150"/>
-            <a:ext cx="13425805" cy="6263005"/>
-            <a:chOff x="1136" y="1090"/>
-            <a:chExt cx="21143" cy="9863"/>
+            <a:off x="3465195" y="692150"/>
+            <a:ext cx="6700520" cy="6842760"/>
+            <a:chOff x="5458" y="1090"/>
+            <a:chExt cx="10552" cy="10776"/>
           </a:xfrm>
         </p:grpSpPr>
         <p:sp>
@@ -11205,8 +11207,8 @@
           </p:nvSpPr>
           <p:spPr>
             <a:xfrm>
-              <a:off x="1136" y="1090"/>
-              <a:ext cx="21143" cy="9863"/>
+              <a:off x="5458" y="1090"/>
+              <a:ext cx="10553" cy="10777"/>
             </a:xfrm>
             <a:prstGeom prst="rect">
               <a:avLst/>
@@ -11242,627 +11244,96 @@
             </a:p>
           </p:txBody>
         </p:sp>
+        <p:sp>
+          <p:nvSpPr>
+            <p:cNvPr id="31" name="文本框 30"/>
+            <p:cNvSpPr txBox="1"/>
+            <p:nvPr/>
+          </p:nvSpPr>
+          <p:spPr>
+            <a:xfrm>
+              <a:off x="6121" y="1175"/>
+              <a:ext cx="9268" cy="725"/>
+            </a:xfrm>
+            <a:prstGeom prst="rect">
+              <a:avLst/>
+            </a:prstGeom>
+            <a:noFill/>
+          </p:spPr>
+          <p:txBody>
+            <a:bodyPr wrap="square" rtlCol="0">
+              <a:spAutoFit/>
+            </a:bodyPr>
+            <a:p>
+              <a:pPr algn="ctr"/>
+              <a:r>
+                <a:rPr lang="en-US" altLang="zh-CN" sz="2400"/>
+                <a:t>Veritical - Height</a:t>
+              </a:r>
+              <a:endParaRPr lang="en-US" altLang="zh-CN" sz="2400"/>
+            </a:p>
+          </p:txBody>
+        </p:sp>
+        <p:sp>
+          <p:nvSpPr>
+            <p:cNvPr id="54" name="文本框 53"/>
+            <p:cNvSpPr txBox="1"/>
+            <p:nvPr/>
+          </p:nvSpPr>
+          <p:spPr>
+            <a:xfrm>
+              <a:off x="8370" y="9019"/>
+              <a:ext cx="5625" cy="507"/>
+            </a:xfrm>
+            <a:prstGeom prst="rect">
+              <a:avLst/>
+            </a:prstGeom>
+            <a:noFill/>
+          </p:spPr>
+          <p:txBody>
+            <a:bodyPr wrap="square" rtlCol="0">
+              <a:spAutoFit/>
+            </a:bodyPr>
+            <a:p>
+              <a:pPr algn="ctr"/>
+              <a:r>
+                <a:rPr lang="en-US" altLang="zh-CN" sz="1500" b="1">
+                  <a:latin typeface="Arial" panose="020B0604020202020204" pitchFamily="34" charset="0"/>
+                  <a:cs typeface="Arial" panose="020B0604020202020204" pitchFamily="34" charset="0"/>
+                </a:rPr>
+                <a:t>Vertical Profile Categories</a:t>
+              </a:r>
+              <a:endParaRPr lang="en-US" altLang="zh-CN" sz="1500" b="1">
+                <a:latin typeface="Arial" panose="020B0604020202020204" pitchFamily="34" charset="0"/>
+                <a:cs typeface="Arial" panose="020B0604020202020204" pitchFamily="34" charset="0"/>
+              </a:endParaRPr>
+            </a:p>
+          </p:txBody>
+        </p:sp>
         <p:grpSp>
           <p:nvGrpSpPr>
-            <p:cNvPr id="72" name="组合 71"/>
+            <p:cNvPr id="70" name="组合 69"/>
             <p:cNvGrpSpPr/>
             <p:nvPr/>
           </p:nvGrpSpPr>
           <p:grpSpPr>
-            <a:xfrm>
-              <a:off x="1136" y="1090"/>
-              <a:ext cx="20406" cy="9713"/>
-              <a:chOff x="1136" y="1090"/>
-              <a:chExt cx="20406" cy="9713"/>
+            <a:xfrm rot="0">
+              <a:off x="6975" y="1967"/>
+              <a:ext cx="7636" cy="7079"/>
+              <a:chOff x="3143" y="2576"/>
+              <a:chExt cx="6906" cy="6401"/>
             </a:xfrm>
           </p:grpSpPr>
-          <p:grpSp>
-            <p:nvGrpSpPr>
-              <p:cNvPr id="71" name="组合 70"/>
-              <p:cNvGrpSpPr/>
-              <p:nvPr/>
-            </p:nvGrpSpPr>
-            <p:grpSpPr>
-              <a:xfrm>
-                <a:off x="12219" y="1882"/>
-                <a:ext cx="7706" cy="7101"/>
-                <a:chOff x="12978" y="2543"/>
-                <a:chExt cx="6996" cy="6447"/>
-              </a:xfrm>
-            </p:grpSpPr>
-            <p:sp>
-              <p:nvSpPr>
-                <p:cNvPr id="55" name="文本框 54"/>
-                <p:cNvSpPr txBox="1"/>
-                <p:nvPr/>
-              </p:nvSpPr>
-              <p:spPr>
-                <a:xfrm>
-                  <a:off x="13112" y="8067"/>
-                  <a:ext cx="1602" cy="527"/>
-                </a:xfrm>
-                <a:prstGeom prst="rect">
-                  <a:avLst/>
-                </a:prstGeom>
-                <a:noFill/>
-              </p:spPr>
-              <p:txBody>
-                <a:bodyPr wrap="square" rtlCol="0">
-                  <a:spAutoFit/>
-                </a:bodyPr>
-                <a:p>
-                  <a:pPr algn="ctr"/>
-                  <a:r>
-                    <a:rPr lang="en-US" altLang="zh-CN"/>
-                    <a:t>Africa</a:t>
-                  </a:r>
-                  <a:endParaRPr lang="en-US" altLang="zh-CN"/>
-                </a:p>
-              </p:txBody>
-            </p:sp>
-            <p:sp>
-              <p:nvSpPr>
-                <p:cNvPr id="56" name="文本框 55"/>
-                <p:cNvSpPr txBox="1"/>
-                <p:nvPr/>
-              </p:nvSpPr>
-              <p:spPr>
-                <a:xfrm>
-                  <a:off x="15230" y="8068"/>
-                  <a:ext cx="2558" cy="922"/>
-                </a:xfrm>
-                <a:prstGeom prst="rect">
-                  <a:avLst/>
-                </a:prstGeom>
-                <a:noFill/>
-              </p:spPr>
-              <p:txBody>
-                <a:bodyPr wrap="square" rtlCol="0">
-                  <a:spAutoFit/>
-                </a:bodyPr>
-                <a:p>
-                  <a:pPr algn="ctr"/>
-                  <a:r>
-                    <a:rPr lang="en-US" altLang="zh-CN"/>
-                    <a:t>South &amp; Southeast Asia</a:t>
-                  </a:r>
-                  <a:endParaRPr lang="en-US" altLang="zh-CN"/>
-                </a:p>
-              </p:txBody>
-            </p:sp>
-            <p:sp>
-              <p:nvSpPr>
-                <p:cNvPr id="57" name="文本框 56"/>
-                <p:cNvSpPr txBox="1"/>
-                <p:nvPr/>
-              </p:nvSpPr>
-              <p:spPr>
-                <a:xfrm>
-                  <a:off x="18103" y="8068"/>
-                  <a:ext cx="1810" cy="922"/>
-                </a:xfrm>
-                <a:prstGeom prst="rect">
-                  <a:avLst/>
-                </a:prstGeom>
-                <a:noFill/>
-              </p:spPr>
-              <p:txBody>
-                <a:bodyPr wrap="square" rtlCol="0">
-                  <a:spAutoFit/>
-                </a:bodyPr>
-                <a:p>
-                  <a:pPr algn="ctr"/>
-                  <a:r>
-                    <a:rPr lang="en-US" altLang="zh-CN">
-                      <a:ea typeface="宋体" panose="02010600030101010101" pitchFamily="2" charset="-122"/>
-                    </a:rPr>
-                    <a:t>Latin</a:t>
-                  </a:r>
-                  <a:endParaRPr lang="en-US" altLang="zh-CN">
-                    <a:ea typeface="宋体" panose="02010600030101010101" pitchFamily="2" charset="-122"/>
-                  </a:endParaRPr>
-                </a:p>
-                <a:p>
-                  <a:pPr algn="ctr"/>
-                  <a:r>
-                    <a:rPr lang="en-US" altLang="zh-CN">
-                      <a:ea typeface="宋体" panose="02010600030101010101" pitchFamily="2" charset="-122"/>
-                    </a:rPr>
-                    <a:t>America</a:t>
-                  </a:r>
-                  <a:endParaRPr lang="en-US" altLang="zh-CN">
-                    <a:ea typeface="宋体" panose="02010600030101010101" pitchFamily="2" charset="-122"/>
-                  </a:endParaRPr>
-                </a:p>
-              </p:txBody>
-            </p:sp>
-            <p:sp>
-              <p:nvSpPr>
-                <p:cNvPr id="64" name="文本框 63"/>
-                <p:cNvSpPr txBox="1"/>
-                <p:nvPr/>
-              </p:nvSpPr>
-              <p:spPr>
-                <a:xfrm>
-                  <a:off x="12978" y="2543"/>
-                  <a:ext cx="933" cy="439"/>
-                </a:xfrm>
-                <a:prstGeom prst="rect">
-                  <a:avLst/>
-                </a:prstGeom>
-                <a:noFill/>
-              </p:spPr>
-              <p:txBody>
-                <a:bodyPr wrap="square" rtlCol="0">
-                  <a:spAutoFit/>
-                </a:bodyPr>
-                <a:p>
-                  <a:pPr algn="ctr"/>
-                  <a:r>
-                    <a:rPr lang="en-US" altLang="zh-CN" sz="1400"/>
-                    <a:t>2016</a:t>
-                  </a:r>
-                  <a:endParaRPr lang="en-US" altLang="zh-CN" sz="1400"/>
-                </a:p>
-              </p:txBody>
-            </p:sp>
-            <p:sp>
-              <p:nvSpPr>
-                <p:cNvPr id="65" name="文本框 64"/>
-                <p:cNvSpPr txBox="1"/>
-                <p:nvPr/>
-              </p:nvSpPr>
-              <p:spPr>
-                <a:xfrm>
-                  <a:off x="13953" y="2543"/>
-                  <a:ext cx="933" cy="439"/>
-                </a:xfrm>
-                <a:prstGeom prst="rect">
-                  <a:avLst/>
-                </a:prstGeom>
-                <a:noFill/>
-              </p:spPr>
-              <p:txBody>
-                <a:bodyPr wrap="square" rtlCol="0">
-                  <a:spAutoFit/>
-                </a:bodyPr>
-                <a:p>
-                  <a:pPr algn="ctr"/>
-                  <a:r>
-                    <a:rPr lang="en-US" altLang="zh-CN" sz="1400"/>
-                    <a:t>2023</a:t>
-                  </a:r>
-                  <a:endParaRPr lang="en-US" altLang="zh-CN" sz="1400"/>
-                </a:p>
-              </p:txBody>
-            </p:sp>
-            <p:sp>
-              <p:nvSpPr>
-                <p:cNvPr id="66" name="文本框 65"/>
-                <p:cNvSpPr txBox="1"/>
-                <p:nvPr/>
-              </p:nvSpPr>
-              <p:spPr>
-                <a:xfrm>
-                  <a:off x="15477" y="2543"/>
-                  <a:ext cx="933" cy="439"/>
-                </a:xfrm>
-                <a:prstGeom prst="rect">
-                  <a:avLst/>
-                </a:prstGeom>
-                <a:noFill/>
-              </p:spPr>
-              <p:txBody>
-                <a:bodyPr wrap="square" rtlCol="0">
-                  <a:spAutoFit/>
-                </a:bodyPr>
-                <a:p>
-                  <a:pPr algn="ctr"/>
-                  <a:r>
-                    <a:rPr lang="en-US" altLang="zh-CN" sz="1400"/>
-                    <a:t>2016</a:t>
-                  </a:r>
-                  <a:endParaRPr lang="en-US" altLang="zh-CN" sz="1400"/>
-                </a:p>
-              </p:txBody>
-            </p:sp>
-            <p:sp>
-              <p:nvSpPr>
-                <p:cNvPr id="67" name="文本框 66"/>
-                <p:cNvSpPr txBox="1"/>
-                <p:nvPr/>
-              </p:nvSpPr>
-              <p:spPr>
-                <a:xfrm>
-                  <a:off x="16452" y="2543"/>
-                  <a:ext cx="933" cy="439"/>
-                </a:xfrm>
-                <a:prstGeom prst="rect">
-                  <a:avLst/>
-                </a:prstGeom>
-                <a:noFill/>
-              </p:spPr>
-              <p:txBody>
-                <a:bodyPr wrap="square" rtlCol="0">
-                  <a:spAutoFit/>
-                </a:bodyPr>
-                <a:p>
-                  <a:pPr algn="ctr"/>
-                  <a:r>
-                    <a:rPr lang="en-US" altLang="zh-CN" sz="1400"/>
-                    <a:t>2023</a:t>
-                  </a:r>
-                  <a:endParaRPr lang="en-US" altLang="zh-CN" sz="1400"/>
-                </a:p>
-              </p:txBody>
-            </p:sp>
-            <p:sp>
-              <p:nvSpPr>
-                <p:cNvPr id="68" name="文本框 67"/>
-                <p:cNvSpPr txBox="1"/>
-                <p:nvPr/>
-              </p:nvSpPr>
-              <p:spPr>
-                <a:xfrm>
-                  <a:off x="18066" y="2543"/>
-                  <a:ext cx="933" cy="439"/>
-                </a:xfrm>
-                <a:prstGeom prst="rect">
-                  <a:avLst/>
-                </a:prstGeom>
-                <a:noFill/>
-              </p:spPr>
-              <p:txBody>
-                <a:bodyPr wrap="square" rtlCol="0">
-                  <a:spAutoFit/>
-                </a:bodyPr>
-                <a:p>
-                  <a:pPr algn="ctr"/>
-                  <a:r>
-                    <a:rPr lang="en-US" altLang="zh-CN" sz="1400"/>
-                    <a:t>2016</a:t>
-                  </a:r>
-                  <a:endParaRPr lang="en-US" altLang="zh-CN" sz="1400"/>
-                </a:p>
-              </p:txBody>
-            </p:sp>
-            <p:sp>
-              <p:nvSpPr>
-                <p:cNvPr id="69" name="文本框 68"/>
-                <p:cNvSpPr txBox="1"/>
-                <p:nvPr/>
-              </p:nvSpPr>
-              <p:spPr>
-                <a:xfrm>
-                  <a:off x="19041" y="2543"/>
-                  <a:ext cx="933" cy="439"/>
-                </a:xfrm>
-                <a:prstGeom prst="rect">
-                  <a:avLst/>
-                </a:prstGeom>
-                <a:noFill/>
-              </p:spPr>
-              <p:txBody>
-                <a:bodyPr wrap="square" rtlCol="0">
-                  <a:spAutoFit/>
-                </a:bodyPr>
-                <a:p>
-                  <a:pPr algn="ctr"/>
-                  <a:r>
-                    <a:rPr lang="en-US" altLang="zh-CN" sz="1400"/>
-                    <a:t>2023</a:t>
-                  </a:r>
-                  <a:endParaRPr lang="en-US" altLang="zh-CN" sz="1400"/>
-                </a:p>
-              </p:txBody>
-            </p:sp>
-          </p:grpSp>
           <p:sp>
             <p:nvSpPr>
-              <p:cNvPr id="14" name="矩形 13"/>
-              <p:cNvSpPr/>
-              <p:nvPr/>
-            </p:nvSpPr>
-            <p:spPr>
-              <a:xfrm>
-                <a:off x="2194" y="9790"/>
-                <a:ext cx="737" cy="442"/>
-              </a:xfrm>
-              <a:prstGeom prst="rect">
-                <a:avLst/>
-              </a:prstGeom>
-              <a:solidFill>
-                <a:srgbClr val="9EDAE5"/>
-              </a:solidFill>
-              <a:ln>
-                <a:noFill/>
-              </a:ln>
-            </p:spPr>
-            <p:style>
-              <a:lnRef idx="2">
-                <a:schemeClr val="accent1">
-                  <a:lumMod val="75000"/>
-                </a:schemeClr>
-              </a:lnRef>
-              <a:fillRef idx="1">
-                <a:schemeClr val="accent1"/>
-              </a:fillRef>
-              <a:effectRef idx="0">
-                <a:srgbClr val="FFFFFF"/>
-              </a:effectRef>
-              <a:fontRef idx="minor">
-                <a:schemeClr val="lt1"/>
-              </a:fontRef>
-            </p:style>
-            <p:txBody>
-              <a:bodyPr rtlCol="0" anchor="ctr"/>
-              <a:p>
-                <a:pPr algn="ctr"/>
-                <a:endParaRPr lang="zh-CN" altLang="en-US"/>
-              </a:p>
-            </p:txBody>
-          </p:sp>
-          <p:sp>
-            <p:nvSpPr>
-              <p:cNvPr id="15" name="文本框 14"/>
+              <p:cNvPr id="10" name="文本框 9"/>
               <p:cNvSpPr txBox="1"/>
               <p:nvPr/>
             </p:nvSpPr>
             <p:spPr>
               <a:xfrm>
-                <a:off x="3056" y="9725"/>
-                <a:ext cx="3409" cy="507"/>
-              </a:xfrm>
-              <a:prstGeom prst="rect">
-                <a:avLst/>
-              </a:prstGeom>
-              <a:noFill/>
-            </p:spPr>
-            <p:txBody>
-              <a:bodyPr wrap="square" rtlCol="0">
-                <a:spAutoFit/>
-              </a:bodyPr>
-              <a:p>
-                <a:r>
-                  <a:rPr lang="en-US" altLang="zh-CN" sz="1500"/>
-                  <a:t>Uniformly Developable</a:t>
-                </a:r>
-                <a:endParaRPr lang="en-US" altLang="zh-CN" sz="1500"/>
-              </a:p>
-            </p:txBody>
-          </p:sp>
-          <p:sp>
-            <p:nvSpPr>
-              <p:cNvPr id="16" name="矩形 15"/>
-              <p:cNvSpPr/>
-              <p:nvPr/>
-            </p:nvSpPr>
-            <p:spPr>
-              <a:xfrm>
-                <a:off x="2194" y="10340"/>
-                <a:ext cx="737" cy="442"/>
-              </a:xfrm>
-              <a:prstGeom prst="rect">
-                <a:avLst/>
-              </a:prstGeom>
-              <a:solidFill>
-                <a:srgbClr val="F7B6D2"/>
-              </a:solidFill>
-              <a:ln>
-                <a:noFill/>
-              </a:ln>
-            </p:spPr>
-            <p:style>
-              <a:lnRef idx="2">
-                <a:schemeClr val="accent1">
-                  <a:lumMod val="75000"/>
-                </a:schemeClr>
-              </a:lnRef>
-              <a:fillRef idx="1">
-                <a:schemeClr val="accent1"/>
-              </a:fillRef>
-              <a:effectRef idx="0">
-                <a:srgbClr val="FFFFFF"/>
-              </a:effectRef>
-              <a:fontRef idx="minor">
-                <a:schemeClr val="lt1"/>
-              </a:fontRef>
-            </p:style>
-            <p:txBody>
-              <a:bodyPr rtlCol="0" anchor="ctr"/>
-              <a:p>
-                <a:pPr algn="ctr"/>
-                <a:endParaRPr lang="zh-CN" altLang="en-US"/>
-              </a:p>
-            </p:txBody>
-          </p:sp>
-          <p:sp>
-            <p:nvSpPr>
-              <p:cNvPr id="17" name="文本框 16"/>
-              <p:cNvSpPr txBox="1"/>
-              <p:nvPr/>
-            </p:nvSpPr>
-            <p:spPr>
-              <a:xfrm>
-                <a:off x="3056" y="10275"/>
-                <a:ext cx="3690" cy="507"/>
-              </a:xfrm>
-              <a:prstGeom prst="rect">
-                <a:avLst/>
-              </a:prstGeom>
-              <a:noFill/>
-            </p:spPr>
-            <p:txBody>
-              <a:bodyPr wrap="square" rtlCol="0">
-                <a:spAutoFit/>
-              </a:bodyPr>
-              <a:p>
-                <a:r>
-                  <a:rPr lang="en-US" altLang="zh-CN" sz="1500"/>
-                  <a:t>Uniformly Constrianed</a:t>
-                </a:r>
-                <a:endParaRPr lang="en-US" altLang="zh-CN" sz="1500"/>
-              </a:p>
-            </p:txBody>
-          </p:sp>
-          <p:sp>
-            <p:nvSpPr>
-              <p:cNvPr id="18" name="矩形 17"/>
-              <p:cNvSpPr/>
-              <p:nvPr/>
-            </p:nvSpPr>
-            <p:spPr>
-              <a:xfrm>
-                <a:off x="6868" y="9769"/>
-                <a:ext cx="737" cy="442"/>
-              </a:xfrm>
-              <a:prstGeom prst="rect">
-                <a:avLst/>
-              </a:prstGeom>
-              <a:solidFill>
-                <a:srgbClr val="D62728"/>
-              </a:solidFill>
-              <a:ln>
-                <a:noFill/>
-              </a:ln>
-            </p:spPr>
-            <p:style>
-              <a:lnRef idx="2">
-                <a:schemeClr val="accent1">
-                  <a:lumMod val="75000"/>
-                </a:schemeClr>
-              </a:lnRef>
-              <a:fillRef idx="1">
-                <a:schemeClr val="accent1"/>
-              </a:fillRef>
-              <a:effectRef idx="0">
-                <a:srgbClr val="FFFFFF"/>
-              </a:effectRef>
-              <a:fontRef idx="minor">
-                <a:schemeClr val="lt1"/>
-              </a:fontRef>
-            </p:style>
-            <p:txBody>
-              <a:bodyPr rtlCol="0" anchor="ctr"/>
-              <a:p>
-                <a:pPr algn="ctr"/>
-                <a:endParaRPr lang="zh-CN" altLang="en-US"/>
-              </a:p>
-            </p:txBody>
-          </p:sp>
-          <p:sp>
-            <p:nvSpPr>
-              <p:cNvPr id="19" name="矩形 18"/>
-              <p:cNvSpPr/>
-              <p:nvPr/>
-            </p:nvSpPr>
-            <p:spPr>
-              <a:xfrm>
-                <a:off x="6868" y="10319"/>
-                <a:ext cx="737" cy="442"/>
-              </a:xfrm>
-              <a:prstGeom prst="rect">
-                <a:avLst/>
-              </a:prstGeom>
-              <a:solidFill>
-                <a:srgbClr val="1F77B4"/>
-              </a:solidFill>
-              <a:ln>
-                <a:noFill/>
-              </a:ln>
-            </p:spPr>
-            <p:style>
-              <a:lnRef idx="2">
-                <a:schemeClr val="accent1">
-                  <a:lumMod val="75000"/>
-                </a:schemeClr>
-              </a:lnRef>
-              <a:fillRef idx="1">
-                <a:schemeClr val="accent1"/>
-              </a:fillRef>
-              <a:effectRef idx="0">
-                <a:srgbClr val="FFFFFF"/>
-              </a:effectRef>
-              <a:fontRef idx="minor">
-                <a:schemeClr val="lt1"/>
-              </a:fontRef>
-            </p:style>
-            <p:txBody>
-              <a:bodyPr rtlCol="0" anchor="ctr"/>
-              <a:p>
-                <a:pPr algn="ctr"/>
-                <a:endParaRPr lang="zh-CN" altLang="en-US"/>
-              </a:p>
-            </p:txBody>
-          </p:sp>
-          <p:sp>
-            <p:nvSpPr>
-              <p:cNvPr id="20" name="文本框 19"/>
-              <p:cNvSpPr txBox="1"/>
-              <p:nvPr/>
-            </p:nvSpPr>
-            <p:spPr>
-              <a:xfrm>
-                <a:off x="7721" y="9747"/>
-                <a:ext cx="4039" cy="507"/>
-              </a:xfrm>
-              <a:prstGeom prst="rect">
-                <a:avLst/>
-              </a:prstGeom>
-              <a:noFill/>
-            </p:spPr>
-            <p:txBody>
-              <a:bodyPr wrap="square" rtlCol="0">
-                <a:spAutoFit/>
-              </a:bodyPr>
-              <a:p>
-                <a:r>
-                  <a:rPr lang="en-US" altLang="zh-CN" sz="1500"/>
-                  <a:t>Core-Open, Edge-Locked</a:t>
-                </a:r>
-                <a:endParaRPr lang="en-US" altLang="zh-CN" sz="1500"/>
-              </a:p>
-            </p:txBody>
-          </p:sp>
-          <p:sp>
-            <p:nvSpPr>
-              <p:cNvPr id="21" name="文本框 20"/>
-              <p:cNvSpPr txBox="1"/>
-              <p:nvPr/>
-            </p:nvSpPr>
-            <p:spPr>
-              <a:xfrm>
-                <a:off x="7721" y="10254"/>
-                <a:ext cx="4039" cy="507"/>
-              </a:xfrm>
-              <a:prstGeom prst="rect">
-                <a:avLst/>
-              </a:prstGeom>
-              <a:noFill/>
-            </p:spPr>
-            <p:txBody>
-              <a:bodyPr wrap="square" rtlCol="0">
-                <a:spAutoFit/>
-              </a:bodyPr>
-              <a:p>
-                <a:r>
-                  <a:rPr lang="en-US" altLang="zh-CN" sz="1500"/>
-                  <a:t>Core-Limited, Edge-Locked</a:t>
-                </a:r>
-                <a:endParaRPr lang="en-US" altLang="zh-CN" sz="1500"/>
-              </a:p>
-            </p:txBody>
-          </p:sp>
-          <p:sp>
-            <p:nvSpPr>
-              <p:cNvPr id="29" name="文本框 28"/>
-              <p:cNvSpPr txBox="1"/>
-              <p:nvPr/>
-            </p:nvSpPr>
-            <p:spPr>
-              <a:xfrm>
-                <a:off x="4076" y="9218"/>
-                <a:ext cx="5625" cy="507"/>
+                <a:off x="3279" y="8057"/>
+                <a:ext cx="1602" cy="524"/>
               </a:xfrm>
               <a:prstGeom prst="rect">
                 <a:avLst/>
@@ -11876,29 +11347,23 @@
               <a:p>
                 <a:pPr algn="ctr"/>
                 <a:r>
-                  <a:rPr lang="en-US" altLang="zh-CN" sz="1500" b="1">
-                    <a:latin typeface="Arial" panose="020B0604020202020204" pitchFamily="34" charset="0"/>
-                    <a:cs typeface="Arial" panose="020B0604020202020204" pitchFamily="34" charset="0"/>
-                  </a:rPr>
-                  <a:t>α-β Categories</a:t>
+                  <a:rPr lang="en-US" altLang="zh-CN"/>
+                  <a:t>Africa</a:t>
                 </a:r>
-                <a:endParaRPr lang="en-US" altLang="zh-CN" sz="1500" b="1">
-                  <a:latin typeface="Arial" panose="020B0604020202020204" pitchFamily="34" charset="0"/>
-                  <a:cs typeface="Arial" panose="020B0604020202020204" pitchFamily="34" charset="0"/>
-                </a:endParaRPr>
+                <a:endParaRPr lang="en-US" altLang="zh-CN"/>
               </a:p>
             </p:txBody>
           </p:sp>
           <p:sp>
             <p:nvSpPr>
-              <p:cNvPr id="31" name="文本框 30"/>
+              <p:cNvPr id="11" name="文本框 10"/>
               <p:cNvSpPr txBox="1"/>
               <p:nvPr/>
             </p:nvSpPr>
             <p:spPr>
               <a:xfrm>
-                <a:off x="1136" y="1090"/>
-                <a:ext cx="9268" cy="725"/>
+                <a:off x="5397" y="8058"/>
+                <a:ext cx="2558" cy="919"/>
               </a:xfrm>
               <a:prstGeom prst="rect">
                 <a:avLst/>
@@ -11912,23 +11377,23 @@
               <a:p>
                 <a:pPr algn="ctr"/>
                 <a:r>
-                  <a:rPr lang="en-US" altLang="zh-CN" sz="2400"/>
-                  <a:t>(a) Horizontal - Structural Zero Part</a:t>
+                  <a:rPr lang="en-US" altLang="zh-CN"/>
+                  <a:t>South &amp; Southeast Asia</a:t>
                 </a:r>
-                <a:endParaRPr lang="en-US" altLang="zh-CN" sz="2400"/>
+                <a:endParaRPr lang="en-US" altLang="zh-CN"/>
               </a:p>
             </p:txBody>
           </p:sp>
           <p:sp>
             <p:nvSpPr>
-              <p:cNvPr id="36" name="文本框 35"/>
+              <p:cNvPr id="12" name="文本框 11"/>
               <p:cNvSpPr txBox="1"/>
               <p:nvPr/>
             </p:nvSpPr>
             <p:spPr>
               <a:xfrm>
-                <a:off x="10675" y="1090"/>
-                <a:ext cx="10867" cy="725"/>
+                <a:off x="8099" y="8058"/>
+                <a:ext cx="1810" cy="919"/>
               </a:xfrm>
               <a:prstGeom prst="rect">
                 <a:avLst/>
@@ -11942,319 +11407,39 @@
               <a:p>
                 <a:pPr algn="ctr"/>
                 <a:r>
-                  <a:rPr lang="en-US" altLang="zh-CN" sz="2400"/>
-                  <a:t>(b) Horizontal - Binomial (Real Construction) Part</a:t>
+                  <a:rPr lang="en-US" altLang="zh-CN">
+                    <a:ea typeface="宋体" panose="02010600030101010101" pitchFamily="2" charset="-122"/>
+                  </a:rPr>
+                  <a:t>Latin</a:t>
                 </a:r>
-                <a:endParaRPr lang="en-US" altLang="zh-CN" sz="2400"/>
+                <a:endParaRPr lang="en-US" altLang="zh-CN">
+                  <a:ea typeface="宋体" panose="02010600030101010101" pitchFamily="2" charset="-122"/>
+                </a:endParaRPr>
+              </a:p>
+              <a:p>
+                <a:pPr algn="ctr"/>
+                <a:r>
+                  <a:rPr lang="en-US" altLang="zh-CN">
+                    <a:ea typeface="宋体" panose="02010600030101010101" pitchFamily="2" charset="-122"/>
+                  </a:rPr>
+                  <a:t>America</a:t>
+                </a:r>
+                <a:endParaRPr lang="en-US" altLang="zh-CN">
+                  <a:ea typeface="宋体" panose="02010600030101010101" pitchFamily="2" charset="-122"/>
+                </a:endParaRPr>
               </a:p>
             </p:txBody>
           </p:sp>
           <p:sp>
             <p:nvSpPr>
-              <p:cNvPr id="46" name="矩形 45"/>
-              <p:cNvSpPr/>
-              <p:nvPr/>
-            </p:nvSpPr>
-            <p:spPr>
-              <a:xfrm>
-                <a:off x="12681" y="9790"/>
-                <a:ext cx="737" cy="442"/>
-              </a:xfrm>
-              <a:prstGeom prst="rect">
-                <a:avLst/>
-              </a:prstGeom>
-              <a:solidFill>
-                <a:srgbClr val="B3B3B3"/>
-              </a:solidFill>
-              <a:ln>
-                <a:noFill/>
-              </a:ln>
-            </p:spPr>
-            <p:style>
-              <a:lnRef idx="2">
-                <a:schemeClr val="accent1">
-                  <a:lumMod val="75000"/>
-                </a:schemeClr>
-              </a:lnRef>
-              <a:fillRef idx="1">
-                <a:schemeClr val="accent1"/>
-              </a:fillRef>
-              <a:effectRef idx="0">
-                <a:srgbClr val="FFFFFF"/>
-              </a:effectRef>
-              <a:fontRef idx="minor">
-                <a:schemeClr val="lt1"/>
-              </a:fontRef>
-            </p:style>
-            <p:txBody>
-              <a:bodyPr rtlCol="0" anchor="ctr"/>
-              <a:p>
-                <a:pPr algn="ctr"/>
-                <a:endParaRPr lang="zh-CN" altLang="en-US"/>
-              </a:p>
-            </p:txBody>
-          </p:sp>
-          <p:sp>
-            <p:nvSpPr>
-              <p:cNvPr id="47" name="文本框 46"/>
+              <p:cNvPr id="58" name="文本框 57"/>
               <p:cNvSpPr txBox="1"/>
               <p:nvPr/>
             </p:nvSpPr>
             <p:spPr>
               <a:xfrm>
-                <a:off x="13543" y="9725"/>
-                <a:ext cx="5625" cy="507"/>
-              </a:xfrm>
-              <a:prstGeom prst="rect">
-                <a:avLst/>
-              </a:prstGeom>
-              <a:noFill/>
-            </p:spPr>
-            <p:txBody>
-              <a:bodyPr wrap="square" rtlCol="0">
-                <a:spAutoFit/>
-              </a:bodyPr>
-              <a:p>
-                <a:r>
-                  <a:rPr lang="en-US" altLang="zh-CN" sz="1500"/>
-                  <a:t>Uniformly Sparse</a:t>
-                </a:r>
-                <a:endParaRPr lang="en-US" altLang="zh-CN" sz="1500"/>
-              </a:p>
-            </p:txBody>
-          </p:sp>
-          <p:sp>
-            <p:nvSpPr>
-              <p:cNvPr id="48" name="矩形 47"/>
-              <p:cNvSpPr/>
-              <p:nvPr/>
-            </p:nvSpPr>
-            <p:spPr>
-              <a:xfrm>
-                <a:off x="12681" y="10340"/>
-                <a:ext cx="737" cy="442"/>
-              </a:xfrm>
-              <a:prstGeom prst="rect">
-                <a:avLst/>
-              </a:prstGeom>
-              <a:solidFill>
-                <a:srgbClr val="FFD92F"/>
-              </a:solidFill>
-              <a:ln>
-                <a:noFill/>
-              </a:ln>
-            </p:spPr>
-            <p:style>
-              <a:lnRef idx="2">
-                <a:schemeClr val="accent1">
-                  <a:lumMod val="75000"/>
-                </a:schemeClr>
-              </a:lnRef>
-              <a:fillRef idx="1">
-                <a:schemeClr val="accent1"/>
-              </a:fillRef>
-              <a:effectRef idx="0">
-                <a:srgbClr val="FFFFFF"/>
-              </a:effectRef>
-              <a:fontRef idx="minor">
-                <a:schemeClr val="lt1"/>
-              </a:fontRef>
-            </p:style>
-            <p:txBody>
-              <a:bodyPr rtlCol="0" anchor="ctr"/>
-              <a:p>
-                <a:pPr algn="ctr"/>
-                <a:endParaRPr lang="zh-CN" altLang="en-US"/>
-              </a:p>
-            </p:txBody>
-          </p:sp>
-          <p:sp>
-            <p:nvSpPr>
-              <p:cNvPr id="49" name="文本框 48"/>
-              <p:cNvSpPr txBox="1"/>
-              <p:nvPr/>
-            </p:nvSpPr>
-            <p:spPr>
-              <a:xfrm>
-                <a:off x="13543" y="10296"/>
-                <a:ext cx="5626" cy="507"/>
-              </a:xfrm>
-              <a:prstGeom prst="rect">
-                <a:avLst/>
-              </a:prstGeom>
-              <a:noFill/>
-            </p:spPr>
-            <p:txBody>
-              <a:bodyPr wrap="square" rtlCol="0">
-                <a:spAutoFit/>
-              </a:bodyPr>
-              <a:p>
-                <a:r>
-                  <a:rPr lang="en-US" altLang="zh-CN" sz="1500"/>
-                  <a:t>Uniformly Dense</a:t>
-                </a:r>
-                <a:endParaRPr lang="en-US" altLang="zh-CN" sz="1500"/>
-              </a:p>
-            </p:txBody>
-          </p:sp>
-          <p:sp>
-            <p:nvSpPr>
-              <p:cNvPr id="50" name="矩形 49"/>
-              <p:cNvSpPr/>
-              <p:nvPr/>
-            </p:nvSpPr>
-            <p:spPr>
-              <a:xfrm>
-                <a:off x="16233" y="9769"/>
-                <a:ext cx="737" cy="442"/>
-              </a:xfrm>
-              <a:prstGeom prst="rect">
-                <a:avLst/>
-              </a:prstGeom>
-              <a:solidFill>
-                <a:srgbClr val="8DA0CB"/>
-              </a:solidFill>
-              <a:ln>
-                <a:noFill/>
-              </a:ln>
-            </p:spPr>
-            <p:style>
-              <a:lnRef idx="2">
-                <a:schemeClr val="accent1">
-                  <a:lumMod val="75000"/>
-                </a:schemeClr>
-              </a:lnRef>
-              <a:fillRef idx="1">
-                <a:schemeClr val="accent1"/>
-              </a:fillRef>
-              <a:effectRef idx="0">
-                <a:srgbClr val="FFFFFF"/>
-              </a:effectRef>
-              <a:fontRef idx="minor">
-                <a:schemeClr val="lt1"/>
-              </a:fontRef>
-            </p:style>
-            <p:txBody>
-              <a:bodyPr rtlCol="0" anchor="ctr"/>
-              <a:p>
-                <a:pPr algn="ctr"/>
-                <a:endParaRPr lang="zh-CN" altLang="en-US"/>
-              </a:p>
-            </p:txBody>
-          </p:sp>
-          <p:sp>
-            <p:nvSpPr>
-              <p:cNvPr id="51" name="矩形 50"/>
-              <p:cNvSpPr/>
-              <p:nvPr/>
-            </p:nvSpPr>
-            <p:spPr>
-              <a:xfrm>
-                <a:off x="16233" y="10319"/>
-                <a:ext cx="737" cy="442"/>
-              </a:xfrm>
-              <a:prstGeom prst="rect">
-                <a:avLst/>
-              </a:prstGeom>
-              <a:solidFill>
-                <a:srgbClr val="66C2A5"/>
-              </a:solidFill>
-              <a:ln>
-                <a:noFill/>
-              </a:ln>
-            </p:spPr>
-            <p:style>
-              <a:lnRef idx="2">
-                <a:schemeClr val="accent1">
-                  <a:lumMod val="75000"/>
-                </a:schemeClr>
-              </a:lnRef>
-              <a:fillRef idx="1">
-                <a:schemeClr val="accent1"/>
-              </a:fillRef>
-              <a:effectRef idx="0">
-                <a:srgbClr val="FFFFFF"/>
-              </a:effectRef>
-              <a:fontRef idx="minor">
-                <a:schemeClr val="lt1"/>
-              </a:fontRef>
-            </p:style>
-            <p:txBody>
-              <a:bodyPr rtlCol="0" anchor="ctr"/>
-              <a:p>
-                <a:pPr algn="ctr"/>
-                <a:endParaRPr lang="zh-CN" altLang="en-US"/>
-              </a:p>
-            </p:txBody>
-          </p:sp>
-          <p:sp>
-            <p:nvSpPr>
-              <p:cNvPr id="52" name="文本框 51"/>
-              <p:cNvSpPr txBox="1"/>
-              <p:nvPr/>
-            </p:nvSpPr>
-            <p:spPr>
-              <a:xfrm>
-                <a:off x="17086" y="9747"/>
-                <a:ext cx="4455" cy="507"/>
-              </a:xfrm>
-              <a:prstGeom prst="rect">
-                <a:avLst/>
-              </a:prstGeom>
-              <a:noFill/>
-            </p:spPr>
-            <p:txBody>
-              <a:bodyPr wrap="square" rtlCol="0">
-                <a:spAutoFit/>
-              </a:bodyPr>
-              <a:p>
-                <a:r>
-                  <a:rPr lang="en-US" altLang="zh-CN" sz="1500"/>
-                  <a:t>Small-Core, Sparse-Periphery</a:t>
-                </a:r>
-                <a:endParaRPr lang="en-US" altLang="zh-CN" sz="1500"/>
-              </a:p>
-            </p:txBody>
-          </p:sp>
-          <p:sp>
-            <p:nvSpPr>
-              <p:cNvPr id="53" name="文本框 52"/>
-              <p:cNvSpPr txBox="1"/>
-              <p:nvPr/>
-            </p:nvSpPr>
-            <p:spPr>
-              <a:xfrm>
-                <a:off x="17086" y="10254"/>
-                <a:ext cx="4456" cy="507"/>
-              </a:xfrm>
-              <a:prstGeom prst="rect">
-                <a:avLst/>
-              </a:prstGeom>
-              <a:noFill/>
-            </p:spPr>
-            <p:txBody>
-              <a:bodyPr wrap="square" rtlCol="0">
-                <a:spAutoFit/>
-              </a:bodyPr>
-              <a:p>
-                <a:r>
-                  <a:rPr lang="en-US" altLang="zh-CN" sz="1500"/>
-                  <a:t>Dense-Core, Sparse-Periphery</a:t>
-                </a:r>
-                <a:endParaRPr lang="en-US" altLang="zh-CN" sz="1500"/>
-              </a:p>
-            </p:txBody>
-          </p:sp>
-          <p:sp>
-            <p:nvSpPr>
-              <p:cNvPr id="54" name="文本框 53"/>
-              <p:cNvSpPr txBox="1"/>
-              <p:nvPr/>
-            </p:nvSpPr>
-            <p:spPr>
-              <a:xfrm>
-                <a:off x="14207" y="9154"/>
-                <a:ext cx="5625" cy="507"/>
+                <a:off x="3143" y="2576"/>
+                <a:ext cx="933" cy="437"/>
               </a:xfrm>
               <a:prstGeom prst="rect">
                 <a:avLst/>
@@ -12268,345 +11453,706 @@
               <a:p>
                 <a:pPr algn="ctr"/>
                 <a:r>
-                  <a:rPr lang="en-US" altLang="zh-CN" sz="1500" b="1">
-                    <a:latin typeface="Arial" panose="020B0604020202020204" pitchFamily="34" charset="0"/>
-                    <a:cs typeface="Arial" panose="020B0604020202020204" pitchFamily="34" charset="0"/>
-                  </a:rPr>
-                  <a:t>κ-δ Categories</a:t>
+                  <a:rPr lang="en-US" altLang="zh-CN" sz="1400"/>
+                  <a:t>2016</a:t>
                 </a:r>
-                <a:endParaRPr lang="en-US" altLang="zh-CN" sz="1500" b="1">
-                  <a:latin typeface="Arial" panose="020B0604020202020204" pitchFamily="34" charset="0"/>
-                  <a:cs typeface="Arial" panose="020B0604020202020204" pitchFamily="34" charset="0"/>
-                </a:endParaRPr>
+                <a:endParaRPr lang="en-US" altLang="zh-CN" sz="1400"/>
               </a:p>
             </p:txBody>
           </p:sp>
-          <p:grpSp>
-            <p:nvGrpSpPr>
-              <p:cNvPr id="70" name="组合 69"/>
-              <p:cNvGrpSpPr/>
+          <p:sp>
+            <p:nvSpPr>
+              <p:cNvPr id="59" name="文本框 58"/>
+              <p:cNvSpPr txBox="1"/>
               <p:nvPr/>
-            </p:nvGrpSpPr>
-            <p:grpSpPr>
+            </p:nvSpPr>
+            <p:spPr>
               <a:xfrm>
-                <a:off x="2376" y="1900"/>
-                <a:ext cx="7636" cy="7079"/>
-                <a:chOff x="3143" y="2576"/>
-                <a:chExt cx="6906" cy="6401"/>
+                <a:off x="4118" y="2576"/>
+                <a:ext cx="933" cy="437"/>
               </a:xfrm>
-            </p:grpSpPr>
-            <p:sp>
-              <p:nvSpPr>
-                <p:cNvPr id="10" name="文本框 9"/>
-                <p:cNvSpPr txBox="1"/>
-                <p:nvPr/>
-              </p:nvSpPr>
-              <p:spPr>
-                <a:xfrm>
-                  <a:off x="3279" y="8057"/>
-                  <a:ext cx="1602" cy="524"/>
-                </a:xfrm>
-                <a:prstGeom prst="rect">
-                  <a:avLst/>
-                </a:prstGeom>
-                <a:noFill/>
-              </p:spPr>
-              <p:txBody>
-                <a:bodyPr wrap="square" rtlCol="0">
-                  <a:spAutoFit/>
-                </a:bodyPr>
-                <a:p>
-                  <a:pPr algn="ctr"/>
-                  <a:r>
-                    <a:rPr lang="en-US" altLang="zh-CN"/>
-                    <a:t>Africa</a:t>
-                  </a:r>
-                  <a:endParaRPr lang="en-US" altLang="zh-CN"/>
-                </a:p>
-              </p:txBody>
-            </p:sp>
-            <p:sp>
-              <p:nvSpPr>
-                <p:cNvPr id="11" name="文本框 10"/>
-                <p:cNvSpPr txBox="1"/>
-                <p:nvPr/>
-              </p:nvSpPr>
-              <p:spPr>
-                <a:xfrm>
-                  <a:off x="5397" y="8058"/>
-                  <a:ext cx="2558" cy="919"/>
-                </a:xfrm>
-                <a:prstGeom prst="rect">
-                  <a:avLst/>
-                </a:prstGeom>
-                <a:noFill/>
-              </p:spPr>
-              <p:txBody>
-                <a:bodyPr wrap="square" rtlCol="0">
-                  <a:spAutoFit/>
-                </a:bodyPr>
-                <a:p>
-                  <a:pPr algn="ctr"/>
-                  <a:r>
-                    <a:rPr lang="en-US" altLang="zh-CN"/>
-                    <a:t>South &amp; Southeast Asia</a:t>
-                  </a:r>
-                  <a:endParaRPr lang="en-US" altLang="zh-CN"/>
-                </a:p>
-              </p:txBody>
-            </p:sp>
-            <p:sp>
-              <p:nvSpPr>
-                <p:cNvPr id="12" name="文本框 11"/>
-                <p:cNvSpPr txBox="1"/>
-                <p:nvPr/>
-              </p:nvSpPr>
-              <p:spPr>
-                <a:xfrm>
-                  <a:off x="8099" y="8058"/>
-                  <a:ext cx="1810" cy="919"/>
-                </a:xfrm>
-                <a:prstGeom prst="rect">
-                  <a:avLst/>
-                </a:prstGeom>
-                <a:noFill/>
-              </p:spPr>
-              <p:txBody>
-                <a:bodyPr wrap="square" rtlCol="0">
-                  <a:spAutoFit/>
-                </a:bodyPr>
-                <a:p>
-                  <a:pPr algn="ctr"/>
-                  <a:r>
-                    <a:rPr lang="en-US" altLang="zh-CN">
-                      <a:ea typeface="宋体" panose="02010600030101010101" pitchFamily="2" charset="-122"/>
-                    </a:rPr>
-                    <a:t>Latin</a:t>
-                  </a:r>
-                  <a:endParaRPr lang="en-US" altLang="zh-CN">
-                    <a:ea typeface="宋体" panose="02010600030101010101" pitchFamily="2" charset="-122"/>
-                  </a:endParaRPr>
-                </a:p>
-                <a:p>
-                  <a:pPr algn="ctr"/>
-                  <a:r>
-                    <a:rPr lang="en-US" altLang="zh-CN">
-                      <a:ea typeface="宋体" panose="02010600030101010101" pitchFamily="2" charset="-122"/>
-                    </a:rPr>
-                    <a:t>America</a:t>
-                  </a:r>
-                  <a:endParaRPr lang="en-US" altLang="zh-CN">
-                    <a:ea typeface="宋体" panose="02010600030101010101" pitchFamily="2" charset="-122"/>
-                  </a:endParaRPr>
-                </a:p>
-              </p:txBody>
-            </p:sp>
-            <p:sp>
-              <p:nvSpPr>
-                <p:cNvPr id="58" name="文本框 57"/>
-                <p:cNvSpPr txBox="1"/>
-                <p:nvPr/>
-              </p:nvSpPr>
-              <p:spPr>
-                <a:xfrm>
-                  <a:off x="3143" y="2576"/>
-                  <a:ext cx="933" cy="437"/>
-                </a:xfrm>
-                <a:prstGeom prst="rect">
-                  <a:avLst/>
-                </a:prstGeom>
-                <a:noFill/>
-              </p:spPr>
-              <p:txBody>
-                <a:bodyPr wrap="square" rtlCol="0">
-                  <a:spAutoFit/>
-                </a:bodyPr>
-                <a:p>
-                  <a:pPr algn="ctr"/>
-                  <a:r>
-                    <a:rPr lang="en-US" altLang="zh-CN" sz="1400"/>
-                    <a:t>2016</a:t>
-                  </a:r>
-                  <a:endParaRPr lang="en-US" altLang="zh-CN" sz="1400"/>
-                </a:p>
-              </p:txBody>
-            </p:sp>
-            <p:sp>
-              <p:nvSpPr>
-                <p:cNvPr id="59" name="文本框 58"/>
-                <p:cNvSpPr txBox="1"/>
-                <p:nvPr/>
-              </p:nvSpPr>
-              <p:spPr>
-                <a:xfrm>
-                  <a:off x="4118" y="2576"/>
-                  <a:ext cx="933" cy="437"/>
-                </a:xfrm>
-                <a:prstGeom prst="rect">
-                  <a:avLst/>
-                </a:prstGeom>
-                <a:noFill/>
-              </p:spPr>
-              <p:txBody>
-                <a:bodyPr wrap="square" rtlCol="0">
-                  <a:spAutoFit/>
-                </a:bodyPr>
-                <a:p>
-                  <a:pPr algn="ctr"/>
-                  <a:r>
-                    <a:rPr lang="en-US" altLang="zh-CN" sz="1400"/>
-                    <a:t>2023</a:t>
-                  </a:r>
-                  <a:endParaRPr lang="en-US" altLang="zh-CN" sz="1400"/>
-                </a:p>
-              </p:txBody>
-            </p:sp>
-            <p:sp>
-              <p:nvSpPr>
-                <p:cNvPr id="60" name="文本框 59"/>
-                <p:cNvSpPr txBox="1"/>
-                <p:nvPr/>
-              </p:nvSpPr>
-              <p:spPr>
-                <a:xfrm>
-                  <a:off x="5642" y="2576"/>
-                  <a:ext cx="933" cy="437"/>
-                </a:xfrm>
-                <a:prstGeom prst="rect">
-                  <a:avLst/>
-                </a:prstGeom>
-                <a:noFill/>
-              </p:spPr>
-              <p:txBody>
-                <a:bodyPr wrap="square" rtlCol="0">
-                  <a:spAutoFit/>
-                </a:bodyPr>
-                <a:p>
-                  <a:pPr algn="ctr"/>
-                  <a:r>
-                    <a:rPr lang="en-US" altLang="zh-CN" sz="1400"/>
-                    <a:t>2016</a:t>
-                  </a:r>
-                  <a:endParaRPr lang="en-US" altLang="zh-CN" sz="1400"/>
-                </a:p>
-              </p:txBody>
-            </p:sp>
-            <p:sp>
-              <p:nvSpPr>
-                <p:cNvPr id="61" name="文本框 60"/>
-                <p:cNvSpPr txBox="1"/>
-                <p:nvPr/>
-              </p:nvSpPr>
-              <p:spPr>
-                <a:xfrm>
-                  <a:off x="6617" y="2576"/>
-                  <a:ext cx="933" cy="437"/>
-                </a:xfrm>
-                <a:prstGeom prst="rect">
-                  <a:avLst/>
-                </a:prstGeom>
-                <a:noFill/>
-              </p:spPr>
-              <p:txBody>
-                <a:bodyPr wrap="square" rtlCol="0">
-                  <a:spAutoFit/>
-                </a:bodyPr>
-                <a:p>
-                  <a:pPr algn="ctr"/>
-                  <a:r>
-                    <a:rPr lang="en-US" altLang="zh-CN" sz="1400"/>
-                    <a:t>2023</a:t>
-                  </a:r>
-                  <a:endParaRPr lang="en-US" altLang="zh-CN" sz="1400"/>
-                </a:p>
-              </p:txBody>
-            </p:sp>
-            <p:sp>
-              <p:nvSpPr>
-                <p:cNvPr id="62" name="文本框 61"/>
-                <p:cNvSpPr txBox="1"/>
-                <p:nvPr/>
-              </p:nvSpPr>
-              <p:spPr>
-                <a:xfrm>
-                  <a:off x="8141" y="2576"/>
-                  <a:ext cx="933" cy="437"/>
-                </a:xfrm>
-                <a:prstGeom prst="rect">
-                  <a:avLst/>
-                </a:prstGeom>
-                <a:noFill/>
-              </p:spPr>
-              <p:txBody>
-                <a:bodyPr wrap="square" rtlCol="0">
-                  <a:spAutoFit/>
-                </a:bodyPr>
-                <a:p>
-                  <a:pPr algn="ctr"/>
-                  <a:r>
-                    <a:rPr lang="en-US" altLang="zh-CN" sz="1400"/>
-                    <a:t>2016</a:t>
-                  </a:r>
-                  <a:endParaRPr lang="en-US" altLang="zh-CN" sz="1400"/>
-                </a:p>
-              </p:txBody>
-            </p:sp>
-            <p:sp>
-              <p:nvSpPr>
-                <p:cNvPr id="63" name="文本框 62"/>
-                <p:cNvSpPr txBox="1"/>
-                <p:nvPr/>
-              </p:nvSpPr>
-              <p:spPr>
-                <a:xfrm>
-                  <a:off x="9116" y="2576"/>
-                  <a:ext cx="933" cy="437"/>
-                </a:xfrm>
-                <a:prstGeom prst="rect">
-                  <a:avLst/>
-                </a:prstGeom>
-                <a:noFill/>
-              </p:spPr>
-              <p:txBody>
-                <a:bodyPr wrap="square" rtlCol="0">
-                  <a:spAutoFit/>
-                </a:bodyPr>
-                <a:p>
-                  <a:pPr algn="ctr"/>
-                  <a:r>
-                    <a:rPr lang="en-US" altLang="zh-CN" sz="1400"/>
-                    <a:t>2023</a:t>
-                  </a:r>
-                  <a:endParaRPr lang="en-US" altLang="zh-CN" sz="1400"/>
-                </a:p>
-              </p:txBody>
-            </p:sp>
-          </p:grpSp>
+              <a:prstGeom prst="rect">
+                <a:avLst/>
+              </a:prstGeom>
+              <a:noFill/>
+            </p:spPr>
+            <p:txBody>
+              <a:bodyPr wrap="square" rtlCol="0">
+                <a:spAutoFit/>
+              </a:bodyPr>
+              <a:p>
+                <a:pPr algn="ctr"/>
+                <a:r>
+                  <a:rPr lang="en-US" altLang="zh-CN" sz="1400"/>
+                  <a:t>2023</a:t>
+                </a:r>
+                <a:endParaRPr lang="en-US" altLang="zh-CN" sz="1400"/>
+              </a:p>
+            </p:txBody>
+          </p:sp>
+          <p:sp>
+            <p:nvSpPr>
+              <p:cNvPr id="60" name="文本框 59"/>
+              <p:cNvSpPr txBox="1"/>
+              <p:nvPr/>
+            </p:nvSpPr>
+            <p:spPr>
+              <a:xfrm>
+                <a:off x="5642" y="2576"/>
+                <a:ext cx="933" cy="437"/>
+              </a:xfrm>
+              <a:prstGeom prst="rect">
+                <a:avLst/>
+              </a:prstGeom>
+              <a:noFill/>
+            </p:spPr>
+            <p:txBody>
+              <a:bodyPr wrap="square" rtlCol="0">
+                <a:spAutoFit/>
+              </a:bodyPr>
+              <a:p>
+                <a:pPr algn="ctr"/>
+                <a:r>
+                  <a:rPr lang="en-US" altLang="zh-CN" sz="1400"/>
+                  <a:t>2016</a:t>
+                </a:r>
+                <a:endParaRPr lang="en-US" altLang="zh-CN" sz="1400"/>
+              </a:p>
+            </p:txBody>
+          </p:sp>
+          <p:sp>
+            <p:nvSpPr>
+              <p:cNvPr id="61" name="文本框 60"/>
+              <p:cNvSpPr txBox="1"/>
+              <p:nvPr/>
+            </p:nvSpPr>
+            <p:spPr>
+              <a:xfrm>
+                <a:off x="6617" y="2576"/>
+                <a:ext cx="933" cy="437"/>
+              </a:xfrm>
+              <a:prstGeom prst="rect">
+                <a:avLst/>
+              </a:prstGeom>
+              <a:noFill/>
+            </p:spPr>
+            <p:txBody>
+              <a:bodyPr wrap="square" rtlCol="0">
+                <a:spAutoFit/>
+              </a:bodyPr>
+              <a:p>
+                <a:pPr algn="ctr"/>
+                <a:r>
+                  <a:rPr lang="en-US" altLang="zh-CN" sz="1400"/>
+                  <a:t>2023</a:t>
+                </a:r>
+                <a:endParaRPr lang="en-US" altLang="zh-CN" sz="1400"/>
+              </a:p>
+            </p:txBody>
+          </p:sp>
+          <p:sp>
+            <p:nvSpPr>
+              <p:cNvPr id="62" name="文本框 61"/>
+              <p:cNvSpPr txBox="1"/>
+              <p:nvPr/>
+            </p:nvSpPr>
+            <p:spPr>
+              <a:xfrm>
+                <a:off x="8141" y="2576"/>
+                <a:ext cx="933" cy="437"/>
+              </a:xfrm>
+              <a:prstGeom prst="rect">
+                <a:avLst/>
+              </a:prstGeom>
+              <a:noFill/>
+            </p:spPr>
+            <p:txBody>
+              <a:bodyPr wrap="square" rtlCol="0">
+                <a:spAutoFit/>
+              </a:bodyPr>
+              <a:p>
+                <a:pPr algn="ctr"/>
+                <a:r>
+                  <a:rPr lang="en-US" altLang="zh-CN" sz="1400"/>
+                  <a:t>2016</a:t>
+                </a:r>
+                <a:endParaRPr lang="en-US" altLang="zh-CN" sz="1400"/>
+              </a:p>
+            </p:txBody>
+          </p:sp>
+          <p:sp>
+            <p:nvSpPr>
+              <p:cNvPr id="63" name="文本框 62"/>
+              <p:cNvSpPr txBox="1"/>
+              <p:nvPr/>
+            </p:nvSpPr>
+            <p:spPr>
+              <a:xfrm>
+                <a:off x="9116" y="2576"/>
+                <a:ext cx="933" cy="437"/>
+              </a:xfrm>
+              <a:prstGeom prst="rect">
+                <a:avLst/>
+              </a:prstGeom>
+              <a:noFill/>
+            </p:spPr>
+            <p:txBody>
+              <a:bodyPr wrap="square" rtlCol="0">
+                <a:spAutoFit/>
+              </a:bodyPr>
+              <a:p>
+                <a:pPr algn="ctr"/>
+                <a:r>
+                  <a:rPr lang="en-US" altLang="zh-CN" sz="1400"/>
+                  <a:t>2023</a:t>
+                </a:r>
+                <a:endParaRPr lang="en-US" altLang="zh-CN" sz="1400"/>
+              </a:p>
+            </p:txBody>
+          </p:sp>
         </p:grpSp>
+        <p:pic>
+          <p:nvPicPr>
+            <p:cNvPr id="2" name="图片 1"/>
+            <p:cNvPicPr/>
+            <p:nvPr/>
+          </p:nvPicPr>
+          <p:blipFill>
+            <a:blip r:embed="rId1"/>
+            <a:srcRect t="5669" r="23033" b="4989"/>
+            <a:stretch>
+              <a:fillRect/>
+            </a:stretch>
+          </p:blipFill>
+          <p:spPr>
+            <a:xfrm>
+              <a:off x="5684" y="2374"/>
+              <a:ext cx="9705" cy="5604"/>
+            </a:xfrm>
+            <a:prstGeom prst="rect">
+              <a:avLst/>
+            </a:prstGeom>
+          </p:spPr>
+        </p:pic>
+        <p:sp>
+          <p:nvSpPr>
+            <p:cNvPr id="18" name="矩形 17"/>
+            <p:cNvSpPr/>
+            <p:nvPr/>
+          </p:nvSpPr>
+          <p:spPr>
+            <a:xfrm>
+              <a:off x="7006" y="9636"/>
+              <a:ext cx="619" cy="442"/>
+            </a:xfrm>
+            <a:prstGeom prst="rect">
+              <a:avLst/>
+            </a:prstGeom>
+            <a:solidFill>
+              <a:srgbClr val="66C2A5"/>
+            </a:solidFill>
+            <a:ln>
+              <a:noFill/>
+            </a:ln>
+          </p:spPr>
+          <p:style>
+            <a:lnRef idx="2">
+              <a:schemeClr val="accent1">
+                <a:lumMod val="75000"/>
+              </a:schemeClr>
+            </a:lnRef>
+            <a:fillRef idx="1">
+              <a:schemeClr val="accent1"/>
+            </a:fillRef>
+            <a:effectRef idx="0">
+              <a:srgbClr val="FFFFFF"/>
+            </a:effectRef>
+            <a:fontRef idx="minor">
+              <a:schemeClr val="lt1"/>
+            </a:fontRef>
+          </p:style>
+          <p:txBody>
+            <a:bodyPr rtlCol="0" anchor="ctr"/>
+            <a:p>
+              <a:pPr algn="ctr"/>
+              <a:endParaRPr lang="zh-CN" altLang="en-US"/>
+            </a:p>
+          </p:txBody>
+        </p:sp>
+        <p:sp>
+          <p:nvSpPr>
+            <p:cNvPr id="19" name="矩形 18"/>
+            <p:cNvSpPr/>
+            <p:nvPr/>
+          </p:nvSpPr>
+          <p:spPr>
+            <a:xfrm>
+              <a:off x="7006" y="10214"/>
+              <a:ext cx="619" cy="442"/>
+            </a:xfrm>
+            <a:prstGeom prst="rect">
+              <a:avLst/>
+            </a:prstGeom>
+            <a:solidFill>
+              <a:srgbClr val="FC8D62"/>
+            </a:solidFill>
+            <a:ln>
+              <a:noFill/>
+            </a:ln>
+          </p:spPr>
+          <p:style>
+            <a:lnRef idx="2">
+              <a:schemeClr val="accent1">
+                <a:lumMod val="75000"/>
+              </a:schemeClr>
+            </a:lnRef>
+            <a:fillRef idx="1">
+              <a:schemeClr val="accent1"/>
+            </a:fillRef>
+            <a:effectRef idx="0">
+              <a:srgbClr val="FFFFFF"/>
+            </a:effectRef>
+            <a:fontRef idx="minor">
+              <a:schemeClr val="lt1"/>
+            </a:fontRef>
+          </p:style>
+          <p:txBody>
+            <a:bodyPr rtlCol="0" anchor="ctr"/>
+            <a:p>
+              <a:pPr algn="ctr"/>
+              <a:endParaRPr lang="zh-CN" altLang="en-US"/>
+            </a:p>
+          </p:txBody>
+        </p:sp>
+        <p:sp>
+          <p:nvSpPr>
+            <p:cNvPr id="20" name="文本框 19"/>
+            <p:cNvSpPr txBox="1"/>
+            <p:nvPr/>
+          </p:nvSpPr>
+          <p:spPr>
+            <a:xfrm>
+              <a:off x="7741" y="9636"/>
+              <a:ext cx="3393" cy="507"/>
+            </a:xfrm>
+            <a:prstGeom prst="rect">
+              <a:avLst/>
+            </a:prstGeom>
+            <a:noFill/>
+          </p:spPr>
+          <p:txBody>
+            <a:bodyPr wrap="square" rtlCol="0">
+              <a:spAutoFit/>
+            </a:bodyPr>
+            <a:p>
+              <a:r>
+                <a:rPr lang="en-US" altLang="zh-CN" sz="1500"/>
+                <a:t>High-scale, Crown</a:t>
+              </a:r>
+              <a:endParaRPr lang="en-US" altLang="zh-CN" sz="1500"/>
+            </a:p>
+          </p:txBody>
+        </p:sp>
+        <p:sp>
+          <p:nvSpPr>
+            <p:cNvPr id="21" name="文本框 20"/>
+            <p:cNvSpPr txBox="1"/>
+            <p:nvPr/>
+          </p:nvSpPr>
+          <p:spPr>
+            <a:xfrm>
+              <a:off x="7741" y="10182"/>
+              <a:ext cx="3393" cy="507"/>
+            </a:xfrm>
+            <a:prstGeom prst="rect">
+              <a:avLst/>
+            </a:prstGeom>
+            <a:noFill/>
+          </p:spPr>
+          <p:txBody>
+            <a:bodyPr wrap="square" rtlCol="0">
+              <a:spAutoFit/>
+            </a:bodyPr>
+            <a:p>
+              <a:r>
+                <a:rPr lang="en-US" altLang="zh-CN" sz="1500"/>
+                <a:t>High-scale, Pyramid</a:t>
+              </a:r>
+              <a:endParaRPr lang="en-US" altLang="zh-CN" sz="1500"/>
+            </a:p>
+          </p:txBody>
+        </p:sp>
+        <p:sp>
+          <p:nvSpPr>
+            <p:cNvPr id="46" name="矩形 45"/>
+            <p:cNvSpPr/>
+            <p:nvPr/>
+          </p:nvSpPr>
+          <p:spPr>
+            <a:xfrm>
+              <a:off x="7006" y="10792"/>
+              <a:ext cx="619" cy="442"/>
+            </a:xfrm>
+            <a:prstGeom prst="rect">
+              <a:avLst/>
+            </a:prstGeom>
+            <a:solidFill>
+              <a:srgbClr val="8DA0CB"/>
+            </a:solidFill>
+            <a:ln>
+              <a:noFill/>
+            </a:ln>
+          </p:spPr>
+          <p:style>
+            <a:lnRef idx="2">
+              <a:schemeClr val="accent1">
+                <a:lumMod val="75000"/>
+              </a:schemeClr>
+            </a:lnRef>
+            <a:fillRef idx="1">
+              <a:schemeClr val="accent1"/>
+            </a:fillRef>
+            <a:effectRef idx="0">
+              <a:srgbClr val="FFFFFF"/>
+            </a:effectRef>
+            <a:fontRef idx="minor">
+              <a:schemeClr val="lt1"/>
+            </a:fontRef>
+          </p:style>
+          <p:txBody>
+            <a:bodyPr rtlCol="0" anchor="ctr"/>
+            <a:p>
+              <a:pPr algn="ctr"/>
+              <a:endParaRPr lang="zh-CN" altLang="en-US"/>
+            </a:p>
+          </p:txBody>
+        </p:sp>
+        <p:sp>
+          <p:nvSpPr>
+            <p:cNvPr id="5" name="文本框 4"/>
+            <p:cNvSpPr txBox="1"/>
+            <p:nvPr/>
+          </p:nvSpPr>
+          <p:spPr>
+            <a:xfrm>
+              <a:off x="7741" y="10728"/>
+              <a:ext cx="3393" cy="507"/>
+            </a:xfrm>
+            <a:prstGeom prst="rect">
+              <a:avLst/>
+            </a:prstGeom>
+            <a:noFill/>
+          </p:spPr>
+          <p:txBody>
+            <a:bodyPr wrap="square" rtlCol="0">
+              <a:spAutoFit/>
+            </a:bodyPr>
+            <a:p>
+              <a:r>
+                <a:rPr lang="en-US" altLang="zh-CN" sz="1500"/>
+                <a:t>High-scale, Volcanic</a:t>
+              </a:r>
+              <a:endParaRPr lang="en-US" altLang="zh-CN" sz="1500"/>
+            </a:p>
+          </p:txBody>
+        </p:sp>
+        <p:sp>
+          <p:nvSpPr>
+            <p:cNvPr id="48" name="矩形 47"/>
+            <p:cNvSpPr/>
+            <p:nvPr/>
+          </p:nvSpPr>
+          <p:spPr>
+            <a:xfrm>
+              <a:off x="11400" y="10812"/>
+              <a:ext cx="653" cy="442"/>
+            </a:xfrm>
+            <a:prstGeom prst="rect">
+              <a:avLst/>
+            </a:prstGeom>
+            <a:solidFill>
+              <a:srgbClr val="E5C494"/>
+            </a:solidFill>
+            <a:ln>
+              <a:noFill/>
+            </a:ln>
+          </p:spPr>
+          <p:style>
+            <a:lnRef idx="2">
+              <a:schemeClr val="accent1">
+                <a:lumMod val="75000"/>
+              </a:schemeClr>
+            </a:lnRef>
+            <a:fillRef idx="1">
+              <a:schemeClr val="accent1"/>
+            </a:fillRef>
+            <a:effectRef idx="0">
+              <a:srgbClr val="FFFFFF"/>
+            </a:effectRef>
+            <a:fontRef idx="minor">
+              <a:schemeClr val="lt1"/>
+            </a:fontRef>
+          </p:style>
+          <p:txBody>
+            <a:bodyPr rtlCol="0" anchor="ctr"/>
+            <a:p>
+              <a:pPr algn="ctr"/>
+              <a:endParaRPr lang="zh-CN" altLang="en-US"/>
+            </a:p>
+          </p:txBody>
+        </p:sp>
+        <p:sp>
+          <p:nvSpPr>
+            <p:cNvPr id="49" name="文本框 48"/>
+            <p:cNvSpPr txBox="1"/>
+            <p:nvPr/>
+          </p:nvSpPr>
+          <p:spPr>
+            <a:xfrm>
+              <a:off x="12164" y="10784"/>
+              <a:ext cx="3225" cy="507"/>
+            </a:xfrm>
+            <a:prstGeom prst="rect">
+              <a:avLst/>
+            </a:prstGeom>
+            <a:noFill/>
+          </p:spPr>
+          <p:txBody>
+            <a:bodyPr wrap="square" rtlCol="0">
+              <a:spAutoFit/>
+            </a:bodyPr>
+            <a:p>
+              <a:r>
+                <a:rPr lang="en-US" altLang="zh-CN" sz="1500"/>
+                <a:t>Low-scale, Pyramid</a:t>
+              </a:r>
+              <a:endParaRPr lang="en-US" altLang="zh-CN" sz="1500"/>
+            </a:p>
+          </p:txBody>
+        </p:sp>
+        <p:sp>
+          <p:nvSpPr>
+            <p:cNvPr id="50" name="矩形 49"/>
+            <p:cNvSpPr/>
+            <p:nvPr/>
+          </p:nvSpPr>
+          <p:spPr>
+            <a:xfrm>
+              <a:off x="11400" y="9636"/>
+              <a:ext cx="653" cy="442"/>
+            </a:xfrm>
+            <a:prstGeom prst="rect">
+              <a:avLst/>
+            </a:prstGeom>
+            <a:solidFill>
+              <a:srgbClr val="A6D854"/>
+            </a:solidFill>
+            <a:ln>
+              <a:noFill/>
+            </a:ln>
+          </p:spPr>
+          <p:style>
+            <a:lnRef idx="2">
+              <a:schemeClr val="accent1">
+                <a:lumMod val="75000"/>
+              </a:schemeClr>
+            </a:lnRef>
+            <a:fillRef idx="1">
+              <a:schemeClr val="accent1"/>
+            </a:fillRef>
+            <a:effectRef idx="0">
+              <a:srgbClr val="FFFFFF"/>
+            </a:effectRef>
+            <a:fontRef idx="minor">
+              <a:schemeClr val="lt1"/>
+            </a:fontRef>
+          </p:style>
+          <p:txBody>
+            <a:bodyPr rtlCol="0" anchor="ctr"/>
+            <a:p>
+              <a:pPr algn="ctr"/>
+              <a:endParaRPr lang="zh-CN" altLang="en-US"/>
+            </a:p>
+          </p:txBody>
+        </p:sp>
+        <p:sp>
+          <p:nvSpPr>
+            <p:cNvPr id="51" name="矩形 50"/>
+            <p:cNvSpPr/>
+            <p:nvPr/>
+          </p:nvSpPr>
+          <p:spPr>
+            <a:xfrm>
+              <a:off x="11400" y="10242"/>
+              <a:ext cx="653" cy="442"/>
+            </a:xfrm>
+            <a:prstGeom prst="rect">
+              <a:avLst/>
+            </a:prstGeom>
+            <a:solidFill>
+              <a:srgbClr val="FFD92F"/>
+            </a:solidFill>
+            <a:ln>
+              <a:noFill/>
+            </a:ln>
+          </p:spPr>
+          <p:style>
+            <a:lnRef idx="2">
+              <a:schemeClr val="accent1">
+                <a:lumMod val="75000"/>
+              </a:schemeClr>
+            </a:lnRef>
+            <a:fillRef idx="1">
+              <a:schemeClr val="accent1"/>
+            </a:fillRef>
+            <a:effectRef idx="0">
+              <a:srgbClr val="FFFFFF"/>
+            </a:effectRef>
+            <a:fontRef idx="minor">
+              <a:schemeClr val="lt1"/>
+            </a:fontRef>
+          </p:style>
+          <p:txBody>
+            <a:bodyPr rtlCol="0" anchor="ctr"/>
+            <a:p>
+              <a:pPr algn="ctr"/>
+              <a:endParaRPr lang="zh-CN" altLang="en-US"/>
+            </a:p>
+          </p:txBody>
+        </p:sp>
+        <p:sp>
+          <p:nvSpPr>
+            <p:cNvPr id="52" name="文本框 51"/>
+            <p:cNvSpPr txBox="1"/>
+            <p:nvPr/>
+          </p:nvSpPr>
+          <p:spPr>
+            <a:xfrm>
+              <a:off x="12164" y="9636"/>
+              <a:ext cx="3224" cy="507"/>
+            </a:xfrm>
+            <a:prstGeom prst="rect">
+              <a:avLst/>
+            </a:prstGeom>
+            <a:noFill/>
+          </p:spPr>
+          <p:txBody>
+            <a:bodyPr wrap="square" rtlCol="0">
+              <a:spAutoFit/>
+            </a:bodyPr>
+            <a:p>
+              <a:r>
+                <a:rPr lang="en-US" altLang="zh-CN" sz="1500"/>
+                <a:t>Low-scale, Bowl</a:t>
+              </a:r>
+              <a:endParaRPr lang="en-US" altLang="zh-CN" sz="1500"/>
+            </a:p>
+          </p:txBody>
+        </p:sp>
+        <p:sp>
+          <p:nvSpPr>
+            <p:cNvPr id="53" name="文本框 52"/>
+            <p:cNvSpPr txBox="1"/>
+            <p:nvPr/>
+          </p:nvSpPr>
+          <p:spPr>
+            <a:xfrm>
+              <a:off x="12164" y="10210"/>
+              <a:ext cx="3224" cy="507"/>
+            </a:xfrm>
+            <a:prstGeom prst="rect">
+              <a:avLst/>
+            </a:prstGeom>
+            <a:noFill/>
+          </p:spPr>
+          <p:txBody>
+            <a:bodyPr wrap="square" rtlCol="0">
+              <a:spAutoFit/>
+            </a:bodyPr>
+            <a:p>
+              <a:r>
+                <a:rPr lang="en-US" altLang="zh-CN" sz="1500"/>
+                <a:t>Low-scale, Crown</a:t>
+              </a:r>
+              <a:endParaRPr lang="en-US" altLang="zh-CN" sz="1500"/>
+            </a:p>
+          </p:txBody>
+        </p:sp>
+        <p:sp>
+          <p:nvSpPr>
+            <p:cNvPr id="6" name="矩形 5"/>
+            <p:cNvSpPr/>
+            <p:nvPr/>
+          </p:nvSpPr>
+          <p:spPr>
+            <a:xfrm>
+              <a:off x="11400" y="11403"/>
+              <a:ext cx="653" cy="442"/>
+            </a:xfrm>
+            <a:prstGeom prst="rect">
+              <a:avLst/>
+            </a:prstGeom>
+            <a:solidFill>
+              <a:srgbClr val="B3B3B3"/>
+            </a:solidFill>
+            <a:ln>
+              <a:noFill/>
+            </a:ln>
+          </p:spPr>
+          <p:style>
+            <a:lnRef idx="2">
+              <a:schemeClr val="accent1">
+                <a:lumMod val="75000"/>
+              </a:schemeClr>
+            </a:lnRef>
+            <a:fillRef idx="1">
+              <a:schemeClr val="accent1"/>
+            </a:fillRef>
+            <a:effectRef idx="0">
+              <a:srgbClr val="FFFFFF"/>
+            </a:effectRef>
+            <a:fontRef idx="minor">
+              <a:schemeClr val="lt1"/>
+            </a:fontRef>
+          </p:style>
+          <p:txBody>
+            <a:bodyPr rtlCol="0" anchor="ctr"/>
+            <a:p>
+              <a:pPr algn="ctr"/>
+              <a:endParaRPr lang="zh-CN" altLang="en-US"/>
+            </a:p>
+          </p:txBody>
+        </p:sp>
+        <p:sp>
+          <p:nvSpPr>
+            <p:cNvPr id="7" name="文本框 6"/>
+            <p:cNvSpPr txBox="1"/>
+            <p:nvPr/>
+          </p:nvSpPr>
+          <p:spPr>
+            <a:xfrm>
+              <a:off x="12164" y="11358"/>
+              <a:ext cx="3225" cy="507"/>
+            </a:xfrm>
+            <a:prstGeom prst="rect">
+              <a:avLst/>
+            </a:prstGeom>
+            <a:noFill/>
+          </p:spPr>
+          <p:txBody>
+            <a:bodyPr wrap="square" rtlCol="0">
+              <a:spAutoFit/>
+            </a:bodyPr>
+            <a:p>
+              <a:r>
+                <a:rPr lang="en-US" altLang="zh-CN" sz="1500"/>
+                <a:t>Low-scale, Volcanic</a:t>
+              </a:r>
+              <a:endParaRPr lang="en-US" altLang="zh-CN" sz="1500"/>
+            </a:p>
+          </p:txBody>
+        </p:sp>
       </p:grpSp>
-      <p:pic>
-        <p:nvPicPr>
-          <p:cNvPr id="2" name="图片 1"/>
-          <p:cNvPicPr/>
-          <p:nvPr/>
-        </p:nvPicPr>
-        <p:blipFill>
-          <a:blip r:embed="rId1"/>
-          <a:srcRect t="5669" r="23033" b="4989"/>
-          <a:stretch>
-            <a:fillRect/>
-          </a:stretch>
-        </p:blipFill>
-        <p:spPr>
-          <a:xfrm>
-            <a:off x="3609340" y="1507490"/>
-            <a:ext cx="6162675" cy="3558540"/>
-          </a:xfrm>
-          <a:prstGeom prst="rect">
-            <a:avLst/>
-          </a:prstGeom>
-        </p:spPr>
-      </p:pic>
     </p:spTree>
   </p:cSld>
   <p:clrMapOvr>
@@ -18748,6 +18294,31 @@
         <p:nvPr/>
       </p:nvGrpSpPr>
       <p:grpSpPr/>
+      <p:pic>
+        <p:nvPicPr>
+          <p:cNvPr id="42" name="图片 41"/>
+          <p:cNvPicPr>
+            <a:picLocks noChangeAspect="1"/>
+          </p:cNvPicPr>
+          <p:nvPr/>
+        </p:nvPicPr>
+        <p:blipFill>
+          <a:blip r:embed="rId1"/>
+          <a:srcRect l="8417" b="7890"/>
+          <a:stretch>
+            <a:fillRect/>
+          </a:stretch>
+        </p:blipFill>
+        <p:spPr>
+          <a:xfrm>
+            <a:off x="10466705" y="343535"/>
+            <a:ext cx="3247390" cy="3321050"/>
+          </a:xfrm>
+          <a:prstGeom prst="rect">
+            <a:avLst/>
+          </a:prstGeom>
+        </p:spPr>
+      </p:pic>
       <mc:AlternateContent xmlns:mc="http://schemas.openxmlformats.org/markup-compatibility/2006" xmlns:a14="http://schemas.microsoft.com/office/drawing/2010/main">
         <mc:Choice Requires="a14">
           <p:graphicFrame>
@@ -18756,7 +18327,7 @@
               <p:cNvGraphicFramePr/>
               <p:nvPr>
                 <p:custDataLst>
-                  <p:tags r:id="rId1"/>
+                  <p:tags r:id="rId2"/>
                 </p:custDataLst>
               </p:nvPr>
             </p:nvGraphicFramePr>
@@ -19360,7 +18931,7 @@
               <p:cNvGraphicFramePr/>
               <p:nvPr>
                 <p:custDataLst>
-                  <p:tags r:id="rId2"/>
+                  <p:tags r:id="rId3"/>
                 </p:custDataLst>
               </p:nvPr>
             </p:nvGraphicFramePr>
@@ -19440,7 +19011,7 @@
                       </a:txBody>
                       <a:tcPr marL="0" marR="0" marT="0" marB="0">
                         <a:blipFill>
-                          <a:blip r:embed="rId3"/>
+                          <a:blip r:embed="rId4"/>
                         </a:blipFill>
                       </a:tcPr>
                     </a:tc>
@@ -19488,7 +19059,7 @@
                       </a:txBody>
                       <a:tcPr marL="0" marR="0" marT="0" marB="0">
                         <a:blipFill>
-                          <a:blip r:embed="rId3"/>
+                          <a:blip r:embed="rId4"/>
                         </a:blipFill>
                       </a:tcPr>
                     </a:tc>
@@ -19536,7 +19107,7 @@
                       </a:txBody>
                       <a:tcPr marL="0" marR="0" marT="0" marB="0">
                         <a:blipFill>
-                          <a:blip r:embed="rId3"/>
+                          <a:blip r:embed="rId4"/>
                         </a:blipFill>
                       </a:tcPr>
                     </a:tc>
@@ -19584,7 +19155,7 @@
                       </a:txBody>
                       <a:tcPr marL="0" marR="0" marT="0" marB="0">
                         <a:blipFill>
-                          <a:blip r:embed="rId3"/>
+                          <a:blip r:embed="rId4"/>
                         </a:blipFill>
                       </a:tcPr>
                     </a:tc>
@@ -19632,7 +19203,7 @@
                       </a:txBody>
                       <a:tcPr marL="0" marR="0" marT="0" marB="0">
                         <a:blipFill>
-                          <a:blip r:embed="rId3"/>
+                          <a:blip r:embed="rId4"/>
                         </a:blipFill>
                       </a:tcPr>
                     </a:tc>
@@ -19684,7 +19255,7 @@
                       </a:txBody>
                       <a:tcPr marL="0" marR="0" marT="0" marB="0">
                         <a:blipFill>
-                          <a:blip r:embed="rId3"/>
+                          <a:blip r:embed="rId4"/>
                         </a:blipFill>
                       </a:tcPr>
                     </a:tc>
@@ -19732,7 +19303,7 @@
                       </a:txBody>
                       <a:tcPr marL="0" marR="0" marT="0" marB="0">
                         <a:blipFill>
-                          <a:blip r:embed="rId3"/>
+                          <a:blip r:embed="rId4"/>
                         </a:blipFill>
                       </a:tcPr>
                     </a:tc>
@@ -20129,9 +19700,9 @@
         <p:grpSpPr>
           <a:xfrm>
             <a:off x="109855" y="381635"/>
-            <a:ext cx="13811250" cy="7388860"/>
+            <a:ext cx="13811885" cy="7388860"/>
             <a:chOff x="173" y="601"/>
-            <a:chExt cx="21750" cy="11636"/>
+            <a:chExt cx="21751" cy="11636"/>
           </a:xfrm>
         </p:grpSpPr>
         <p:pic>
@@ -20141,7 +19712,7 @@
             <p:nvPr/>
           </p:nvPicPr>
           <p:blipFill>
-            <a:blip r:embed="rId4"/>
+            <a:blip r:embed="rId5"/>
             <a:srcRect l="1918" t="1292" r="75749" b="52389"/>
             <a:stretch>
               <a:fillRect/>
@@ -20232,7 +19803,7 @@
                   <a:avLst/>
                 </a:prstGeom>
                 <a:blipFill rotWithShape="1">
-                  <a:blip r:embed="rId5"/>
+                  <a:blip r:embed="rId6"/>
                 </a:blipFill>
               </p:spPr>
               <p:txBody>
@@ -20257,7 +19828,7 @@
             <p:nvPr/>
           </p:nvPicPr>
           <p:blipFill>
-            <a:blip r:embed="rId4"/>
+            <a:blip r:embed="rId5"/>
             <a:srcRect l="27028" t="1292" r="50577" b="52389"/>
             <a:stretch>
               <a:fillRect/>
@@ -20348,7 +19919,7 @@
                   <a:avLst/>
                 </a:prstGeom>
                 <a:blipFill rotWithShape="1">
-                  <a:blip r:embed="rId6"/>
+                  <a:blip r:embed="rId7"/>
                 </a:blipFill>
               </p:spPr>
               <p:txBody>
@@ -20373,7 +19944,7 @@
             <p:nvPr/>
           </p:nvPicPr>
           <p:blipFill>
-            <a:blip r:embed="rId4"/>
+            <a:blip r:embed="rId5"/>
             <a:srcRect l="52342" t="811" r="25263" b="52513"/>
             <a:stretch>
               <a:fillRect/>
@@ -20383,29 +19954,6 @@
             <a:xfrm>
               <a:off x="10999" y="601"/>
               <a:ext cx="5056" cy="5237"/>
-            </a:xfrm>
-            <a:prstGeom prst="rect">
-              <a:avLst/>
-            </a:prstGeom>
-          </p:spPr>
-        </p:pic>
-        <p:pic>
-          <p:nvPicPr>
-            <p:cNvPr id="17" name="图片 16"/>
-            <p:cNvPicPr/>
-            <p:nvPr/>
-          </p:nvPicPr>
-          <p:blipFill>
-            <a:blip r:embed="rId4"/>
-            <a:srcRect l="77426" t="935" r="237" b="52389"/>
-            <a:stretch>
-              <a:fillRect/>
-            </a:stretch>
-          </p:blipFill>
-          <p:spPr>
-            <a:xfrm>
-              <a:off x="16399" y="601"/>
-              <a:ext cx="5043" cy="5237"/>
             </a:xfrm>
             <a:prstGeom prst="rect">
               <a:avLst/>
@@ -20487,7 +20035,7 @@
                   <a:avLst/>
                 </a:prstGeom>
                 <a:blipFill rotWithShape="1">
-                  <a:blip r:embed="rId7"/>
+                  <a:blip r:embed="rId8"/>
                 </a:blipFill>
               </p:spPr>
               <p:txBody>
@@ -20515,7 +20063,7 @@
               </p:nvSpPr>
               <p:spPr>
                 <a:xfrm>
-                  <a:off x="16943" y="641"/>
+                  <a:off x="17039" y="635"/>
                   <a:ext cx="1199" cy="1004"/>
                 </a:xfrm>
                 <a:prstGeom prst="rect">
@@ -20573,14 +20121,14 @@
               </p:nvSpPr>
               <p:spPr>
                 <a:xfrm>
-                  <a:off x="16943" y="641"/>
+                  <a:off x="17039" y="635"/>
                   <a:ext cx="1199" cy="1004"/>
                 </a:xfrm>
                 <a:prstGeom prst="rect">
                   <a:avLst/>
                 </a:prstGeom>
                 <a:blipFill rotWithShape="1">
-                  <a:blip r:embed="rId8"/>
+                  <a:blip r:embed="rId9"/>
                 </a:blipFill>
               </p:spPr>
               <p:txBody>
@@ -21000,7 +20548,7 @@
                 <p:nvPr/>
               </p:nvPicPr>
               <p:blipFill>
-                <a:blip r:embed="rId4"/>
+                <a:blip r:embed="rId5"/>
                 <a:srcRect l="1917" t="50579" r="75927" b="3155"/>
                 <a:stretch>
                   <a:fillRect/>
@@ -21023,7 +20571,7 @@
                 <p:nvPr/>
               </p:nvPicPr>
               <p:blipFill>
-                <a:blip r:embed="rId4"/>
+                <a:blip r:embed="rId5"/>
                 <a:srcRect l="27196" t="50579" r="50688" b="2977"/>
                 <a:stretch>
                   <a:fillRect/>
@@ -21046,7 +20594,7 @@
                 <p:nvPr/>
               </p:nvPicPr>
               <p:blipFill>
-                <a:blip r:embed="rId4"/>
+                <a:blip r:embed="rId5"/>
                 <a:srcRect l="50916" t="50579" r="25356" b="2977"/>
                 <a:stretch>
                   <a:fillRect/>
@@ -21137,7 +20685,7 @@
                       <a:avLst/>
                     </a:prstGeom>
                     <a:blipFill rotWithShape="1">
-                      <a:blip r:embed="rId9"/>
+                      <a:blip r:embed="rId10"/>
                     </a:blipFill>
                   </p:spPr>
                   <p:txBody>
@@ -21230,7 +20778,7 @@
                       <a:avLst/>
                     </a:prstGeom>
                     <a:blipFill rotWithShape="1">
-                      <a:blip r:embed="rId10"/>
+                      <a:blip r:embed="rId11"/>
                     </a:blipFill>
                   </p:spPr>
                   <p:txBody>
@@ -21323,7 +20871,7 @@
                       <a:avLst/>
                     </a:prstGeom>
                     <a:blipFill rotWithShape="1">
-                      <a:blip r:embed="rId11"/>
+                      <a:blip r:embed="rId12"/>
                     </a:blipFill>
                   </p:spPr>
                   <p:txBody>
@@ -21442,7 +20990,7 @@
             <p:nvPr/>
           </p:nvPicPr>
           <p:blipFill>
-            <a:blip r:embed="rId12"/>
+            <a:blip r:embed="rId13"/>
             <a:stretch>
               <a:fillRect/>
             </a:stretch>
@@ -21467,6 +21015,888 @@
 </file>
 
 <file path=ppt/slides/slide15.xml><?xml version="1.0" encoding="utf-8"?>
+<p:sld xmlns:a="http://schemas.openxmlformats.org/drawingml/2006/main" xmlns:r="http://schemas.openxmlformats.org/officeDocument/2006/relationships" xmlns:p="http://schemas.openxmlformats.org/presentationml/2006/main">
+  <p:cSld>
+    <p:spTree>
+      <p:nvGrpSpPr>
+        <p:cNvPr id="1" name=""/>
+        <p:cNvGrpSpPr/>
+        <p:nvPr/>
+      </p:nvGrpSpPr>
+      <p:grpSpPr/>
+      <mc:AlternateContent xmlns:mc="http://schemas.openxmlformats.org/markup-compatibility/2006" xmlns:a14="http://schemas.microsoft.com/office/drawing/2010/main">
+        <mc:Choice Requires="a14">
+          <p:graphicFrame>
+            <p:nvGraphicFramePr>
+              <p:cNvPr id="2" name="表格 1"/>
+              <p:cNvGraphicFramePr/>
+              <p:nvPr/>
+            </p:nvGraphicFramePr>
+            <p:xfrm>
+              <a:off x="2160270" y="3096895"/>
+              <a:ext cx="10079355" cy="3327400"/>
+            </p:xfrm>
+            <a:graphic>
+              <a:graphicData uri="http://schemas.openxmlformats.org/drawingml/2006/table">
+                <a:tbl>
+                  <a:tblPr firstRow="1">
+                    <a:tableStyleId>{9D7B26C5-4107-4FEC-AEDC-1716B250A1EF}</a:tableStyleId>
+                  </a:tblPr>
+                  <a:tblGrid>
+                    <a:gridCol w="3359785"/>
+                    <a:gridCol w="3359785"/>
+                    <a:gridCol w="3359785"/>
+                  </a:tblGrid>
+                  <a:tr h="381000">
+                    <a:tc>
+                      <a:txBody>
+                        <a:bodyPr/>
+                        <a:p>
+                          <a:pPr>
+                            <a:buNone/>
+                          </a:pPr>
+                          <a:r>
+                            <a:rPr lang="zh-CN" altLang="en-US">
+                              <a:latin typeface="Arial" panose="020B0604020202020204" pitchFamily="34" charset="0"/>
+                              <a:cs typeface="Arial" panose="020B0604020202020204" pitchFamily="34" charset="0"/>
+                            </a:rPr>
+                            <a:t>Δ</a:t>
+                          </a:r>
+                          <a:r>
+                            <a:rPr lang="en-US" altLang="zh-CN">
+                              <a:latin typeface="Arial" panose="020B0604020202020204" pitchFamily="34" charset="0"/>
+                              <a:cs typeface="Arial" panose="020B0604020202020204" pitchFamily="34" charset="0"/>
+                            </a:rPr>
+                            <a:t>Param</a:t>
+                          </a:r>
+                          <a:endParaRPr lang="en-US" altLang="zh-CN">
+                            <a:latin typeface="Arial" panose="020B0604020202020204" pitchFamily="34" charset="0"/>
+                            <a:cs typeface="Arial" panose="020B0604020202020204" pitchFamily="34" charset="0"/>
+                          </a:endParaRPr>
+                        </a:p>
+                      </a:txBody>
+                      <a:tcPr/>
+                    </a:tc>
+                    <a:tc>
+                      <a:txBody>
+                        <a:bodyPr/>
+                        <a:p>
+                          <a:pPr>
+                            <a:buNone/>
+                          </a:pPr>
+                          <a:r>
+                            <a:rPr lang="en-US" altLang="zh-CN"/>
+                            <a:t>Significance</a:t>
+                          </a:r>
+                          <a:endParaRPr lang="en-US" altLang="zh-CN"/>
+                        </a:p>
+                      </a:txBody>
+                      <a:tcPr/>
+                    </a:tc>
+                    <a:tc>
+                      <a:txBody>
+                        <a:bodyPr/>
+                        <a:p>
+                          <a:pPr>
+                            <a:buNone/>
+                          </a:pPr>
+                          <a:r>
+                            <a:rPr lang="en-US" altLang="zh-CN"/>
+                            <a:t>Sign</a:t>
+                          </a:r>
+                          <a:endParaRPr lang="en-US" altLang="zh-CN"/>
+                        </a:p>
+                      </a:txBody>
+                      <a:tcPr/>
+                    </a:tc>
+                  </a:tr>
+                  <a:tr h="381000">
+                    <a:tc>
+                      <a:txBody>
+                        <a:bodyPr/>
+                        <a:p>
+                          <a:pPr>
+                            <a:buNone/>
+                          </a:pPr>
+                          <a14:m>
+                            <m:oMathPara xmlns:m="http://schemas.openxmlformats.org/officeDocument/2006/math">
+                              <m:oMathParaPr>
+                                <m:jc m:val="centerGroup"/>
+                              </m:oMathParaPr>
+                              <m:oMath xmlns:m="http://schemas.openxmlformats.org/officeDocument/2006/math">
+                                <m:r>
+                                  <a:rPr lang="en-US" altLang="zh-CN" i="1">
+                                    <a:latin typeface="Cambria Math" panose="02040503050406030204" charset="0"/>
+                                    <a:cs typeface="Cambria Math" panose="02040503050406030204" charset="0"/>
+                                  </a:rPr>
+                                  <m:t>𝛥𝛼</m:t>
+                                </m:r>
+                              </m:oMath>
+                            </m:oMathPara>
+                          </a14:m>
+                          <a:endParaRPr lang="zh-CN" altLang="en-US">
+                            <a:latin typeface="Arial" panose="020B0604020202020204" pitchFamily="34" charset="0"/>
+                            <a:cs typeface="Arial" panose="020B0604020202020204" pitchFamily="34" charset="0"/>
+                          </a:endParaRPr>
+                        </a:p>
+                      </a:txBody>
+                      <a:tcPr/>
+                    </a:tc>
+                    <a:tc>
+                      <a:txBody>
+                        <a:bodyPr/>
+                        <a:p>
+                          <a:pPr>
+                            <a:buNone/>
+                          </a:pPr>
+                          <a:endParaRPr lang="zh-CN" altLang="en-US"/>
+                        </a:p>
+                      </a:txBody>
+                      <a:tcPr/>
+                    </a:tc>
+                    <a:tc>
+                      <a:txBody>
+                        <a:bodyPr/>
+                        <a:p>
+                          <a:pPr>
+                            <a:buNone/>
+                          </a:pPr>
+                          <a:endParaRPr lang="zh-CN" altLang="en-US"/>
+                        </a:p>
+                      </a:txBody>
+                      <a:tcPr/>
+                    </a:tc>
+                  </a:tr>
+                  <a:tr h="381000">
+                    <a:tc>
+                      <a:txBody>
+                        <a:bodyPr/>
+                        <a:p>
+                          <a:pPr>
+                            <a:buNone/>
+                          </a:pPr>
+                          <a14:m>
+                            <m:oMathPara xmlns:m="http://schemas.openxmlformats.org/officeDocument/2006/math">
+                              <m:oMathParaPr>
+                                <m:jc m:val="centerGroup"/>
+                              </m:oMathParaPr>
+                              <m:oMath xmlns:m="http://schemas.openxmlformats.org/officeDocument/2006/math">
+                                <m:r>
+                                  <a:rPr lang="en-US" altLang="zh-CN" sz="2125" i="1">
+                                    <a:latin typeface="Cambria Math" panose="02040503050406030204" charset="0"/>
+                                    <a:cs typeface="Cambria Math" panose="02040503050406030204" charset="0"/>
+                                  </a:rPr>
+                                  <m:t>𝛥𝛽</m:t>
+                                </m:r>
+                              </m:oMath>
+                            </m:oMathPara>
+                          </a14:m>
+                          <a:endParaRPr lang="zh-CN" altLang="en-US"/>
+                        </a:p>
+                      </a:txBody>
+                      <a:tcPr/>
+                    </a:tc>
+                    <a:tc>
+                      <a:txBody>
+                        <a:bodyPr/>
+                        <a:p>
+                          <a:pPr>
+                            <a:buNone/>
+                          </a:pPr>
+                          <a:endParaRPr lang="zh-CN" altLang="en-US"/>
+                        </a:p>
+                      </a:txBody>
+                      <a:tcPr/>
+                    </a:tc>
+                    <a:tc>
+                      <a:txBody>
+                        <a:bodyPr/>
+                        <a:p>
+                          <a:pPr>
+                            <a:buNone/>
+                          </a:pPr>
+                          <a:endParaRPr lang="zh-CN" altLang="en-US"/>
+                        </a:p>
+                      </a:txBody>
+                      <a:tcPr/>
+                    </a:tc>
+                  </a:tr>
+                  <a:tr h="381000">
+                    <a:tc>
+                      <a:txBody>
+                        <a:bodyPr/>
+                        <a:p>
+                          <a:pPr>
+                            <a:buNone/>
+                          </a:pPr>
+                          <a14:m>
+                            <m:oMathPara xmlns:m="http://schemas.openxmlformats.org/officeDocument/2006/math">
+                              <m:oMathParaPr>
+                                <m:jc m:val="centerGroup"/>
+                              </m:oMathParaPr>
+                              <m:oMath xmlns:m="http://schemas.openxmlformats.org/officeDocument/2006/math">
+                                <m:r>
+                                  <a:rPr lang="en-US" altLang="zh-CN" sz="2125" i="1">
+                                    <a:latin typeface="Cambria Math" panose="02040503050406030204" charset="0"/>
+                                    <a:cs typeface="Cambria Math" panose="02040503050406030204" charset="0"/>
+                                  </a:rPr>
+                                  <m:t>𝛥𝜅</m:t>
+                                </m:r>
+                              </m:oMath>
+                            </m:oMathPara>
+                          </a14:m>
+                          <a:endParaRPr lang="zh-CN" altLang="en-US"/>
+                        </a:p>
+                      </a:txBody>
+                      <a:tcPr/>
+                    </a:tc>
+                    <a:tc>
+                      <a:txBody>
+                        <a:bodyPr/>
+                        <a:p>
+                          <a:pPr>
+                            <a:buNone/>
+                          </a:pPr>
+                          <a:endParaRPr lang="zh-CN" altLang="en-US"/>
+                        </a:p>
+                      </a:txBody>
+                      <a:tcPr/>
+                    </a:tc>
+                    <a:tc>
+                      <a:txBody>
+                        <a:bodyPr/>
+                        <a:p>
+                          <a:pPr>
+                            <a:buNone/>
+                          </a:pPr>
+                          <a:endParaRPr lang="zh-CN" altLang="en-US"/>
+                        </a:p>
+                      </a:txBody>
+                      <a:tcPr/>
+                    </a:tc>
+                  </a:tr>
+                  <a:tr h="381000">
+                    <a:tc>
+                      <a:txBody>
+                        <a:bodyPr/>
+                        <a:p>
+                          <a:pPr>
+                            <a:buNone/>
+                          </a:pPr>
+                          <a14:m>
+                            <m:oMathPara xmlns:m="http://schemas.openxmlformats.org/officeDocument/2006/math">
+                              <m:oMathParaPr>
+                                <m:jc m:val="centerGroup"/>
+                              </m:oMathParaPr>
+                              <m:oMath xmlns:m="http://schemas.openxmlformats.org/officeDocument/2006/math">
+                                <m:r>
+                                  <a:rPr lang="en-US" altLang="zh-CN" sz="2125" i="1">
+                                    <a:latin typeface="Cambria Math" panose="02040503050406030204" charset="0"/>
+                                    <a:cs typeface="Cambria Math" panose="02040503050406030204" charset="0"/>
+                                  </a:rPr>
+                                  <m:t>𝛥𝛿</m:t>
+                                </m:r>
+                              </m:oMath>
+                            </m:oMathPara>
+                          </a14:m>
+                          <a:endParaRPr lang="zh-CN" altLang="en-US"/>
+                        </a:p>
+                      </a:txBody>
+                      <a:tcPr/>
+                    </a:tc>
+                    <a:tc>
+                      <a:txBody>
+                        <a:bodyPr/>
+                        <a:p>
+                          <a:pPr>
+                            <a:buNone/>
+                          </a:pPr>
+                          <a:endParaRPr lang="zh-CN" altLang="en-US"/>
+                        </a:p>
+                      </a:txBody>
+                      <a:tcPr/>
+                    </a:tc>
+                    <a:tc>
+                      <a:txBody>
+                        <a:bodyPr/>
+                        <a:p>
+                          <a:pPr>
+                            <a:buNone/>
+                          </a:pPr>
+                          <a:endParaRPr lang="zh-CN" altLang="en-US"/>
+                        </a:p>
+                      </a:txBody>
+                      <a:tcPr/>
+                    </a:tc>
+                  </a:tr>
+                  <a:tr h="381000">
+                    <a:tc>
+                      <a:txBody>
+                        <a:bodyPr/>
+                        <a:p>
+                          <a:pPr>
+                            <a:buNone/>
+                          </a:pPr>
+                          <a14:m>
+                            <m:oMathPara xmlns:m="http://schemas.openxmlformats.org/officeDocument/2006/math">
+                              <m:oMathParaPr>
+                                <m:jc m:val="centerGroup"/>
+                              </m:oMathParaPr>
+                              <m:oMath xmlns:m="http://schemas.openxmlformats.org/officeDocument/2006/math">
+                                <m:r>
+                                  <a:rPr lang="en-US" altLang="zh-CN" sz="2125" i="1">
+                                    <a:latin typeface="Cambria Math" panose="02040503050406030204" charset="0"/>
+                                    <a:cs typeface="Cambria Math" panose="02040503050406030204" charset="0"/>
+                                  </a:rPr>
+                                  <m:t>𝛥</m:t>
+                                </m:r>
+                                <m:r>
+                                  <a:rPr lang="en-US" altLang="zh-CN" sz="2125" i="1">
+                                    <a:latin typeface="Cambria Math" panose="02040503050406030204" charset="0"/>
+                                    <a:cs typeface="Cambria Math" panose="02040503050406030204" charset="0"/>
+                                  </a:rPr>
+                                  <m:t>𝐴</m:t>
+                                </m:r>
+                              </m:oMath>
+                            </m:oMathPara>
+                          </a14:m>
+                          <a:endParaRPr lang="zh-CN" altLang="en-US"/>
+                        </a:p>
+                      </a:txBody>
+                      <a:tcPr/>
+                    </a:tc>
+                    <a:tc>
+                      <a:txBody>
+                        <a:bodyPr/>
+                        <a:p>
+                          <a:pPr>
+                            <a:buNone/>
+                          </a:pPr>
+                          <a:endParaRPr lang="zh-CN" altLang="en-US"/>
+                        </a:p>
+                      </a:txBody>
+                      <a:tcPr/>
+                    </a:tc>
+                    <a:tc>
+                      <a:txBody>
+                        <a:bodyPr/>
+                        <a:p>
+                          <a:pPr>
+                            <a:buNone/>
+                          </a:pPr>
+                          <a:endParaRPr lang="zh-CN" altLang="en-US"/>
+                        </a:p>
+                      </a:txBody>
+                      <a:tcPr/>
+                    </a:tc>
+                  </a:tr>
+                  <a:tr h="381000">
+                    <a:tc>
+                      <a:txBody>
+                        <a:bodyPr/>
+                        <a:p>
+                          <a:pPr>
+                            <a:buNone/>
+                          </a:pPr>
+                          <a14:m>
+                            <m:oMathPara xmlns:m="http://schemas.openxmlformats.org/officeDocument/2006/math">
+                              <m:oMathParaPr>
+                                <m:jc m:val="centerGroup"/>
+                              </m:oMathParaPr>
+                              <m:oMath xmlns:m="http://schemas.openxmlformats.org/officeDocument/2006/math">
+                                <m:r>
+                                  <a:rPr lang="en-US" altLang="zh-CN" sz="2125" i="1">
+                                    <a:latin typeface="Cambria Math" panose="02040503050406030204" charset="0"/>
+                                    <a:cs typeface="Cambria Math" panose="02040503050406030204" charset="0"/>
+                                  </a:rPr>
+                                  <m:t>𝛥</m:t>
+                                </m:r>
+                                <m:r>
+                                  <a:rPr lang="en-US" altLang="zh-CN" sz="2125" i="1">
+                                    <a:latin typeface="Cambria Math" panose="02040503050406030204" charset="0"/>
+                                    <a:cs typeface="Cambria Math" panose="02040503050406030204" charset="0"/>
+                                  </a:rPr>
+                                  <m:t>𝐵</m:t>
+                                </m:r>
+                              </m:oMath>
+                            </m:oMathPara>
+                          </a14:m>
+                          <a:endParaRPr lang="zh-CN" altLang="en-US"/>
+                        </a:p>
+                      </a:txBody>
+                      <a:tcPr/>
+                    </a:tc>
+                    <a:tc>
+                      <a:txBody>
+                        <a:bodyPr/>
+                        <a:p>
+                          <a:pPr>
+                            <a:buNone/>
+                          </a:pPr>
+                          <a:endParaRPr lang="zh-CN" altLang="en-US"/>
+                        </a:p>
+                      </a:txBody>
+                      <a:tcPr/>
+                    </a:tc>
+                    <a:tc>
+                      <a:txBody>
+                        <a:bodyPr/>
+                        <a:p>
+                          <a:pPr>
+                            <a:buNone/>
+                          </a:pPr>
+                          <a:endParaRPr lang="zh-CN" altLang="en-US"/>
+                        </a:p>
+                      </a:txBody>
+                      <a:tcPr/>
+                    </a:tc>
+                  </a:tr>
+                  <a:tr h="381000">
+                    <a:tc>
+                      <a:txBody>
+                        <a:bodyPr/>
+                        <a:p>
+                          <a:pPr>
+                            <a:buNone/>
+                          </a:pPr>
+                          <a14:m>
+                            <m:oMathPara xmlns:m="http://schemas.openxmlformats.org/officeDocument/2006/math">
+                              <m:oMathParaPr>
+                                <m:jc m:val="centerGroup"/>
+                              </m:oMathParaPr>
+                              <m:oMath xmlns:m="http://schemas.openxmlformats.org/officeDocument/2006/math">
+                                <m:r>
+                                  <a:rPr lang="en-US" altLang="zh-CN" sz="2125" i="1">
+                                    <a:latin typeface="Cambria Math" panose="02040503050406030204" charset="0"/>
+                                    <a:cs typeface="Cambria Math" panose="02040503050406030204" charset="0"/>
+                                  </a:rPr>
+                                  <m:t>𝛥</m:t>
+                                </m:r>
+                                <m:r>
+                                  <a:rPr lang="en-US" altLang="zh-CN" sz="2125" i="1">
+                                    <a:latin typeface="Cambria Math" panose="02040503050406030204" charset="0"/>
+                                    <a:cs typeface="Cambria Math" panose="02040503050406030204" charset="0"/>
+                                  </a:rPr>
+                                  <m:t>𝐶</m:t>
+                                </m:r>
+                              </m:oMath>
+                            </m:oMathPara>
+                          </a14:m>
+                          <a:endParaRPr lang="zh-CN" altLang="en-US"/>
+                        </a:p>
+                      </a:txBody>
+                      <a:tcPr/>
+                    </a:tc>
+                    <a:tc>
+                      <a:txBody>
+                        <a:bodyPr/>
+                        <a:p>
+                          <a:pPr>
+                            <a:buNone/>
+                          </a:pPr>
+                          <a:endParaRPr lang="zh-CN" altLang="en-US"/>
+                        </a:p>
+                      </a:txBody>
+                      <a:tcPr/>
+                    </a:tc>
+                    <a:tc>
+                      <a:txBody>
+                        <a:bodyPr/>
+                        <a:p>
+                          <a:pPr>
+                            <a:buNone/>
+                          </a:pPr>
+                          <a:endParaRPr lang="zh-CN" altLang="en-US"/>
+                        </a:p>
+                      </a:txBody>
+                      <a:tcPr/>
+                    </a:tc>
+                  </a:tr>
+                </a:tbl>
+              </a:graphicData>
+            </a:graphic>
+          </p:graphicFrame>
+        </mc:Choice>
+        <mc:Fallback xmlns="">
+          <p:graphicFrame>
+            <p:nvGraphicFramePr>
+              <p:cNvPr id="2" name="表格 1"/>
+              <p:cNvGraphicFramePr/>
+              <p:nvPr/>
+            </p:nvGraphicFramePr>
+            <p:xfrm>
+              <a:off x="2160270" y="3096895"/>
+              <a:ext cx="10079355" cy="3327400"/>
+            </p:xfrm>
+            <a:graphic>
+              <a:graphicData uri="http://schemas.openxmlformats.org/drawingml/2006/table">
+                <a:tbl>
+                  <a:tblPr firstRow="1">
+                    <a:tableStyleId>{9D7B26C5-4107-4FEC-AEDC-1716B250A1EF}</a:tableStyleId>
+                  </a:tblPr>
+                  <a:tblGrid>
+                    <a:gridCol w="3359785"/>
+                    <a:gridCol w="3359785"/>
+                    <a:gridCol w="3359785"/>
+                  </a:tblGrid>
+                  <a:tr h="381000">
+                    <a:tc>
+                      <a:txBody>
+                        <a:bodyPr/>
+                        <a:p>
+                          <a:pPr>
+                            <a:buNone/>
+                          </a:pPr>
+                          <a:r>
+                            <a:rPr lang="zh-CN" altLang="en-US">
+                              <a:latin typeface="Arial" panose="020B0604020202020204" pitchFamily="34" charset="0"/>
+                              <a:cs typeface="Arial" panose="020B0604020202020204" pitchFamily="34" charset="0"/>
+                            </a:rPr>
+                            <a:t>Δ</a:t>
+                          </a:r>
+                          <a:r>
+                            <a:rPr lang="en-US" altLang="zh-CN">
+                              <a:latin typeface="Arial" panose="020B0604020202020204" pitchFamily="34" charset="0"/>
+                              <a:cs typeface="Arial" panose="020B0604020202020204" pitchFamily="34" charset="0"/>
+                            </a:rPr>
+                            <a:t>Param</a:t>
+                          </a:r>
+                          <a:endParaRPr lang="en-US" altLang="zh-CN">
+                            <a:latin typeface="Arial" panose="020B0604020202020204" pitchFamily="34" charset="0"/>
+                            <a:cs typeface="Arial" panose="020B0604020202020204" pitchFamily="34" charset="0"/>
+                          </a:endParaRPr>
+                        </a:p>
+                      </a:txBody>
+                      <a:tcPr/>
+                    </a:tc>
+                    <a:tc>
+                      <a:txBody>
+                        <a:bodyPr/>
+                        <a:p>
+                          <a:pPr>
+                            <a:buNone/>
+                          </a:pPr>
+                          <a:r>
+                            <a:rPr lang="en-US" altLang="zh-CN"/>
+                            <a:t>Significance</a:t>
+                          </a:r>
+                          <a:endParaRPr lang="en-US" altLang="zh-CN"/>
+                        </a:p>
+                      </a:txBody>
+                      <a:tcPr/>
+                    </a:tc>
+                    <a:tc>
+                      <a:txBody>
+                        <a:bodyPr/>
+                        <a:p>
+                          <a:pPr>
+                            <a:buNone/>
+                          </a:pPr>
+                          <a:r>
+                            <a:rPr lang="en-US" altLang="zh-CN"/>
+                            <a:t>Sign</a:t>
+                          </a:r>
+                          <a:endParaRPr lang="en-US" altLang="zh-CN"/>
+                        </a:p>
+                      </a:txBody>
+                      <a:tcPr/>
+                    </a:tc>
+                  </a:tr>
+                  <a:tr h="415925">
+                    <a:tc>
+                      <a:txBody>
+                        <a:bodyPr/>
+                        <a:lstStyle/>
+                        <a:p>
+                          <a:endParaRPr lang="zh-CN"/>
+                        </a:p>
+                      </a:txBody>
+                      <a:tcPr>
+                        <a:blipFill>
+                          <a:blip r:embed="rId1"/>
+                        </a:blipFill>
+                      </a:tcPr>
+                    </a:tc>
+                    <a:tc>
+                      <a:txBody>
+                        <a:bodyPr/>
+                        <a:p>
+                          <a:pPr>
+                            <a:buNone/>
+                          </a:pPr>
+                          <a:endParaRPr lang="zh-CN" altLang="en-US"/>
+                        </a:p>
+                      </a:txBody>
+                      <a:tcPr/>
+                    </a:tc>
+                    <a:tc>
+                      <a:txBody>
+                        <a:bodyPr/>
+                        <a:p>
+                          <a:pPr>
+                            <a:buNone/>
+                          </a:pPr>
+                          <a:endParaRPr lang="zh-CN" altLang="en-US"/>
+                        </a:p>
+                      </a:txBody>
+                      <a:tcPr/>
+                    </a:tc>
+                  </a:tr>
+                  <a:tr h="415925">
+                    <a:tc>
+                      <a:txBody>
+                        <a:bodyPr/>
+                        <a:lstStyle/>
+                        <a:p>
+                          <a:endParaRPr lang="zh-CN"/>
+                        </a:p>
+                      </a:txBody>
+                      <a:tcPr>
+                        <a:blipFill>
+                          <a:blip r:embed="rId1"/>
+                        </a:blipFill>
+                      </a:tcPr>
+                    </a:tc>
+                    <a:tc>
+                      <a:txBody>
+                        <a:bodyPr/>
+                        <a:p>
+                          <a:pPr>
+                            <a:buNone/>
+                          </a:pPr>
+                          <a:endParaRPr lang="zh-CN" altLang="en-US"/>
+                        </a:p>
+                      </a:txBody>
+                      <a:tcPr/>
+                    </a:tc>
+                    <a:tc>
+                      <a:txBody>
+                        <a:bodyPr/>
+                        <a:p>
+                          <a:pPr>
+                            <a:buNone/>
+                          </a:pPr>
+                          <a:endParaRPr lang="zh-CN" altLang="en-US"/>
+                        </a:p>
+                      </a:txBody>
+                      <a:tcPr/>
+                    </a:tc>
+                  </a:tr>
+                  <a:tr h="415925">
+                    <a:tc>
+                      <a:txBody>
+                        <a:bodyPr/>
+                        <a:lstStyle/>
+                        <a:p>
+                          <a:endParaRPr lang="zh-CN"/>
+                        </a:p>
+                      </a:txBody>
+                      <a:tcPr>
+                        <a:blipFill>
+                          <a:blip r:embed="rId1"/>
+                        </a:blipFill>
+                      </a:tcPr>
+                    </a:tc>
+                    <a:tc>
+                      <a:txBody>
+                        <a:bodyPr/>
+                        <a:p>
+                          <a:pPr>
+                            <a:buNone/>
+                          </a:pPr>
+                          <a:endParaRPr lang="zh-CN" altLang="en-US"/>
+                        </a:p>
+                      </a:txBody>
+                      <a:tcPr/>
+                    </a:tc>
+                    <a:tc>
+                      <a:txBody>
+                        <a:bodyPr/>
+                        <a:p>
+                          <a:pPr>
+                            <a:buNone/>
+                          </a:pPr>
+                          <a:endParaRPr lang="zh-CN" altLang="en-US"/>
+                        </a:p>
+                      </a:txBody>
+                      <a:tcPr/>
+                    </a:tc>
+                  </a:tr>
+                  <a:tr h="415925">
+                    <a:tc>
+                      <a:txBody>
+                        <a:bodyPr/>
+                        <a:lstStyle/>
+                        <a:p>
+                          <a:endParaRPr lang="zh-CN"/>
+                        </a:p>
+                      </a:txBody>
+                      <a:tcPr>
+                        <a:blipFill>
+                          <a:blip r:embed="rId1"/>
+                        </a:blipFill>
+                      </a:tcPr>
+                    </a:tc>
+                    <a:tc>
+                      <a:txBody>
+                        <a:bodyPr/>
+                        <a:p>
+                          <a:pPr>
+                            <a:buNone/>
+                          </a:pPr>
+                          <a:endParaRPr lang="zh-CN" altLang="en-US"/>
+                        </a:p>
+                      </a:txBody>
+                      <a:tcPr/>
+                    </a:tc>
+                    <a:tc>
+                      <a:txBody>
+                        <a:bodyPr/>
+                        <a:p>
+                          <a:pPr>
+                            <a:buNone/>
+                          </a:pPr>
+                          <a:endParaRPr lang="zh-CN" altLang="en-US"/>
+                        </a:p>
+                      </a:txBody>
+                      <a:tcPr/>
+                    </a:tc>
+                  </a:tr>
+                  <a:tr h="415925">
+                    <a:tc>
+                      <a:txBody>
+                        <a:bodyPr/>
+                        <a:lstStyle/>
+                        <a:p>
+                          <a:endParaRPr lang="zh-CN"/>
+                        </a:p>
+                      </a:txBody>
+                      <a:tcPr>
+                        <a:blipFill>
+                          <a:blip r:embed="rId1"/>
+                        </a:blipFill>
+                      </a:tcPr>
+                    </a:tc>
+                    <a:tc>
+                      <a:txBody>
+                        <a:bodyPr/>
+                        <a:p>
+                          <a:pPr>
+                            <a:buNone/>
+                          </a:pPr>
+                          <a:endParaRPr lang="zh-CN" altLang="en-US"/>
+                        </a:p>
+                      </a:txBody>
+                      <a:tcPr/>
+                    </a:tc>
+                    <a:tc>
+                      <a:txBody>
+                        <a:bodyPr/>
+                        <a:p>
+                          <a:pPr>
+                            <a:buNone/>
+                          </a:pPr>
+                          <a:endParaRPr lang="zh-CN" altLang="en-US"/>
+                        </a:p>
+                      </a:txBody>
+                      <a:tcPr/>
+                    </a:tc>
+                  </a:tr>
+                  <a:tr h="415925">
+                    <a:tc>
+                      <a:txBody>
+                        <a:bodyPr/>
+                        <a:lstStyle/>
+                        <a:p>
+                          <a:endParaRPr lang="zh-CN"/>
+                        </a:p>
+                      </a:txBody>
+                      <a:tcPr>
+                        <a:blipFill>
+                          <a:blip r:embed="rId1"/>
+                        </a:blipFill>
+                      </a:tcPr>
+                    </a:tc>
+                    <a:tc>
+                      <a:txBody>
+                        <a:bodyPr/>
+                        <a:p>
+                          <a:pPr>
+                            <a:buNone/>
+                          </a:pPr>
+                          <a:endParaRPr lang="zh-CN" altLang="en-US"/>
+                        </a:p>
+                      </a:txBody>
+                      <a:tcPr/>
+                    </a:tc>
+                    <a:tc>
+                      <a:txBody>
+                        <a:bodyPr/>
+                        <a:p>
+                          <a:pPr>
+                            <a:buNone/>
+                          </a:pPr>
+                          <a:endParaRPr lang="zh-CN" altLang="en-US"/>
+                        </a:p>
+                      </a:txBody>
+                      <a:tcPr/>
+                    </a:tc>
+                  </a:tr>
+                  <a:tr h="415925">
+                    <a:tc>
+                      <a:txBody>
+                        <a:bodyPr/>
+                        <a:lstStyle/>
+                        <a:p>
+                          <a:endParaRPr lang="zh-CN"/>
+                        </a:p>
+                      </a:txBody>
+                      <a:tcPr>
+                        <a:blipFill>
+                          <a:blip r:embed="rId1"/>
+                        </a:blipFill>
+                      </a:tcPr>
+                    </a:tc>
+                    <a:tc>
+                      <a:txBody>
+                        <a:bodyPr/>
+                        <a:p>
+                          <a:pPr>
+                            <a:buNone/>
+                          </a:pPr>
+                          <a:endParaRPr lang="zh-CN" altLang="en-US"/>
+                        </a:p>
+                      </a:txBody>
+                      <a:tcPr/>
+                    </a:tc>
+                    <a:tc>
+                      <a:txBody>
+                        <a:bodyPr/>
+                        <a:p>
+                          <a:pPr>
+                            <a:buNone/>
+                          </a:pPr>
+                          <a:endParaRPr lang="zh-CN" altLang="en-US"/>
+                        </a:p>
+                      </a:txBody>
+                      <a:tcPr/>
+                    </a:tc>
+                  </a:tr>
+                </a:tbl>
+              </a:graphicData>
+            </a:graphic>
+          </p:graphicFrame>
+        </mc:Fallback>
+      </mc:AlternateContent>
+    </p:spTree>
+  </p:cSld>
+  <p:clrMapOvr>
+    <a:masterClrMapping/>
+  </p:clrMapOvr>
+</p:sld>
+</file>
+
+<file path=ppt/slides/slide16.xml><?xml version="1.0" encoding="utf-8"?>
 <p:sld xmlns:a="http://schemas.openxmlformats.org/drawingml/2006/main" xmlns:r="http://schemas.openxmlformats.org/officeDocument/2006/relationships" xmlns:p="http://schemas.openxmlformats.org/presentationml/2006/main" show="0">
   <p:cSld>
     <p:spTree>
@@ -22321,7 +22751,7 @@
                       <a:avLst/>
                     </a:prstGeom>
                     <a:blipFill rotWithShape="1">
-                      <a:blip r:embed="rId3"/>
+                      <a:blip r:embed="rId10"/>
                     </a:blipFill>
                   </p:spPr>
                   <p:txBody>
@@ -22517,7 +22947,7 @@
                       <a:avLst/>
                     </a:prstGeom>
                     <a:blipFill rotWithShape="1">
-                      <a:blip r:embed="rId5"/>
+                      <a:blip r:embed="rId11"/>
                     </a:blipFill>
                   </p:spPr>
                   <p:txBody>
@@ -23202,7 +23632,7 @@
 </p:sld>
 </file>
 
-<file path=ppt/slides/slide16.xml><?xml version="1.0" encoding="utf-8"?>
+<file path=ppt/slides/slide17.xml><?xml version="1.0" encoding="utf-8"?>
 <p:sld xmlns:a="http://schemas.openxmlformats.org/drawingml/2006/main" xmlns:r="http://schemas.openxmlformats.org/officeDocument/2006/relationships" xmlns:p="http://schemas.openxmlformats.org/presentationml/2006/main">
   <p:cSld>
     <p:spTree>
@@ -37547,7 +37977,7 @@
         </p:nvGrpSpPr>
         <p:grpSpPr>
           <a:xfrm>
-            <a:off x="1626870" y="491490"/>
+            <a:off x="1626870" y="480060"/>
             <a:ext cx="11659235" cy="6403975"/>
             <a:chOff x="2562" y="774"/>
             <a:chExt cx="18361" cy="10085"/>
@@ -41174,15 +41604,15 @@
               </p:nvPicPr>
               <p:blipFill>
                 <a:blip r:embed="rId1"/>
-                <a:srcRect t="6532" r="30360" b="4873"/>
+                <a:srcRect l="-385" t="5935" r="30745" b="5033"/>
                 <a:stretch>
                   <a:fillRect/>
                 </a:stretch>
               </p:blipFill>
               <p:spPr>
                 <a:xfrm>
-                  <a:off x="11760" y="2603"/>
-                  <a:ext cx="8697" cy="5527"/>
+                  <a:off x="11760" y="2576"/>
+                  <a:ext cx="8697" cy="5555"/>
                 </a:xfrm>
                 <a:prstGeom prst="rect">
                   <a:avLst/>
@@ -42222,15 +42652,15 @@
               </p:nvPicPr>
               <p:blipFill>
                 <a:blip r:embed="rId2"/>
-                <a:srcRect t="6151" r="32370" b="4661"/>
+                <a:srcRect t="6151" r="32370" b="5770"/>
                 <a:stretch>
                   <a:fillRect/>
                 </a:stretch>
               </p:blipFill>
               <p:spPr>
                 <a:xfrm>
-                  <a:off x="2021" y="2602"/>
-                  <a:ext cx="8382" cy="5528"/>
+                  <a:off x="2021" y="2600"/>
+                  <a:ext cx="8382" cy="5461"/>
                 </a:xfrm>
                 <a:prstGeom prst="rect">
                   <a:avLst/>

</xml_diff>

<commit_message>
update on 2026-05-20 18:46
</commit_message>
<xml_diff>
--- a/Presentations/Graphs/Parameters Scatter.pptx
+++ b/Presentations/Graphs/Parameters Scatter.pptx
@@ -29,7 +29,7 @@
     <p:sldId id="265" r:id="rId19"/>
     <p:sldId id="268" r:id="rId20"/>
   </p:sldIdLst>
-  <p:sldSz cx="8099425" cy="14399895"/>
+  <p:sldSz cx="14399895" cy="14399895"/>
   <p:notesSz cx="7103745" cy="10234295"/>
   <p:defaultTextStyle>
     <a:defPPr>
@@ -163,12 +163,12 @@
             <a:srgbClr val="A4A3A4"/>
           </p15:clr>
         </p15:guide>
-        <p15:guide id="2" pos="2550" userDrawn="1">
+        <p15:guide id="2" pos="4535" userDrawn="1">
           <p15:clr>
             <a:srgbClr val="A4A3A4"/>
           </p15:clr>
         </p15:guide>
-        <p15:guide id="3" orient="horz" pos="4566" userDrawn="1">
+        <p15:guide id="3" orient="horz" pos="4563" userDrawn="1">
           <p15:clr>
             <a:srgbClr val="A4A3A4"/>
           </p15:clr>
@@ -5762,8 +5762,8 @@
         </p:nvSpPr>
         <p:spPr>
           <a:xfrm>
-            <a:off x="2581274" y="1279525"/>
-            <a:ext cx="1943100" cy="3454400"/>
+            <a:off x="1825624" y="1279525"/>
+            <a:ext cx="3454400" cy="3454400"/>
           </a:xfrm>
           <a:prstGeom prst="rect">
             <a:avLst/>
@@ -6081,19 +6081,12 @@
         <p:cNvGrpSpPr/>
         <p:nvPr/>
       </p:nvGrpSpPr>
-      <p:grpSpPr>
-        <a:xfrm>
-          <a:off x="0" y="0"/>
-          <a:ext cx="0" cy="0"/>
-          <a:chOff x="0" y="0"/>
-          <a:chExt cx="0" cy="0"/>
-        </a:xfrm>
-      </p:grpSpPr>
+      <p:grpSpPr/>
       <p:sp>
         <p:nvSpPr>
           <p:cNvPr id="2" name="幻灯片图像占位符 1"/>
           <p:cNvSpPr>
-            <a:spLocks noGrp="1" noRot="1" noChangeAspect="1"/>
+            <a:spLocks noGrp="1"/>
           </p:cNvSpPr>
           <p:nvPr>
             <p:ph type="sldImg" idx="2"/>
@@ -6114,7 +6107,6 @@
         <p:spPr/>
         <p:txBody>
           <a:bodyPr/>
-          <a:lstStyle/>
           <a:p>
             <a:endParaRPr lang="zh-CN" altLang="en-US"/>
           </a:p>
@@ -6211,10 +6203,66 @@
             <p:ph type="sldImg" idx="2"/>
           </p:nvPr>
         </p:nvSpPr>
+        <p:spPr/>
+      </p:sp>
+      <p:sp>
+        <p:nvSpPr>
+          <p:cNvPr id="3" name="文本占位符 2"/>
+          <p:cNvSpPr>
+            <a:spLocks noGrp="1"/>
+          </p:cNvSpPr>
+          <p:nvPr>
+            <p:ph type="body" idx="3"/>
+          </p:nvPr>
+        </p:nvSpPr>
+        <p:spPr/>
+        <p:txBody>
+          <a:bodyPr/>
+          <a:lstStyle/>
+          <a:p>
+            <a:endParaRPr lang="zh-CN" altLang="en-US"/>
+          </a:p>
+        </p:txBody>
+      </p:sp>
+    </p:spTree>
+  </p:cSld>
+  <p:clrMapOvr>
+    <a:masterClrMapping/>
+  </p:clrMapOvr>
+</p:notes>
+</file>
+
+<file path=ppt/notesSlides/notesSlide5.xml><?xml version="1.0" encoding="utf-8"?>
+<p:notes xmlns:a="http://schemas.openxmlformats.org/drawingml/2006/main" xmlns:r="http://schemas.openxmlformats.org/officeDocument/2006/relationships" xmlns:p="http://schemas.openxmlformats.org/presentationml/2006/main">
+  <p:cSld>
+    <p:spTree>
+      <p:nvGrpSpPr>
+        <p:cNvPr id="1" name=""/>
+        <p:cNvGrpSpPr/>
+        <p:nvPr/>
+      </p:nvGrpSpPr>
+      <p:grpSpPr>
+        <a:xfrm>
+          <a:off x="0" y="0"/>
+          <a:ext cx="0" cy="0"/>
+          <a:chOff x="0" y="0"/>
+          <a:chExt cx="0" cy="0"/>
+        </a:xfrm>
+      </p:grpSpPr>
+      <p:sp>
+        <p:nvSpPr>
+          <p:cNvPr id="2" name="幻灯片图像占位符 1"/>
+          <p:cNvSpPr>
+            <a:spLocks noGrp="1" noRot="1" noChangeAspect="1"/>
+          </p:cNvSpPr>
+          <p:nvPr>
+            <p:ph type="sldImg" idx="2"/>
+          </p:nvPr>
+        </p:nvSpPr>
         <p:spPr>
           <a:xfrm>
-            <a:off x="2581275" y="1279525"/>
-            <a:ext cx="1943100" cy="3454400"/>
+            <a:off x="1825625" y="1279525"/>
+            <a:ext cx="3454400" cy="3454400"/>
           </a:xfrm>
         </p:spPr>
       </p:sp>
@@ -6274,8 +6322,8 @@
         </p:nvSpPr>
         <p:spPr>
           <a:xfrm>
-            <a:off x="1012507" y="2778071"/>
-            <a:ext cx="6075045" cy="4592454"/>
+            <a:off x="1800140" y="2778091"/>
+            <a:ext cx="10800847" cy="4592488"/>
           </a:xfrm>
         </p:spPr>
         <p:txBody>
@@ -6284,7 +6332,7 @@
           </a:bodyPr>
           <a:lstStyle>
             <a:lvl1pPr algn="ctr">
-              <a:defRPr sz="5315">
+              <a:defRPr sz="9450">
                 <a:effectLst>
                   <a:outerShdw blurRad="38100" dist="38100" dir="2700000" algn="tl">
                     <a:srgbClr val="000000">
@@ -6379,8 +6427,8 @@
         </p:nvSpPr>
         <p:spPr>
           <a:xfrm>
-            <a:off x="1012507" y="7563872"/>
-            <a:ext cx="6075045" cy="3476914"/>
+            <a:off x="1800140" y="7563927"/>
+            <a:ext cx="10800847" cy="3476939"/>
           </a:xfrm>
         </p:spPr>
         <p:txBody>
@@ -6390,7 +6438,7 @@
           <a:lstStyle>
             <a:lvl1pPr marL="0" indent="0" algn="ctr">
               <a:buNone/>
-              <a:defRPr sz="1595">
+              <a:defRPr sz="2835">
                 <a:solidFill>
                   <a:schemeClr val="tx1">
                     <a:lumMod val="75000"/>
@@ -6402,37 +6450,37 @@
                 <a:ea typeface="+mj-ea"/>
               </a:defRPr>
             </a:lvl1pPr>
-            <a:lvl2pPr marL="405130" indent="0" algn="ctr">
+            <a:lvl2pPr marL="720090" indent="0" algn="ctr">
               <a:buNone/>
-              <a:defRPr sz="1770"/>
+              <a:defRPr sz="3145"/>
             </a:lvl2pPr>
-            <a:lvl3pPr marL="810260" indent="0" algn="ctr">
+            <a:lvl3pPr marL="1440815" indent="0" algn="ctr">
               <a:buNone/>
-              <a:defRPr sz="1595"/>
+              <a:defRPr sz="2835"/>
             </a:lvl3pPr>
-            <a:lvl4pPr marL="1214755" indent="0" algn="ctr">
+            <a:lvl4pPr marL="2159635" indent="0" algn="ctr">
               <a:buNone/>
-              <a:defRPr sz="1420"/>
+              <a:defRPr sz="2525"/>
             </a:lvl4pPr>
-            <a:lvl5pPr marL="1620520" indent="0" algn="ctr">
+            <a:lvl5pPr marL="2880995" indent="0" algn="ctr">
               <a:buNone/>
-              <a:defRPr sz="1420"/>
+              <a:defRPr sz="2525"/>
             </a:lvl5pPr>
-            <a:lvl6pPr marL="2025015" indent="0" algn="ctr">
+            <a:lvl6pPr marL="3600450" indent="0" algn="ctr">
               <a:buNone/>
-              <a:defRPr sz="1420"/>
+              <a:defRPr sz="2525"/>
             </a:lvl6pPr>
-            <a:lvl7pPr marL="2430145" indent="0" algn="ctr">
+            <a:lvl7pPr marL="4320540" indent="0" algn="ctr">
               <a:buNone/>
-              <a:defRPr sz="1420"/>
+              <a:defRPr sz="2525"/>
             </a:lvl7pPr>
-            <a:lvl8pPr marL="2835275" indent="0" algn="ctr">
+            <a:lvl8pPr marL="5040630" indent="0" algn="ctr">
               <a:buNone/>
-              <a:defRPr sz="1420"/>
+              <a:defRPr sz="2525"/>
             </a:lvl8pPr>
-            <a:lvl9pPr marL="3240405" indent="0" algn="ctr">
+            <a:lvl9pPr marL="5761355" indent="0" algn="ctr">
               <a:buNone/>
-              <a:defRPr sz="1420"/>
+              <a:defRPr sz="2525"/>
             </a:lvl9pPr>
           </a:lstStyle>
           <a:p>
@@ -6544,8 +6592,8 @@
         </p:nvSpPr>
         <p:spPr>
           <a:xfrm>
-            <a:off x="556879" y="1158178"/>
-            <a:ext cx="6986301" cy="11673209"/>
+            <a:off x="990077" y="1158186"/>
+            <a:ext cx="12420973" cy="11673294"/>
           </a:xfrm>
         </p:spPr>
         <p:txBody>
@@ -6630,8 +6678,8 @@
         </p:nvSpPr>
         <p:spPr>
           <a:xfrm>
-            <a:off x="430316" y="542705"/>
-            <a:ext cx="6986301" cy="2783533"/>
+            <a:off x="765061" y="542709"/>
+            <a:ext cx="12420973" cy="2783553"/>
           </a:xfrm>
         </p:spPr>
         <p:txBody>
@@ -6640,7 +6688,7 @@
           </a:bodyPr>
           <a:lstStyle>
             <a:lvl1pPr>
-              <a:defRPr sz="2125" b="1">
+              <a:defRPr sz="3780" b="1">
                 <a:effectLst>
                   <a:outerShdw blurRad="38100" dist="38100" dir="2700000" algn="tl">
                     <a:srgbClr val="000000">
@@ -6672,8 +6720,8 @@
         </p:nvSpPr>
         <p:spPr>
           <a:xfrm>
-            <a:off x="430316" y="3833606"/>
-            <a:ext cx="6986301" cy="9137317"/>
+            <a:off x="765061" y="3833634"/>
+            <a:ext cx="12420973" cy="9137384"/>
           </a:xfrm>
         </p:spPr>
         <p:txBody>
@@ -6682,7 +6730,7 @@
           </a:bodyPr>
           <a:lstStyle>
             <a:lvl1pPr>
-              <a:defRPr sz="1770">
+              <a:defRPr sz="3145">
                 <a:solidFill>
                   <a:schemeClr val="tx1">
                     <a:lumMod val="75000"/>
@@ -6692,7 +6740,7 @@
               </a:defRPr>
             </a:lvl1pPr>
             <a:lvl2pPr>
-              <a:defRPr sz="1595">
+              <a:defRPr sz="2835">
                 <a:solidFill>
                   <a:schemeClr val="tx1">
                     <a:lumMod val="75000"/>
@@ -6702,7 +6750,7 @@
               </a:defRPr>
             </a:lvl2pPr>
             <a:lvl3pPr>
-              <a:defRPr sz="1420">
+              <a:defRPr sz="2525">
                 <a:solidFill>
                   <a:schemeClr val="tx1">
                     <a:lumMod val="75000"/>
@@ -6712,7 +6760,7 @@
               </a:defRPr>
             </a:lvl3pPr>
             <a:lvl4pPr>
-              <a:defRPr sz="1420">
+              <a:defRPr sz="2525">
                 <a:solidFill>
                   <a:schemeClr val="tx1">
                     <a:lumMod val="75000"/>
@@ -6722,7 +6770,7 @@
               </a:defRPr>
             </a:lvl4pPr>
             <a:lvl5pPr>
-              <a:defRPr sz="1420">
+              <a:defRPr sz="2525">
                 <a:solidFill>
                   <a:schemeClr val="tx1">
                     <a:lumMod val="75000"/>
@@ -6874,8 +6922,8 @@
         </p:nvSpPr>
         <p:spPr>
           <a:xfrm>
-            <a:off x="552660" y="7876920"/>
-            <a:ext cx="4864255" cy="1703758"/>
+            <a:off x="982576" y="7876978"/>
+            <a:ext cx="8648179" cy="1703770"/>
           </a:xfrm>
         </p:spPr>
         <p:txBody>
@@ -6884,7 +6932,7 @@
           </a:bodyPr>
           <a:lstStyle>
             <a:lvl1pPr>
-              <a:defRPr sz="3545">
+              <a:defRPr sz="6305">
                 <a:effectLst>
                   <a:outerShdw blurRad="38100" dist="38100" dir="2700000" algn="tl">
                     <a:srgbClr val="000000">
@@ -6916,8 +6964,8 @@
         </p:nvSpPr>
         <p:spPr>
           <a:xfrm>
-            <a:off x="552660" y="9680536"/>
-            <a:ext cx="4864255" cy="1359793"/>
+            <a:off x="982576" y="9680607"/>
+            <a:ext cx="8648179" cy="1359803"/>
           </a:xfrm>
         </p:spPr>
         <p:txBody>
@@ -6927,15 +6975,15 @@
           <a:lstStyle>
             <a:lvl1pPr marL="0" indent="0">
               <a:buNone/>
-              <a:defRPr sz="1595">
+              <a:defRPr sz="2835">
                 <a:solidFill>
                   <a:schemeClr val="tx1"/>
                 </a:solidFill>
               </a:defRPr>
             </a:lvl1pPr>
-            <a:lvl2pPr marL="405130" indent="0">
+            <a:lvl2pPr marL="720090" indent="0">
               <a:buNone/>
-              <a:defRPr sz="1770">
+              <a:defRPr sz="3145">
                 <a:solidFill>
                   <a:schemeClr val="tx1">
                     <a:tint val="75000"/>
@@ -6943,9 +6991,9 @@
                 </a:solidFill>
               </a:defRPr>
             </a:lvl2pPr>
-            <a:lvl3pPr marL="810260" indent="0">
+            <a:lvl3pPr marL="1440815" indent="0">
               <a:buNone/>
-              <a:defRPr sz="1595">
+              <a:defRPr sz="2835">
                 <a:solidFill>
                   <a:schemeClr val="tx1">
                     <a:tint val="75000"/>
@@ -6953,9 +7001,9 @@
                 </a:solidFill>
               </a:defRPr>
             </a:lvl3pPr>
-            <a:lvl4pPr marL="1214755" indent="0">
+            <a:lvl4pPr marL="2159635" indent="0">
               <a:buNone/>
-              <a:defRPr sz="1420">
+              <a:defRPr sz="2525">
                 <a:solidFill>
                   <a:schemeClr val="tx1">
                     <a:tint val="75000"/>
@@ -6963,9 +7011,9 @@
                 </a:solidFill>
               </a:defRPr>
             </a:lvl4pPr>
-            <a:lvl5pPr marL="1620520" indent="0">
+            <a:lvl5pPr marL="2880995" indent="0">
               <a:buNone/>
-              <a:defRPr sz="1420">
+              <a:defRPr sz="2525">
                 <a:solidFill>
                   <a:schemeClr val="tx1">
                     <a:tint val="75000"/>
@@ -6973,9 +7021,9 @@
                 </a:solidFill>
               </a:defRPr>
             </a:lvl5pPr>
-            <a:lvl6pPr marL="2025015" indent="0">
+            <a:lvl6pPr marL="3600450" indent="0">
               <a:buNone/>
-              <a:defRPr sz="1420">
+              <a:defRPr sz="2525">
                 <a:solidFill>
                   <a:schemeClr val="tx1">
                     <a:tint val="75000"/>
@@ -6983,9 +7031,9 @@
                 </a:solidFill>
               </a:defRPr>
             </a:lvl6pPr>
-            <a:lvl7pPr marL="2430145" indent="0">
+            <a:lvl7pPr marL="4320540" indent="0">
               <a:buNone/>
-              <a:defRPr sz="1420">
+              <a:defRPr sz="2525">
                 <a:solidFill>
                   <a:schemeClr val="tx1">
                     <a:tint val="75000"/>
@@ -6993,9 +7041,9 @@
                 </a:solidFill>
               </a:defRPr>
             </a:lvl7pPr>
-            <a:lvl8pPr marL="2835275" indent="0">
+            <a:lvl8pPr marL="5040630" indent="0">
               <a:buNone/>
-              <a:defRPr sz="1420">
+              <a:defRPr sz="2525">
                 <a:solidFill>
                   <a:schemeClr val="tx1">
                     <a:tint val="75000"/>
@@ -7003,9 +7051,9 @@
                 </a:solidFill>
               </a:defRPr>
             </a:lvl8pPr>
-            <a:lvl9pPr marL="3240405" indent="0">
+            <a:lvl9pPr marL="5761355" indent="0">
               <a:buNone/>
-              <a:defRPr sz="1420">
+              <a:defRPr sz="2525">
                 <a:solidFill>
                   <a:schemeClr val="tx1">
                     <a:tint val="75000"/>
@@ -7124,8 +7172,8 @@
         </p:nvSpPr>
         <p:spPr>
           <a:xfrm>
-            <a:off x="430316" y="542705"/>
-            <a:ext cx="6986301" cy="2783533"/>
+            <a:off x="765061" y="542709"/>
+            <a:ext cx="12420973" cy="2783553"/>
           </a:xfrm>
         </p:spPr>
         <p:txBody>
@@ -7134,7 +7182,7 @@
           </a:bodyPr>
           <a:lstStyle>
             <a:lvl1pPr>
-              <a:defRPr sz="2125" b="1" i="0">
+              <a:defRPr sz="3780" b="1" i="0">
                 <a:effectLst>
                   <a:outerShdw blurRad="38100" dist="38100" dir="2700000" algn="tl">
                     <a:srgbClr val="000000">
@@ -7166,8 +7214,8 @@
         </p:nvSpPr>
         <p:spPr>
           <a:xfrm>
-            <a:off x="430316" y="3833606"/>
-            <a:ext cx="3442525" cy="9137317"/>
+            <a:off x="765061" y="3833634"/>
+            <a:ext cx="6120479" cy="9137384"/>
           </a:xfrm>
         </p:spPr>
         <p:txBody>
@@ -7179,7 +7227,7 @@
               <a:lnSpc>
                 <a:spcPct val="150000"/>
               </a:lnSpc>
-              <a:defRPr sz="1770">
+              <a:defRPr sz="3145">
                 <a:solidFill>
                   <a:schemeClr val="tx1">
                     <a:lumMod val="75000"/>
@@ -7192,7 +7240,7 @@
               <a:lnSpc>
                 <a:spcPct val="150000"/>
               </a:lnSpc>
-              <a:defRPr sz="1595">
+              <a:defRPr sz="2835">
                 <a:solidFill>
                   <a:schemeClr val="tx1">
                     <a:lumMod val="75000"/>
@@ -7205,7 +7253,7 @@
               <a:lnSpc>
                 <a:spcPct val="150000"/>
               </a:lnSpc>
-              <a:defRPr sz="1420">
+              <a:defRPr sz="2525">
                 <a:solidFill>
                   <a:schemeClr val="tx1">
                     <a:lumMod val="75000"/>
@@ -7218,7 +7266,7 @@
               <a:lnSpc>
                 <a:spcPct val="150000"/>
               </a:lnSpc>
-              <a:defRPr sz="1420">
+              <a:defRPr sz="2525">
                 <a:solidFill>
                   <a:schemeClr val="tx1">
                     <a:lumMod val="75000"/>
@@ -7231,7 +7279,7 @@
               <a:lnSpc>
                 <a:spcPct val="150000"/>
               </a:lnSpc>
-              <a:defRPr sz="1420">
+              <a:defRPr sz="2525">
                 <a:solidFill>
                   <a:schemeClr val="tx1">
                     <a:lumMod val="75000"/>
@@ -7295,8 +7343,8 @@
         </p:nvSpPr>
         <p:spPr>
           <a:xfrm>
-            <a:off x="3974092" y="3833606"/>
-            <a:ext cx="3442525" cy="9137317"/>
+            <a:off x="7065554" y="3833634"/>
+            <a:ext cx="6120479" cy="9137384"/>
           </a:xfrm>
         </p:spPr>
         <p:txBody>
@@ -7308,7 +7356,7 @@
               <a:lnSpc>
                 <a:spcPct val="150000"/>
               </a:lnSpc>
-              <a:defRPr sz="1770">
+              <a:defRPr sz="3145">
                 <a:solidFill>
                   <a:schemeClr val="tx1">
                     <a:lumMod val="75000"/>
@@ -7321,7 +7369,7 @@
               <a:lnSpc>
                 <a:spcPct val="150000"/>
               </a:lnSpc>
-              <a:defRPr sz="1595">
+              <a:defRPr sz="2835">
                 <a:solidFill>
                   <a:schemeClr val="tx1">
                     <a:lumMod val="75000"/>
@@ -7334,7 +7382,7 @@
               <a:lnSpc>
                 <a:spcPct val="150000"/>
               </a:lnSpc>
-              <a:defRPr sz="1420">
+              <a:defRPr sz="2525">
                 <a:solidFill>
                   <a:schemeClr val="tx1">
                     <a:lumMod val="75000"/>
@@ -7347,7 +7395,7 @@
               <a:lnSpc>
                 <a:spcPct val="150000"/>
               </a:lnSpc>
-              <a:defRPr sz="1420">
+              <a:defRPr sz="2525">
                 <a:solidFill>
                   <a:schemeClr val="tx1">
                     <a:lumMod val="75000"/>
@@ -7360,7 +7408,7 @@
               <a:lnSpc>
                 <a:spcPct val="150000"/>
               </a:lnSpc>
-              <a:defRPr sz="1420">
+              <a:defRPr sz="2525">
                 <a:solidFill>
                   <a:schemeClr val="tx1">
                     <a:lumMod val="75000"/>
@@ -7512,8 +7560,8 @@
         </p:nvSpPr>
         <p:spPr>
           <a:xfrm>
-            <a:off x="557934" y="766721"/>
-            <a:ext cx="6986301" cy="2783533"/>
+            <a:off x="991953" y="766727"/>
+            <a:ext cx="12420973" cy="2783553"/>
           </a:xfrm>
         </p:spPr>
         <p:txBody>
@@ -7540,8 +7588,8 @@
         </p:nvSpPr>
         <p:spPr>
           <a:xfrm>
-            <a:off x="557934" y="3664221"/>
-            <a:ext cx="3426705" cy="1730121"/>
+            <a:off x="991953" y="3664248"/>
+            <a:ext cx="6092353" cy="1730134"/>
           </a:xfrm>
         </p:spPr>
         <p:txBody>
@@ -7549,39 +7597,39 @@
           <a:lstStyle>
             <a:lvl1pPr marL="0" indent="0">
               <a:buNone/>
-              <a:defRPr sz="2125" b="1"/>
+              <a:defRPr sz="3780" b="1"/>
             </a:lvl1pPr>
-            <a:lvl2pPr marL="405130" indent="0">
+            <a:lvl2pPr marL="720090" indent="0">
               <a:buNone/>
-              <a:defRPr sz="1770" b="1"/>
+              <a:defRPr sz="3145" b="1"/>
             </a:lvl2pPr>
-            <a:lvl3pPr marL="810260" indent="0">
+            <a:lvl3pPr marL="1440815" indent="0">
               <a:buNone/>
-              <a:defRPr sz="1595" b="1"/>
+              <a:defRPr sz="2835" b="1"/>
             </a:lvl3pPr>
-            <a:lvl4pPr marL="1214755" indent="0">
+            <a:lvl4pPr marL="2159635" indent="0">
               <a:buNone/>
-              <a:defRPr sz="1420" b="1"/>
+              <a:defRPr sz="2525" b="1"/>
             </a:lvl4pPr>
-            <a:lvl5pPr marL="1620520" indent="0">
+            <a:lvl5pPr marL="2880995" indent="0">
               <a:buNone/>
-              <a:defRPr sz="1420" b="1"/>
+              <a:defRPr sz="2525" b="1"/>
             </a:lvl5pPr>
-            <a:lvl6pPr marL="2025015" indent="0">
+            <a:lvl6pPr marL="3600450" indent="0">
               <a:buNone/>
-              <a:defRPr sz="1420" b="1"/>
+              <a:defRPr sz="2525" b="1"/>
             </a:lvl6pPr>
-            <a:lvl7pPr marL="2430145" indent="0">
+            <a:lvl7pPr marL="4320540" indent="0">
               <a:buNone/>
-              <a:defRPr sz="1420" b="1"/>
+              <a:defRPr sz="2525" b="1"/>
             </a:lvl7pPr>
-            <a:lvl8pPr marL="2835275" indent="0">
+            <a:lvl8pPr marL="5040630" indent="0">
               <a:buNone/>
-              <a:defRPr sz="1420" b="1"/>
+              <a:defRPr sz="2525" b="1"/>
             </a:lvl8pPr>
-            <a:lvl9pPr marL="3240405" indent="0">
+            <a:lvl9pPr marL="5761355" indent="0">
               <a:buNone/>
-              <a:defRPr sz="1420" b="1"/>
+              <a:defRPr sz="2525" b="1"/>
             </a:lvl9pPr>
           </a:lstStyle>
           <a:p>
@@ -7606,8 +7654,8 @@
         </p:nvSpPr>
         <p:spPr>
           <a:xfrm>
-            <a:off x="557934" y="5492483"/>
-            <a:ext cx="3426705" cy="7505109"/>
+            <a:off x="991953" y="5492523"/>
+            <a:ext cx="6092353" cy="7505164"/>
           </a:xfrm>
         </p:spPr>
         <p:txBody>
@@ -7667,8 +7715,8 @@
         </p:nvSpPr>
         <p:spPr>
           <a:xfrm>
-            <a:off x="4100655" y="3664221"/>
-            <a:ext cx="3443581" cy="1730121"/>
+            <a:off x="7290571" y="3664248"/>
+            <a:ext cx="6122357" cy="1730134"/>
           </a:xfrm>
         </p:spPr>
         <p:txBody>
@@ -7676,39 +7724,39 @@
           <a:lstStyle>
             <a:lvl1pPr marL="0" indent="0">
               <a:buNone/>
-              <a:defRPr sz="2125" b="1"/>
+              <a:defRPr sz="3780" b="1"/>
             </a:lvl1pPr>
-            <a:lvl2pPr marL="405130" indent="0">
+            <a:lvl2pPr marL="720090" indent="0">
               <a:buNone/>
-              <a:defRPr sz="1770" b="1"/>
+              <a:defRPr sz="3145" b="1"/>
             </a:lvl2pPr>
-            <a:lvl3pPr marL="810260" indent="0">
+            <a:lvl3pPr marL="1440815" indent="0">
               <a:buNone/>
-              <a:defRPr sz="1595" b="1"/>
+              <a:defRPr sz="2835" b="1"/>
             </a:lvl3pPr>
-            <a:lvl4pPr marL="1214755" indent="0">
+            <a:lvl4pPr marL="2159635" indent="0">
               <a:buNone/>
-              <a:defRPr sz="1420" b="1"/>
+              <a:defRPr sz="2525" b="1"/>
             </a:lvl4pPr>
-            <a:lvl5pPr marL="1620520" indent="0">
+            <a:lvl5pPr marL="2880995" indent="0">
               <a:buNone/>
-              <a:defRPr sz="1420" b="1"/>
+              <a:defRPr sz="2525" b="1"/>
             </a:lvl5pPr>
-            <a:lvl6pPr marL="2025015" indent="0">
+            <a:lvl6pPr marL="3600450" indent="0">
               <a:buNone/>
-              <a:defRPr sz="1420" b="1"/>
+              <a:defRPr sz="2525" b="1"/>
             </a:lvl6pPr>
-            <a:lvl7pPr marL="2430145" indent="0">
+            <a:lvl7pPr marL="4320540" indent="0">
               <a:buNone/>
-              <a:defRPr sz="1420" b="1"/>
+              <a:defRPr sz="2525" b="1"/>
             </a:lvl7pPr>
-            <a:lvl8pPr marL="2835275" indent="0">
+            <a:lvl8pPr marL="5040630" indent="0">
               <a:buNone/>
-              <a:defRPr sz="1420" b="1"/>
+              <a:defRPr sz="2525" b="1"/>
             </a:lvl8pPr>
-            <a:lvl9pPr marL="3240405" indent="0">
+            <a:lvl9pPr marL="5761355" indent="0">
               <a:buNone/>
-              <a:defRPr sz="1420" b="1"/>
+              <a:defRPr sz="2525" b="1"/>
             </a:lvl9pPr>
           </a:lstStyle>
           <a:p>
@@ -7733,8 +7781,8 @@
         </p:nvSpPr>
         <p:spPr>
           <a:xfrm>
-            <a:off x="4100655" y="5492483"/>
-            <a:ext cx="3443581" cy="7505109"/>
+            <a:off x="7290571" y="5492523"/>
+            <a:ext cx="6122357" cy="7505164"/>
           </a:xfrm>
         </p:spPr>
         <p:txBody>
@@ -7882,8 +7930,8 @@
         </p:nvSpPr>
         <p:spPr>
           <a:xfrm>
-            <a:off x="556879" y="5808747"/>
-            <a:ext cx="6986301" cy="2783533"/>
+            <a:off x="990077" y="5808790"/>
+            <a:ext cx="12420973" cy="2783553"/>
           </a:xfrm>
         </p:spPr>
         <p:txBody>
@@ -7892,7 +7940,7 @@
           </a:bodyPr>
           <a:lstStyle>
             <a:lvl1pPr algn="ctr">
-              <a:defRPr sz="4255" b="0">
+              <a:defRPr sz="7565" b="0">
                 <a:effectLst>
                   <a:outerShdw blurRad="38100" dist="38100" dir="2700000" algn="tl">
                     <a:srgbClr val="000000">
@@ -8100,8 +8148,8 @@
         </p:nvSpPr>
         <p:spPr>
           <a:xfrm>
-            <a:off x="429682" y="266686"/>
-            <a:ext cx="2767255" cy="3360239"/>
+            <a:off x="763933" y="266688"/>
+            <a:ext cx="4919914" cy="3360264"/>
           </a:xfrm>
         </p:spPr>
         <p:txBody>
@@ -8110,7 +8158,7 @@
           </a:bodyPr>
           <a:lstStyle>
             <a:lvl1pPr>
-              <a:defRPr sz="2125" b="1">
+              <a:defRPr sz="3780" b="1">
                 <a:effectLst>
                   <a:outerShdw blurRad="38100" dist="38100" dir="2700000" algn="tl">
                     <a:srgbClr val="000000">
@@ -8142,8 +8190,8 @@
         </p:nvSpPr>
         <p:spPr>
           <a:xfrm>
-            <a:off x="3444120" y="1609257"/>
-            <a:ext cx="3864919" cy="10697761"/>
+            <a:off x="6123315" y="1609269"/>
+            <a:ext cx="6871455" cy="10697839"/>
           </a:xfrm>
         </p:spPr>
         <p:txBody>
@@ -8151,39 +8199,39 @@
           <a:lstStyle>
             <a:lvl1pPr marL="0" indent="0">
               <a:buNone/>
-              <a:defRPr sz="2835"/>
+              <a:defRPr sz="5040"/>
             </a:lvl1pPr>
-            <a:lvl2pPr marL="405130" indent="0">
+            <a:lvl2pPr marL="720090" indent="0">
               <a:buNone/>
-              <a:defRPr sz="2480"/>
+              <a:defRPr sz="4410"/>
             </a:lvl2pPr>
-            <a:lvl3pPr marL="810260" indent="0">
+            <a:lvl3pPr marL="1440815" indent="0">
               <a:buNone/>
-              <a:defRPr sz="2125"/>
+              <a:defRPr sz="3780"/>
             </a:lvl3pPr>
-            <a:lvl4pPr marL="1214755" indent="0">
+            <a:lvl4pPr marL="2159635" indent="0">
               <a:buNone/>
-              <a:defRPr sz="1770"/>
+              <a:defRPr sz="3145"/>
             </a:lvl4pPr>
-            <a:lvl5pPr marL="1620520" indent="0">
+            <a:lvl5pPr marL="2880995" indent="0">
               <a:buNone/>
-              <a:defRPr sz="1770"/>
+              <a:defRPr sz="3145"/>
             </a:lvl5pPr>
-            <a:lvl6pPr marL="2025015" indent="0">
+            <a:lvl6pPr marL="3600450" indent="0">
               <a:buNone/>
-              <a:defRPr sz="1770"/>
+              <a:defRPr sz="3145"/>
             </a:lvl6pPr>
-            <a:lvl7pPr marL="2430145" indent="0">
+            <a:lvl7pPr marL="4320540" indent="0">
               <a:buNone/>
-              <a:defRPr sz="1770"/>
+              <a:defRPr sz="3145"/>
             </a:lvl7pPr>
-            <a:lvl8pPr marL="2835275" indent="0">
+            <a:lvl8pPr marL="5040630" indent="0">
               <a:buNone/>
-              <a:defRPr sz="1770"/>
+              <a:defRPr sz="3145"/>
             </a:lvl8pPr>
-            <a:lvl9pPr marL="3240405" indent="0">
+            <a:lvl9pPr marL="5761355" indent="0">
               <a:buNone/>
-              <a:defRPr sz="1770"/>
+              <a:defRPr sz="3145"/>
             </a:lvl9pPr>
           </a:lstStyle>
           <a:p>
@@ -8203,8 +8251,8 @@
         </p:nvSpPr>
         <p:spPr>
           <a:xfrm>
-            <a:off x="433057" y="4320307"/>
-            <a:ext cx="2767255" cy="8003904"/>
+            <a:off x="769934" y="4320339"/>
+            <a:ext cx="4919914" cy="8003963"/>
           </a:xfrm>
         </p:spPr>
         <p:txBody>
@@ -8217,39 +8265,39 @@
                 <a:spcPct val="150000"/>
               </a:lnSpc>
               <a:buNone/>
-              <a:defRPr sz="1420"/>
+              <a:defRPr sz="2525"/>
             </a:lvl1pPr>
-            <a:lvl2pPr marL="405130" indent="0">
+            <a:lvl2pPr marL="720090" indent="0">
               <a:buNone/>
-              <a:defRPr sz="1240"/>
+              <a:defRPr sz="2205"/>
             </a:lvl2pPr>
-            <a:lvl3pPr marL="810260" indent="0">
+            <a:lvl3pPr marL="1440815" indent="0">
               <a:buNone/>
-              <a:defRPr sz="1060"/>
+              <a:defRPr sz="1885"/>
             </a:lvl3pPr>
-            <a:lvl4pPr marL="1214755" indent="0">
+            <a:lvl4pPr marL="2159635" indent="0">
               <a:buNone/>
-              <a:defRPr sz="885"/>
+              <a:defRPr sz="1575"/>
             </a:lvl4pPr>
-            <a:lvl5pPr marL="1620520" indent="0">
+            <a:lvl5pPr marL="2880995" indent="0">
               <a:buNone/>
-              <a:defRPr sz="885"/>
+              <a:defRPr sz="1575"/>
             </a:lvl5pPr>
-            <a:lvl6pPr marL="2025015" indent="0">
+            <a:lvl6pPr marL="3600450" indent="0">
               <a:buNone/>
-              <a:defRPr sz="885"/>
+              <a:defRPr sz="1575"/>
             </a:lvl6pPr>
-            <a:lvl7pPr marL="2430145" indent="0">
+            <a:lvl7pPr marL="4320540" indent="0">
               <a:buNone/>
-              <a:defRPr sz="885"/>
+              <a:defRPr sz="1575"/>
             </a:lvl7pPr>
-            <a:lvl8pPr marL="2835275" indent="0">
+            <a:lvl8pPr marL="5040630" indent="0">
               <a:buNone/>
-              <a:defRPr sz="885"/>
+              <a:defRPr sz="1575"/>
             </a:lvl8pPr>
-            <a:lvl9pPr marL="3240405" indent="0">
+            <a:lvl9pPr marL="5761355" indent="0">
               <a:buNone/>
-              <a:defRPr sz="885"/>
+              <a:defRPr sz="1575"/>
             </a:lvl9pPr>
           </a:lstStyle>
           <a:p>
@@ -8362,8 +8410,8 @@
         </p:nvSpPr>
         <p:spPr>
           <a:xfrm>
-            <a:off x="6527142" y="766721"/>
-            <a:ext cx="1016039" cy="12204202"/>
+            <a:off x="11604632" y="766727"/>
+            <a:ext cx="1806420" cy="12204291"/>
           </a:xfrm>
         </p:spPr>
         <p:txBody>
@@ -8372,7 +8420,7 @@
           </a:bodyPr>
           <a:lstStyle>
             <a:lvl1pPr>
-              <a:defRPr sz="3190"/>
+              <a:defRPr sz="5670"/>
             </a:lvl1pPr>
           </a:lstStyle>
           <a:p>
@@ -8396,8 +8444,8 @@
         </p:nvSpPr>
         <p:spPr>
           <a:xfrm>
-            <a:off x="556879" y="766721"/>
-            <a:ext cx="5899622" cy="12204202"/>
+            <a:off x="990077" y="766727"/>
+            <a:ext cx="10488962" cy="12204291"/>
           </a:xfrm>
         </p:spPr>
         <p:txBody>
@@ -8553,8 +8601,8 @@
         </p:nvSpPr>
         <p:spPr>
           <a:xfrm>
-            <a:off x="556879" y="766721"/>
-            <a:ext cx="6986301" cy="2783533"/>
+            <a:off x="990077" y="766727"/>
+            <a:ext cx="12420973" cy="2783553"/>
           </a:xfrm>
           <a:prstGeom prst="rect">
             <a:avLst/>
@@ -8586,8 +8634,8 @@
         </p:nvSpPr>
         <p:spPr>
           <a:xfrm>
-            <a:off x="556879" y="3833606"/>
-            <a:ext cx="6986301" cy="9137317"/>
+            <a:off x="990077" y="3833634"/>
+            <a:ext cx="12420973" cy="9137384"/>
           </a:xfrm>
           <a:prstGeom prst="rect">
             <a:avLst/>
@@ -8652,8 +8700,8 @@
         </p:nvSpPr>
         <p:spPr>
           <a:xfrm>
-            <a:off x="556879" y="13347615"/>
-            <a:ext cx="1822513" cy="766721"/>
+            <a:off x="990077" y="13347713"/>
+            <a:ext cx="3240253" cy="766727"/>
           </a:xfrm>
           <a:prstGeom prst="rect">
             <a:avLst/>
@@ -8665,7 +8713,7 @@
           </a:bodyPr>
           <a:lstStyle>
             <a:lvl1pPr algn="l">
-              <a:defRPr sz="1060">
+              <a:defRPr sz="1885">
                 <a:solidFill>
                   <a:schemeClr val="tx1">
                     <a:tint val="75000"/>
@@ -8696,8 +8744,8 @@
         </p:nvSpPr>
         <p:spPr>
           <a:xfrm>
-            <a:off x="2683145" y="13347615"/>
-            <a:ext cx="2733770" cy="766721"/>
+            <a:off x="4770374" y="13347713"/>
+            <a:ext cx="4860381" cy="766727"/>
           </a:xfrm>
           <a:prstGeom prst="rect">
             <a:avLst/>
@@ -8709,7 +8757,7 @@
           </a:bodyPr>
           <a:lstStyle>
             <a:lvl1pPr algn="ctr">
-              <a:defRPr sz="1060">
+              <a:defRPr sz="1885">
                 <a:solidFill>
                   <a:schemeClr val="tx1">
                     <a:tint val="75000"/>
@@ -8737,8 +8785,8 @@
         </p:nvSpPr>
         <p:spPr>
           <a:xfrm>
-            <a:off x="5720667" y="13347615"/>
-            <a:ext cx="1822513" cy="766721"/>
+            <a:off x="10170797" y="13347713"/>
+            <a:ext cx="3240253" cy="766727"/>
           </a:xfrm>
           <a:prstGeom prst="rect">
             <a:avLst/>
@@ -8750,7 +8798,7 @@
           </a:bodyPr>
           <a:lstStyle>
             <a:lvl1pPr algn="r">
-              <a:defRPr sz="1060">
+              <a:defRPr sz="1885">
                 <a:solidFill>
                   <a:schemeClr val="tx1">
                     <a:tint val="75000"/>
@@ -8786,7 +8834,7 @@
   </p:sldLayoutIdLst>
   <p:txStyles>
     <p:titleStyle>
-      <a:lvl1pPr algn="l" defTabSz="810260" rtl="0" eaLnBrk="1" latinLnBrk="0" hangingPunct="1">
+      <a:lvl1pPr algn="l" defTabSz="1440815" rtl="0" eaLnBrk="1" latinLnBrk="0" hangingPunct="1">
         <a:lnSpc>
           <a:spcPct val="90000"/>
         </a:lnSpc>
@@ -8794,7 +8842,7 @@
           <a:spcPct val="0"/>
         </a:spcBef>
         <a:buNone/>
-        <a:defRPr sz="3545" kern="1200">
+        <a:defRPr sz="6305" kern="1200">
           <a:solidFill>
             <a:schemeClr val="tx1"/>
           </a:solidFill>
@@ -8805,16 +8853,16 @@
       </a:lvl1pPr>
     </p:titleStyle>
     <p:bodyStyle>
-      <a:lvl1pPr marL="202565" indent="-202565" algn="l" defTabSz="810260" rtl="0" eaLnBrk="1" latinLnBrk="0" hangingPunct="1">
+      <a:lvl1pPr marL="360045" indent="-360045" algn="l" defTabSz="1440815" rtl="0" eaLnBrk="1" latinLnBrk="0" hangingPunct="1">
         <a:lnSpc>
           <a:spcPct val="90000"/>
         </a:lnSpc>
         <a:spcBef>
-          <a:spcPts val="885"/>
+          <a:spcPts val="1575"/>
         </a:spcBef>
         <a:buFont typeface="Arial" panose="020B0604020202020204" pitchFamily="34" charset="0"/>
         <a:buChar char="•"/>
-        <a:defRPr sz="2125" kern="1200">
+        <a:defRPr sz="3780" kern="1200">
           <a:solidFill>
             <a:schemeClr val="tx1"/>
           </a:solidFill>
@@ -8823,16 +8871,16 @@
           <a:cs typeface="+mn-cs"/>
         </a:defRPr>
       </a:lvl1pPr>
-      <a:lvl2pPr marL="607695" indent="-202565" algn="l" defTabSz="810260" rtl="0" eaLnBrk="1" latinLnBrk="0" hangingPunct="1">
+      <a:lvl2pPr marL="1080135" indent="-360045" algn="l" defTabSz="1440815" rtl="0" eaLnBrk="1" latinLnBrk="0" hangingPunct="1">
         <a:lnSpc>
           <a:spcPct val="90000"/>
         </a:lnSpc>
         <a:spcBef>
-          <a:spcPct val="89000"/>
+          <a:spcPct val="158000"/>
         </a:spcBef>
         <a:buFont typeface="Arial" panose="020B0604020202020204" pitchFamily="34" charset="0"/>
         <a:buChar char="•"/>
-        <a:defRPr sz="1770" kern="1200">
+        <a:defRPr sz="3145" kern="1200">
           <a:solidFill>
             <a:schemeClr val="tx1"/>
           </a:solidFill>
@@ -8841,16 +8889,16 @@
           <a:cs typeface="+mn-cs"/>
         </a:defRPr>
       </a:lvl2pPr>
-      <a:lvl3pPr marL="1012825" indent="-202565" algn="l" defTabSz="810260" rtl="0" eaLnBrk="1" latinLnBrk="0" hangingPunct="1">
+      <a:lvl3pPr marL="1800860" indent="-360045" algn="l" defTabSz="1440815" rtl="0" eaLnBrk="1" latinLnBrk="0" hangingPunct="1">
         <a:lnSpc>
           <a:spcPct val="90000"/>
         </a:lnSpc>
         <a:spcBef>
-          <a:spcPct val="89000"/>
+          <a:spcPct val="158000"/>
         </a:spcBef>
         <a:buFont typeface="Arial" panose="020B0604020202020204" pitchFamily="34" charset="0"/>
         <a:buChar char="•"/>
-        <a:defRPr sz="1595" kern="1200">
+        <a:defRPr sz="2835" kern="1200">
           <a:solidFill>
             <a:schemeClr val="tx1"/>
           </a:solidFill>
@@ -8859,16 +8907,16 @@
           <a:cs typeface="+mn-cs"/>
         </a:defRPr>
       </a:lvl3pPr>
-      <a:lvl4pPr marL="1417320" indent="-202565" algn="l" defTabSz="810260" rtl="0" eaLnBrk="1" latinLnBrk="0" hangingPunct="1">
+      <a:lvl4pPr marL="2519680" indent="-360045" algn="l" defTabSz="1440815" rtl="0" eaLnBrk="1" latinLnBrk="0" hangingPunct="1">
         <a:lnSpc>
           <a:spcPct val="90000"/>
         </a:lnSpc>
         <a:spcBef>
-          <a:spcPct val="89000"/>
+          <a:spcPct val="158000"/>
         </a:spcBef>
         <a:buFont typeface="Arial" panose="020B0604020202020204" pitchFamily="34" charset="0"/>
         <a:buChar char="•"/>
-        <a:defRPr sz="1595" kern="1200">
+        <a:defRPr sz="2835" kern="1200">
           <a:solidFill>
             <a:schemeClr val="tx1"/>
           </a:solidFill>
@@ -8877,16 +8925,16 @@
           <a:cs typeface="+mn-cs"/>
         </a:defRPr>
       </a:lvl4pPr>
-      <a:lvl5pPr marL="1822450" indent="-202565" algn="l" defTabSz="810260" rtl="0" eaLnBrk="1" latinLnBrk="0" hangingPunct="1">
+      <a:lvl5pPr marL="3240405" indent="-360045" algn="l" defTabSz="1440815" rtl="0" eaLnBrk="1" latinLnBrk="0" hangingPunct="1">
         <a:lnSpc>
           <a:spcPct val="90000"/>
         </a:lnSpc>
         <a:spcBef>
-          <a:spcPct val="89000"/>
+          <a:spcPct val="158000"/>
         </a:spcBef>
         <a:buFont typeface="Arial" panose="020B0604020202020204" pitchFamily="34" charset="0"/>
         <a:buChar char="•"/>
-        <a:defRPr sz="1595" kern="1200">
+        <a:defRPr sz="2835" kern="1200">
           <a:solidFill>
             <a:schemeClr val="tx1"/>
           </a:solidFill>
@@ -8895,16 +8943,16 @@
           <a:cs typeface="+mn-cs"/>
         </a:defRPr>
       </a:lvl5pPr>
-      <a:lvl6pPr marL="2227580" indent="-202565" algn="l" defTabSz="810260" rtl="0" eaLnBrk="1" latinLnBrk="0" hangingPunct="1">
+      <a:lvl6pPr marL="3960495" indent="-360045" algn="l" defTabSz="1440815" rtl="0" eaLnBrk="1" latinLnBrk="0" hangingPunct="1">
         <a:lnSpc>
           <a:spcPct val="90000"/>
         </a:lnSpc>
         <a:spcBef>
-          <a:spcPct val="89000"/>
+          <a:spcPct val="158000"/>
         </a:spcBef>
         <a:buFont typeface="Arial" panose="020B0604020202020204" pitchFamily="34" charset="0"/>
         <a:buChar char="•"/>
-        <a:defRPr sz="1595" kern="1200">
+        <a:defRPr sz="2835" kern="1200">
           <a:solidFill>
             <a:schemeClr val="tx1"/>
           </a:solidFill>
@@ -8913,16 +8961,16 @@
           <a:cs typeface="+mn-cs"/>
         </a:defRPr>
       </a:lvl6pPr>
-      <a:lvl7pPr marL="2632710" indent="-202565" algn="l" defTabSz="810260" rtl="0" eaLnBrk="1" latinLnBrk="0" hangingPunct="1">
+      <a:lvl7pPr marL="4680585" indent="-360045" algn="l" defTabSz="1440815" rtl="0" eaLnBrk="1" latinLnBrk="0" hangingPunct="1">
         <a:lnSpc>
           <a:spcPct val="90000"/>
         </a:lnSpc>
         <a:spcBef>
-          <a:spcPct val="89000"/>
+          <a:spcPct val="158000"/>
         </a:spcBef>
         <a:buFont typeface="Arial" panose="020B0604020202020204" pitchFamily="34" charset="0"/>
         <a:buChar char="•"/>
-        <a:defRPr sz="1595" kern="1200">
+        <a:defRPr sz="2835" kern="1200">
           <a:solidFill>
             <a:schemeClr val="tx1"/>
           </a:solidFill>
@@ -8931,16 +8979,16 @@
           <a:cs typeface="+mn-cs"/>
         </a:defRPr>
       </a:lvl7pPr>
-      <a:lvl8pPr marL="3037840" indent="-202565" algn="l" defTabSz="810260" rtl="0" eaLnBrk="1" latinLnBrk="0" hangingPunct="1">
+      <a:lvl8pPr marL="5400675" indent="-360045" algn="l" defTabSz="1440815" rtl="0" eaLnBrk="1" latinLnBrk="0" hangingPunct="1">
         <a:lnSpc>
           <a:spcPct val="90000"/>
         </a:lnSpc>
         <a:spcBef>
-          <a:spcPct val="89000"/>
+          <a:spcPct val="158000"/>
         </a:spcBef>
         <a:buFont typeface="Arial" panose="020B0604020202020204" pitchFamily="34" charset="0"/>
         <a:buChar char="•"/>
-        <a:defRPr sz="1595" kern="1200">
+        <a:defRPr sz="2835" kern="1200">
           <a:solidFill>
             <a:schemeClr val="tx1"/>
           </a:solidFill>
@@ -8949,16 +8997,16 @@
           <a:cs typeface="+mn-cs"/>
         </a:defRPr>
       </a:lvl8pPr>
-      <a:lvl9pPr marL="3442335" indent="-202565" algn="l" defTabSz="810260" rtl="0" eaLnBrk="1" latinLnBrk="0" hangingPunct="1">
+      <a:lvl9pPr marL="6120130" indent="-360045" algn="l" defTabSz="1440815" rtl="0" eaLnBrk="1" latinLnBrk="0" hangingPunct="1">
         <a:lnSpc>
           <a:spcPct val="90000"/>
         </a:lnSpc>
         <a:spcBef>
-          <a:spcPct val="89000"/>
+          <a:spcPct val="158000"/>
         </a:spcBef>
         <a:buFont typeface="Arial" panose="020B0604020202020204" pitchFamily="34" charset="0"/>
         <a:buChar char="•"/>
-        <a:defRPr sz="1595" kern="1200">
+        <a:defRPr sz="2835" kern="1200">
           <a:solidFill>
             <a:schemeClr val="tx1"/>
           </a:solidFill>
@@ -8972,8 +9020,8 @@
       <a:defPPr>
         <a:defRPr lang="zh-CN"/>
       </a:defPPr>
-      <a:lvl1pPr marL="0" algn="l" defTabSz="810260" rtl="0" eaLnBrk="1" latinLnBrk="0" hangingPunct="1">
-        <a:defRPr sz="1595" kern="1200">
+      <a:lvl1pPr marL="0" algn="l" defTabSz="1440815" rtl="0" eaLnBrk="1" latinLnBrk="0" hangingPunct="1">
+        <a:defRPr sz="2835" kern="1200">
           <a:solidFill>
             <a:schemeClr val="tx1"/>
           </a:solidFill>
@@ -8982,8 +9030,8 @@
           <a:cs typeface="+mn-cs"/>
         </a:defRPr>
       </a:lvl1pPr>
-      <a:lvl2pPr marL="405130" algn="l" defTabSz="810260" rtl="0" eaLnBrk="1" latinLnBrk="0" hangingPunct="1">
-        <a:defRPr sz="1595" kern="1200">
+      <a:lvl2pPr marL="720090" algn="l" defTabSz="1440815" rtl="0" eaLnBrk="1" latinLnBrk="0" hangingPunct="1">
+        <a:defRPr sz="2835" kern="1200">
           <a:solidFill>
             <a:schemeClr val="tx1"/>
           </a:solidFill>
@@ -8992,8 +9040,8 @@
           <a:cs typeface="+mn-cs"/>
         </a:defRPr>
       </a:lvl2pPr>
-      <a:lvl3pPr marL="810260" algn="l" defTabSz="810260" rtl="0" eaLnBrk="1" latinLnBrk="0" hangingPunct="1">
-        <a:defRPr sz="1595" kern="1200">
+      <a:lvl3pPr marL="1440815" algn="l" defTabSz="1440815" rtl="0" eaLnBrk="1" latinLnBrk="0" hangingPunct="1">
+        <a:defRPr sz="2835" kern="1200">
           <a:solidFill>
             <a:schemeClr val="tx1"/>
           </a:solidFill>
@@ -9002,8 +9050,8 @@
           <a:cs typeface="+mn-cs"/>
         </a:defRPr>
       </a:lvl3pPr>
-      <a:lvl4pPr marL="1214755" algn="l" defTabSz="810260" rtl="0" eaLnBrk="1" latinLnBrk="0" hangingPunct="1">
-        <a:defRPr sz="1595" kern="1200">
+      <a:lvl4pPr marL="2159635" algn="l" defTabSz="1440815" rtl="0" eaLnBrk="1" latinLnBrk="0" hangingPunct="1">
+        <a:defRPr sz="2835" kern="1200">
           <a:solidFill>
             <a:schemeClr val="tx1"/>
           </a:solidFill>
@@ -9012,8 +9060,8 @@
           <a:cs typeface="+mn-cs"/>
         </a:defRPr>
       </a:lvl4pPr>
-      <a:lvl5pPr marL="1620520" algn="l" defTabSz="810260" rtl="0" eaLnBrk="1" latinLnBrk="0" hangingPunct="1">
-        <a:defRPr sz="1595" kern="1200">
+      <a:lvl5pPr marL="2880995" algn="l" defTabSz="1440815" rtl="0" eaLnBrk="1" latinLnBrk="0" hangingPunct="1">
+        <a:defRPr sz="2835" kern="1200">
           <a:solidFill>
             <a:schemeClr val="tx1"/>
           </a:solidFill>
@@ -9022,8 +9070,8 @@
           <a:cs typeface="+mn-cs"/>
         </a:defRPr>
       </a:lvl5pPr>
-      <a:lvl6pPr marL="2025015" algn="l" defTabSz="810260" rtl="0" eaLnBrk="1" latinLnBrk="0" hangingPunct="1">
-        <a:defRPr sz="1595" kern="1200">
+      <a:lvl6pPr marL="3600450" algn="l" defTabSz="1440815" rtl="0" eaLnBrk="1" latinLnBrk="0" hangingPunct="1">
+        <a:defRPr sz="2835" kern="1200">
           <a:solidFill>
             <a:schemeClr val="tx1"/>
           </a:solidFill>
@@ -9032,8 +9080,8 @@
           <a:cs typeface="+mn-cs"/>
         </a:defRPr>
       </a:lvl6pPr>
-      <a:lvl7pPr marL="2430145" algn="l" defTabSz="810260" rtl="0" eaLnBrk="1" latinLnBrk="0" hangingPunct="1">
-        <a:defRPr sz="1595" kern="1200">
+      <a:lvl7pPr marL="4320540" algn="l" defTabSz="1440815" rtl="0" eaLnBrk="1" latinLnBrk="0" hangingPunct="1">
+        <a:defRPr sz="2835" kern="1200">
           <a:solidFill>
             <a:schemeClr val="tx1"/>
           </a:solidFill>
@@ -9042,8 +9090,8 @@
           <a:cs typeface="+mn-cs"/>
         </a:defRPr>
       </a:lvl7pPr>
-      <a:lvl8pPr marL="2835275" algn="l" defTabSz="810260" rtl="0" eaLnBrk="1" latinLnBrk="0" hangingPunct="1">
-        <a:defRPr sz="1595" kern="1200">
+      <a:lvl8pPr marL="5040630" algn="l" defTabSz="1440815" rtl="0" eaLnBrk="1" latinLnBrk="0" hangingPunct="1">
+        <a:defRPr sz="2835" kern="1200">
           <a:solidFill>
             <a:schemeClr val="tx1"/>
           </a:solidFill>
@@ -9052,8 +9100,8 @@
           <a:cs typeface="+mn-cs"/>
         </a:defRPr>
       </a:lvl8pPr>
-      <a:lvl9pPr marL="3240405" algn="l" defTabSz="810260" rtl="0" eaLnBrk="1" latinLnBrk="0" hangingPunct="1">
-        <a:defRPr sz="1595" kern="1200">
+      <a:lvl9pPr marL="5761355" algn="l" defTabSz="1440815" rtl="0" eaLnBrk="1" latinLnBrk="0" hangingPunct="1">
+        <a:defRPr sz="2835" kern="1200">
           <a:solidFill>
             <a:schemeClr val="tx1"/>
           </a:solidFill>
@@ -9092,8 +9140,8 @@
         </p:nvGrpSpPr>
         <p:grpSpPr>
           <a:xfrm>
-            <a:off x="1085709" y="5437071"/>
-            <a:ext cx="5898638" cy="3612621"/>
+            <a:off x="4235975" y="5437111"/>
+            <a:ext cx="5898681" cy="3612647"/>
             <a:chOff x="1301" y="464"/>
             <a:chExt cx="16514" cy="10114"/>
           </a:xfrm>
@@ -11288,8 +11336,8 @@
         </p:nvGrpSpPr>
         <p:grpSpPr>
           <a:xfrm>
-            <a:off x="1949187" y="5311357"/>
-            <a:ext cx="3769427" cy="3889086"/>
+            <a:off x="5099459" y="5311396"/>
+            <a:ext cx="3769455" cy="3889114"/>
             <a:chOff x="5457" y="1090"/>
             <a:chExt cx="10553" cy="10888"/>
           </a:xfrm>
@@ -11516,7 +11564,7 @@
             <p:spPr>
               <a:xfrm>
                 <a:off x="8099" y="8058"/>
-                <a:ext cx="2116" cy="1102"/>
+                <a:ext cx="2116" cy="1022"/>
               </a:xfrm>
               <a:prstGeom prst="rect">
                 <a:avLst/>
@@ -11563,7 +11611,7 @@
             <p:spPr>
               <a:xfrm>
                 <a:off x="3143" y="2576"/>
-                <a:ext cx="933" cy="910"/>
+                <a:ext cx="933" cy="844"/>
               </a:xfrm>
               <a:prstGeom prst="rect">
                 <a:avLst/>
@@ -11594,7 +11642,7 @@
             <p:spPr>
               <a:xfrm>
                 <a:off x="4118" y="2576"/>
-                <a:ext cx="933" cy="910"/>
+                <a:ext cx="933" cy="844"/>
               </a:xfrm>
               <a:prstGeom prst="rect">
                 <a:avLst/>
@@ -11625,7 +11673,7 @@
             <p:spPr>
               <a:xfrm>
                 <a:off x="5642" y="2576"/>
-                <a:ext cx="933" cy="910"/>
+                <a:ext cx="933" cy="844"/>
               </a:xfrm>
               <a:prstGeom prst="rect">
                 <a:avLst/>
@@ -11656,7 +11704,7 @@
             <p:spPr>
               <a:xfrm>
                 <a:off x="6617" y="2576"/>
-                <a:ext cx="933" cy="910"/>
+                <a:ext cx="933" cy="844"/>
               </a:xfrm>
               <a:prstGeom prst="rect">
                 <a:avLst/>
@@ -11687,7 +11735,7 @@
             <p:spPr>
               <a:xfrm>
                 <a:off x="8141" y="2576"/>
-                <a:ext cx="933" cy="910"/>
+                <a:ext cx="933" cy="844"/>
               </a:xfrm>
               <a:prstGeom prst="rect">
                 <a:avLst/>
@@ -11718,7 +11766,7 @@
             <p:spPr>
               <a:xfrm>
                 <a:off x="9116" y="2576"/>
-                <a:ext cx="933" cy="910"/>
+                <a:ext cx="933" cy="844"/>
               </a:xfrm>
               <a:prstGeom prst="rect">
                 <a:avLst/>
@@ -12307,8 +12355,8 @@
         </p:nvGrpSpPr>
         <p:grpSpPr>
           <a:xfrm>
-            <a:off x="1357322" y="9564063"/>
-            <a:ext cx="5570380" cy="417912"/>
+            <a:off x="4507590" y="9564133"/>
+            <a:ext cx="5570421" cy="417915"/>
             <a:chOff x="3800" y="12996"/>
             <a:chExt cx="15595" cy="1170"/>
           </a:xfrm>
@@ -12827,8 +12875,8 @@
         </p:nvGrpSpPr>
         <p:grpSpPr>
           <a:xfrm>
-            <a:off x="0" y="5230990"/>
-            <a:ext cx="8100000" cy="4051397"/>
+            <a:off x="3150258" y="5231028"/>
+            <a:ext cx="8100059" cy="4051427"/>
             <a:chOff x="0" y="865"/>
             <a:chExt cx="22677" cy="11342"/>
           </a:xfrm>
@@ -15124,8 +15172,8 @@
         </p:blipFill>
         <p:spPr>
           <a:xfrm>
-            <a:off x="3931592" y="9654789"/>
-            <a:ext cx="3248287" cy="2563554"/>
+            <a:off x="7081879" y="9654860"/>
+            <a:ext cx="3248311" cy="2563573"/>
           </a:xfrm>
           <a:prstGeom prst="rect">
             <a:avLst/>
@@ -15147,8 +15195,8 @@
         </p:blipFill>
         <p:spPr>
           <a:xfrm>
-            <a:off x="357547" y="9663362"/>
-            <a:ext cx="3248287" cy="2563554"/>
+            <a:off x="3507808" y="9663433"/>
+            <a:ext cx="3248311" cy="2563573"/>
           </a:xfrm>
           <a:prstGeom prst="rect">
             <a:avLst/>
@@ -15163,8 +15211,8 @@
         </p:nvSpPr>
         <p:spPr>
           <a:xfrm>
-            <a:off x="174666" y="5370651"/>
-            <a:ext cx="7104512" cy="3814791"/>
+            <a:off x="3324925" y="5370690"/>
+            <a:ext cx="7104564" cy="3814819"/>
           </a:xfrm>
           <a:prstGeom prst="rect">
             <a:avLst/>
@@ -15209,8 +15257,8 @@
         </p:nvGrpSpPr>
         <p:grpSpPr>
           <a:xfrm>
-            <a:off x="231102" y="5443875"/>
-            <a:ext cx="6929846" cy="3798360"/>
+            <a:off x="3381362" y="5443915"/>
+            <a:ext cx="6929897" cy="3798388"/>
             <a:chOff x="410845" y="927735"/>
             <a:chExt cx="12319635" cy="6752590"/>
           </a:xfrm>
@@ -16891,7 +16939,7 @@
           <p:spPr>
             <a:xfrm>
               <a:off x="2385695" y="1859280"/>
-              <a:ext cx="1438275" cy="996802"/>
+              <a:ext cx="1438275" cy="996794"/>
             </a:xfrm>
             <a:prstGeom prst="rect">
               <a:avLst/>
@@ -16959,7 +17007,7 @@
           <p:spPr>
             <a:xfrm>
               <a:off x="4068445" y="1859280"/>
-              <a:ext cx="1438275" cy="996802"/>
+              <a:ext cx="1438275" cy="996794"/>
             </a:xfrm>
             <a:prstGeom prst="rect">
               <a:avLst/>
@@ -17036,7 +17084,7 @@
           <p:spPr>
             <a:xfrm>
               <a:off x="1639570" y="5347970"/>
-              <a:ext cx="1438275" cy="996802"/>
+              <a:ext cx="1438275" cy="996794"/>
             </a:xfrm>
             <a:prstGeom prst="rect">
               <a:avLst/>
@@ -17104,7 +17152,7 @@
           <p:spPr>
             <a:xfrm>
               <a:off x="4897120" y="5347970"/>
-              <a:ext cx="1438275" cy="996802"/>
+              <a:ext cx="1438275" cy="996794"/>
             </a:xfrm>
             <a:prstGeom prst="rect">
               <a:avLst/>
@@ -17181,7 +17229,7 @@
           <p:spPr>
             <a:xfrm>
               <a:off x="7593965" y="1859280"/>
-              <a:ext cx="1438275" cy="717968"/>
+              <a:ext cx="1438275" cy="717963"/>
             </a:xfrm>
             <a:prstGeom prst="rect">
               <a:avLst/>
@@ -17249,7 +17297,7 @@
           <p:spPr>
             <a:xfrm>
               <a:off x="7593965" y="5347970"/>
-              <a:ext cx="1438275" cy="717968"/>
+              <a:ext cx="1438275" cy="717963"/>
             </a:xfrm>
             <a:prstGeom prst="rect">
               <a:avLst/>
@@ -17317,7 +17365,7 @@
           <p:spPr>
             <a:xfrm>
               <a:off x="10901680" y="5347970"/>
-              <a:ext cx="1438275" cy="717968"/>
+              <a:ext cx="1438275" cy="717963"/>
             </a:xfrm>
             <a:prstGeom prst="rect">
               <a:avLst/>
@@ -17394,7 +17442,7 @@
           <p:spPr>
             <a:xfrm>
               <a:off x="10901680" y="1859280"/>
-              <a:ext cx="1438275" cy="717968"/>
+              <a:ext cx="1438275" cy="717963"/>
             </a:xfrm>
             <a:prstGeom prst="rect">
               <a:avLst/>
@@ -17496,8 +17544,8 @@
         </p:nvGrpSpPr>
         <p:grpSpPr>
           <a:xfrm>
-            <a:off x="-32147" y="5140978"/>
-            <a:ext cx="8440760" cy="3483675"/>
+            <a:off x="675878" y="5314333"/>
+            <a:ext cx="8440822" cy="3483701"/>
             <a:chOff x="-90" y="613"/>
             <a:chExt cx="23631" cy="9753"/>
           </a:xfrm>
@@ -19137,8 +19185,8 @@
         </p:nvSpPr>
         <p:spPr>
           <a:xfrm>
-            <a:off x="3340442" y="5911437"/>
-            <a:ext cx="709380" cy="403860"/>
+            <a:off x="6490725" y="5911480"/>
+            <a:ext cx="709385" cy="403860"/>
           </a:xfrm>
           <a:prstGeom prst="rect">
             <a:avLst/>
@@ -19182,8 +19230,8 @@
         </p:nvCxnSpPr>
         <p:spPr>
           <a:xfrm>
-            <a:off x="435772" y="6978721"/>
-            <a:ext cx="2202434" cy="0"/>
+            <a:off x="3586033" y="6978772"/>
+            <a:ext cx="2202450" cy="0"/>
           </a:xfrm>
           <a:prstGeom prst="line">
             <a:avLst/>
@@ -19221,8 +19269,8 @@
         </p:nvCxnSpPr>
         <p:spPr>
           <a:xfrm>
-            <a:off x="1726300" y="5849286"/>
-            <a:ext cx="0" cy="1985620"/>
+            <a:off x="4876571" y="5849329"/>
+            <a:ext cx="0" cy="1985635"/>
           </a:xfrm>
           <a:prstGeom prst="line">
             <a:avLst/>
@@ -19260,8 +19308,8 @@
         </p:nvCxnSpPr>
         <p:spPr>
           <a:xfrm>
-            <a:off x="3121842" y="6812270"/>
-            <a:ext cx="2202434" cy="0"/>
+            <a:off x="6272123" y="6812320"/>
+            <a:ext cx="2202450" cy="0"/>
           </a:xfrm>
           <a:prstGeom prst="line">
             <a:avLst/>
@@ -19299,8 +19347,8 @@
         </p:nvCxnSpPr>
         <p:spPr>
           <a:xfrm>
-            <a:off x="4113759" y="5854644"/>
-            <a:ext cx="0" cy="1985620"/>
+            <a:off x="7264047" y="5854687"/>
+            <a:ext cx="0" cy="1985635"/>
           </a:xfrm>
           <a:prstGeom prst="line">
             <a:avLst/>
@@ -19338,8 +19386,8 @@
         </p:nvCxnSpPr>
         <p:spPr>
           <a:xfrm>
-            <a:off x="5833986" y="6830487"/>
-            <a:ext cx="2202434" cy="0"/>
+            <a:off x="8984287" y="6830537"/>
+            <a:ext cx="2202450" cy="0"/>
           </a:xfrm>
           <a:prstGeom prst="line">
             <a:avLst/>
@@ -19377,8 +19425,8 @@
         </p:nvCxnSpPr>
         <p:spPr>
           <a:xfrm>
-            <a:off x="7133087" y="5882504"/>
-            <a:ext cx="0" cy="1985620"/>
+            <a:off x="10283397" y="5882547"/>
+            <a:ext cx="0" cy="1985635"/>
           </a:xfrm>
           <a:prstGeom prst="line">
             <a:avLst/>
@@ -19416,8 +19464,8 @@
         </p:nvSpPr>
         <p:spPr>
           <a:xfrm>
-            <a:off x="4614896" y="6840131"/>
-            <a:ext cx="709380" cy="403860"/>
+            <a:off x="7765188" y="6840181"/>
+            <a:ext cx="709385" cy="403860"/>
           </a:xfrm>
           <a:prstGeom prst="rect">
             <a:avLst/>
@@ -19491,7 +19539,7 @@
               </p:nvPr>
             </p:nvGraphicFramePr>
             <p:xfrm>
-              <a:off x="5468224" y="10530620"/>
+              <a:off x="8618522" y="10530697"/>
               <a:ext cx="1976120" cy="1359535"/>
             </p:xfrm>
             <a:graphic>
@@ -20119,7 +20167,7 @@
               </p:nvPr>
             </p:nvGraphicFramePr>
             <p:xfrm>
-              <a:off x="5468224" y="10530620"/>
+              <a:off x="8618522" y="10530697"/>
               <a:ext cx="1976120" cy="1359535"/>
             </p:xfrm>
             <a:graphic>
@@ -20554,8 +20602,8 @@
         </p:nvGrpSpPr>
         <p:grpSpPr>
           <a:xfrm>
-            <a:off x="98584" y="10141282"/>
-            <a:ext cx="7345972" cy="2647136"/>
+            <a:off x="3248843" y="10141356"/>
+            <a:ext cx="7346026" cy="2647155"/>
             <a:chOff x="992" y="61"/>
             <a:chExt cx="20566" cy="7411"/>
           </a:xfrm>
@@ -20833,8 +20881,8 @@
         </p:nvSpPr>
         <p:spPr>
           <a:xfrm>
-            <a:off x="5888994" y="9540131"/>
-            <a:ext cx="1980262" cy="560705"/>
+            <a:off x="9039295" y="9540201"/>
+            <a:ext cx="1980276" cy="560705"/>
           </a:xfrm>
           <a:prstGeom prst="rect">
             <a:avLst/>
@@ -20901,8 +20949,8 @@
         </p:nvGrpSpPr>
         <p:grpSpPr>
           <a:xfrm>
-            <a:off x="61794" y="5136691"/>
-            <a:ext cx="7769242" cy="4196627"/>
+            <a:off x="3212053" y="5136729"/>
+            <a:ext cx="7769299" cy="4196658"/>
             <a:chOff x="109855" y="381635"/>
             <a:chExt cx="13811885" cy="7460615"/>
           </a:xfrm>
@@ -21777,9 +21825,9 @@
             <p:grpSpPr>
               <a:xfrm>
                 <a:off x="245" y="6378"/>
-                <a:ext cx="15881" cy="5968"/>
+                <a:ext cx="15881" cy="5951"/>
                 <a:chOff x="503" y="6892"/>
-                <a:chExt cx="15881" cy="5968"/>
+                <a:chExt cx="15881" cy="5951"/>
               </a:xfrm>
             </p:grpSpPr>
             <p:grpSp>
@@ -22188,7 +22236,7 @@
               <p:spPr>
                 <a:xfrm>
                   <a:off x="6206" y="12102"/>
-                  <a:ext cx="4497" cy="756"/>
+                  <a:ext cx="4497" cy="741"/>
                 </a:xfrm>
                 <a:prstGeom prst="rect">
                   <a:avLst/>
@@ -22219,7 +22267,7 @@
               <p:spPr>
                 <a:xfrm>
                   <a:off x="11602" y="12102"/>
-                  <a:ext cx="4497" cy="758"/>
+                  <a:ext cx="4497" cy="741"/>
                 </a:xfrm>
                 <a:prstGeom prst="rect">
                   <a:avLst/>
@@ -22302,7 +22350,7 @@
               <p:nvPr/>
             </p:nvGraphicFramePr>
             <p:xfrm>
-              <a:off x="1215161" y="6664036"/>
+              <a:off x="4365428" y="6664085"/>
               <a:ext cx="5669280" cy="1869440"/>
             </p:xfrm>
             <a:graphic>
@@ -22818,7 +22866,7 @@
               <p:nvPr/>
             </p:nvGraphicFramePr>
             <p:xfrm>
-              <a:off x="1215161" y="6664036"/>
+              <a:off x="4365428" y="6664085"/>
               <a:ext cx="5669280" cy="1869440"/>
             </p:xfrm>
             <a:graphic>
@@ -23231,8 +23279,8 @@
         </p:nvGrpSpPr>
         <p:grpSpPr>
           <a:xfrm>
-            <a:off x="161093" y="5368508"/>
-            <a:ext cx="7523853" cy="3687631"/>
+            <a:off x="3311352" y="5368547"/>
+            <a:ext cx="7523908" cy="3687658"/>
             <a:chOff x="451" y="1250"/>
             <a:chExt cx="21064" cy="10324"/>
           </a:xfrm>
@@ -24854,7 +24902,7 @@
               <p:spPr>
                 <a:xfrm>
                   <a:off x="9775" y="1246"/>
-                  <a:ext cx="3227" cy="786"/>
+                  <a:ext cx="3227" cy="741"/>
                 </a:xfrm>
                 <a:prstGeom prst="rect">
                   <a:avLst/>
@@ -24934,7 +24982,7 @@
               <p:spPr>
                 <a:xfrm>
                   <a:off x="9775" y="1875"/>
-                  <a:ext cx="4784" cy="1302"/>
+                  <a:ext cx="4784" cy="1228"/>
                 </a:xfrm>
                 <a:prstGeom prst="rect">
                   <a:avLst/>
@@ -25002,8 +25050,8 @@
         </p:blipFill>
         <p:spPr>
           <a:xfrm>
-            <a:off x="183239" y="9709797"/>
-            <a:ext cx="2053129" cy="2057415"/>
+            <a:off x="3333498" y="9709868"/>
+            <a:ext cx="2053144" cy="2057430"/>
           </a:xfrm>
           <a:prstGeom prst="rect">
             <a:avLst/>
@@ -25018,8 +25066,8 @@
         </p:nvGrpSpPr>
         <p:grpSpPr>
           <a:xfrm>
-            <a:off x="36791" y="5614255"/>
-            <a:ext cx="8022133" cy="3059333"/>
+            <a:off x="3187049" y="5614296"/>
+            <a:ext cx="8022192" cy="3059355"/>
             <a:chOff x="103" y="1938"/>
             <a:chExt cx="22459" cy="8565"/>
           </a:xfrm>
@@ -26067,7 +26115,7 @@
                     <a:avLst/>
                   </a:prstGeom>
                   <a:blipFill rotWithShape="1">
-                    <a:blip r:embed="rId12"/>
+                    <a:blip r:embed="rId7"/>
                   </a:blipFill>
                 </p:spPr>
                 <p:txBody>
@@ -26154,7 +26202,7 @@
                     <a:avLst/>
                   </a:prstGeom>
                   <a:blipFill rotWithShape="1">
-                    <a:blip r:embed="rId8"/>
+                    <a:blip r:embed="rId12"/>
                   </a:blipFill>
                 </p:spPr>
                 <p:txBody>
@@ -26619,7 +26667,7 @@
                     <a:avLst/>
                   </a:prstGeom>
                   <a:blipFill rotWithShape="1">
-                    <a:blip r:embed="rId5"/>
+                    <a:blip r:embed="rId13"/>
                   </a:blipFill>
                 </p:spPr>
                 <p:txBody>
@@ -26817,7 +26865,7 @@
                     <a:avLst/>
                   </a:prstGeom>
                   <a:blipFill rotWithShape="1">
-                    <a:blip r:embed="rId12"/>
+                    <a:blip r:embed="rId14"/>
                   </a:blipFill>
                 </p:spPr>
                 <p:txBody>
@@ -27633,8 +27681,8 @@
         </p:nvGrpSpPr>
         <p:grpSpPr>
           <a:xfrm>
-            <a:off x="2537479" y="9642288"/>
-            <a:ext cx="4575606" cy="622582"/>
+            <a:off x="5687756" y="9642359"/>
+            <a:ext cx="4575639" cy="622587"/>
             <a:chOff x="6709" y="10473"/>
             <a:chExt cx="12810" cy="1743"/>
           </a:xfrm>
@@ -27812,7 +27860,7 @@
                   <a:avLst/>
                 </a:prstGeom>
                 <a:blipFill rotWithShape="1">
-                  <a:blip r:embed="rId13"/>
+                  <a:blip r:embed="rId15"/>
                 </a:blipFill>
               </p:spPr>
               <p:txBody>
@@ -27969,7 +28017,7 @@
                   <a:avLst/>
                 </a:prstGeom>
                 <a:blipFill rotWithShape="1">
-                  <a:blip r:embed="rId14"/>
+                  <a:blip r:embed="rId16"/>
                 </a:blipFill>
               </p:spPr>
               <p:txBody>
@@ -28126,7 +28174,7 @@
                   <a:avLst/>
                 </a:prstGeom>
                 <a:blipFill rotWithShape="1">
-                  <a:blip r:embed="rId15"/>
+                  <a:blip r:embed="rId17"/>
                 </a:blipFill>
               </p:spPr>
               <p:txBody>
@@ -28186,8 +28234,8 @@
         </p:nvGrpSpPr>
         <p:grpSpPr>
           <a:xfrm>
-            <a:off x="1097288" y="5312072"/>
-            <a:ext cx="5892208" cy="3737637"/>
+            <a:off x="4247554" y="5312111"/>
+            <a:ext cx="5892251" cy="3737664"/>
             <a:chOff x="1333" y="114"/>
             <a:chExt cx="16496" cy="10464"/>
           </a:xfrm>
@@ -30831,8 +30879,8 @@
         </p:nvGrpSpPr>
         <p:grpSpPr>
           <a:xfrm>
-            <a:off x="621005" y="5397781"/>
-            <a:ext cx="6883768" cy="3555471"/>
+            <a:off x="3771268" y="5397821"/>
+            <a:ext cx="6883818" cy="3555497"/>
             <a:chOff x="0" y="354"/>
             <a:chExt cx="19272" cy="9954"/>
           </a:xfrm>
@@ -33500,8 +33548,8 @@
         </p:nvSpPr>
         <p:spPr>
           <a:xfrm>
-            <a:off x="3717486" y="6026792"/>
-            <a:ext cx="841183" cy="333375"/>
+            <a:off x="6867771" y="6026836"/>
+            <a:ext cx="841189" cy="333375"/>
           </a:xfrm>
           <a:prstGeom prst="rect">
             <a:avLst/>
@@ -33587,8 +33635,8 @@
         </p:nvGrpSpPr>
         <p:grpSpPr>
           <a:xfrm>
-            <a:off x="0" y="4383405"/>
-            <a:ext cx="8100060" cy="3554095"/>
+            <a:off x="3150258" y="4383437"/>
+            <a:ext cx="8100119" cy="3554121"/>
             <a:chOff x="0" y="1736"/>
             <a:chExt cx="22678" cy="6706"/>
           </a:xfrm>
@@ -33900,10 +33948,10 @@
         </p:nvGrpSpPr>
         <p:grpSpPr>
           <a:xfrm>
-            <a:off x="85725" y="4052570"/>
-            <a:ext cx="7614920" cy="6424930"/>
+            <a:off x="3235984" y="4052600"/>
+            <a:ext cx="7614976" cy="6425612"/>
             <a:chOff x="135" y="6382"/>
-            <a:chExt cx="11992" cy="10118"/>
+            <a:chExt cx="11992" cy="10119"/>
           </a:xfrm>
         </p:grpSpPr>
         <p:grpSp>
@@ -36692,8 +36740,8 @@
             </p:nvSpPr>
             <p:spPr>
               <a:xfrm>
-                <a:off x="2339407" y="11274047"/>
-                <a:ext cx="3511722" cy="527050"/>
+                <a:off x="5489682" y="11274130"/>
+                <a:ext cx="3511748" cy="527050"/>
               </a:xfrm>
               <a:prstGeom prst="rect">
                 <a:avLst/>
@@ -36758,8 +36806,8 @@
             </p:nvSpPr>
             <p:spPr>
               <a:xfrm>
-                <a:off x="2339407" y="11274047"/>
-                <a:ext cx="3511722" cy="527050"/>
+                <a:off x="5489682" y="11274130"/>
+                <a:ext cx="3511748" cy="527050"/>
               </a:xfrm>
               <a:prstGeom prst="rect">
                 <a:avLst/>
@@ -36767,7 +36815,7 @@
               <a:blipFill rotWithShape="1">
                 <a:blip r:embed="rId1"/>
                 <a:stretch>
-                  <a:fillRect l="-2" t="-49" r="7" b="49"/>
+                  <a:fillRect l="-3" t="-64" r="9" b="64"/>
                 </a:stretch>
               </a:blipFill>
             </p:spPr>
@@ -36794,8 +36842,8 @@
         </p:nvGrpSpPr>
         <p:grpSpPr>
           <a:xfrm>
-            <a:off x="277457" y="5908976"/>
-            <a:ext cx="7614936" cy="2646779"/>
+            <a:off x="3427717" y="5909019"/>
+            <a:ext cx="7614992" cy="2646798"/>
             <a:chOff x="775" y="2740"/>
             <a:chExt cx="21319" cy="7410"/>
           </a:xfrm>
@@ -38105,8 +38153,8 @@
         </p:blipFill>
         <p:spPr>
           <a:xfrm>
-            <a:off x="904279" y="9707044"/>
-            <a:ext cx="2271652" cy="1398427"/>
+            <a:off x="4054544" y="9707115"/>
+            <a:ext cx="2271669" cy="1398437"/>
           </a:xfrm>
           <a:prstGeom prst="rect">
             <a:avLst/>
@@ -38133,8 +38181,8 @@
         </p:blipFill>
         <p:spPr>
           <a:xfrm>
-            <a:off x="3651776" y="9781289"/>
-            <a:ext cx="1792011" cy="993453"/>
+            <a:off x="6802061" y="9781361"/>
+            <a:ext cx="1792024" cy="993460"/>
           </a:xfrm>
           <a:prstGeom prst="rect">
             <a:avLst/>
@@ -38157,8 +38205,8 @@
         </p:blipFill>
         <p:spPr>
           <a:xfrm>
-            <a:off x="5738236" y="9781289"/>
-            <a:ext cx="1673894" cy="927644"/>
+            <a:off x="8888536" y="9781361"/>
+            <a:ext cx="1673906" cy="927651"/>
           </a:xfrm>
           <a:prstGeom prst="rect">
             <a:avLst/>
@@ -38173,10 +38221,10 @@
         </p:nvGrpSpPr>
         <p:grpSpPr>
           <a:xfrm>
-            <a:off x="252730" y="5544185"/>
-            <a:ext cx="7555230" cy="2633345"/>
+            <a:off x="3402990" y="5544226"/>
+            <a:ext cx="7555285" cy="2620287"/>
             <a:chOff x="398" y="8731"/>
-            <a:chExt cx="11898" cy="4147"/>
+            <a:chExt cx="11898" cy="4126"/>
           </a:xfrm>
         </p:grpSpPr>
         <p:grpSp>
@@ -38188,9 +38236,9 @@
           <p:grpSpPr>
             <a:xfrm>
               <a:off x="430" y="9118"/>
-              <a:ext cx="11866" cy="3760"/>
+              <a:ext cx="11866" cy="3739"/>
               <a:chOff x="647" y="2057"/>
-              <a:chExt cx="17861" cy="5660"/>
+              <a:chExt cx="17861" cy="5629"/>
             </a:xfrm>
           </p:grpSpPr>
           <p:grpSp>
@@ -38607,9 +38655,9 @@
             <p:grpSpPr>
               <a:xfrm>
                 <a:off x="7659" y="2455"/>
-                <a:ext cx="3661" cy="5262"/>
+                <a:ext cx="3661" cy="5231"/>
                 <a:chOff x="7722" y="2455"/>
-                <a:chExt cx="3661" cy="5262"/>
+                <a:chExt cx="3661" cy="5231"/>
               </a:xfrm>
             </p:grpSpPr>
             <p:pic>
@@ -38715,9 +38763,9 @@
               <p:grpSpPr>
                 <a:xfrm>
                   <a:off x="8233" y="5693"/>
-                  <a:ext cx="2657" cy="2024"/>
+                  <a:ext cx="2657" cy="1993"/>
                   <a:chOff x="5687" y="5068"/>
-                  <a:chExt cx="2657" cy="2024"/>
+                  <a:chExt cx="2657" cy="1993"/>
                 </a:xfrm>
               </p:grpSpPr>
               <p:cxnSp>
@@ -38836,9 +38884,9 @@
                 <p:grpSpPr>
                   <a:xfrm>
                     <a:off x="5687" y="5068"/>
-                    <a:ext cx="2657" cy="2024"/>
+                    <a:ext cx="2657" cy="1993"/>
                     <a:chOff x="3202" y="5108"/>
-                    <a:chExt cx="2657" cy="2024"/>
+                    <a:chExt cx="2657" cy="1993"/>
                   </a:xfrm>
                 </p:grpSpPr>
                 <p:sp>
@@ -38889,7 +38937,7 @@
                   <p:spPr>
                     <a:xfrm>
                       <a:off x="3202" y="5108"/>
-                      <a:ext cx="446" cy="636"/>
+                      <a:ext cx="446" cy="605"/>
                     </a:xfrm>
                     <a:prstGeom prst="rect">
                       <a:avLst/>
@@ -38925,7 +38973,7 @@
                   <p:spPr>
                     <a:xfrm>
                       <a:off x="5413" y="6496"/>
-                      <a:ext cx="446" cy="636"/>
+                      <a:ext cx="446" cy="605"/>
                     </a:xfrm>
                     <a:prstGeom prst="rect">
                       <a:avLst/>
@@ -38964,9 +39012,9 @@
             <p:grpSpPr>
               <a:xfrm>
                 <a:off x="14741" y="2761"/>
-                <a:ext cx="3767" cy="4956"/>
+                <a:ext cx="3767" cy="4925"/>
                 <a:chOff x="14737" y="2761"/>
-                <a:chExt cx="3767" cy="4956"/>
+                <a:chExt cx="3767" cy="4925"/>
               </a:xfrm>
             </p:grpSpPr>
             <p:pic>
@@ -39083,9 +39131,9 @@
               <p:grpSpPr>
                 <a:xfrm>
                   <a:off x="15354" y="5693"/>
-                  <a:ext cx="2657" cy="2024"/>
+                  <a:ext cx="2657" cy="1993"/>
                   <a:chOff x="10870" y="5054"/>
-                  <a:chExt cx="2657" cy="2024"/>
+                  <a:chExt cx="2657" cy="1993"/>
                 </a:xfrm>
               </p:grpSpPr>
               <p:sp>
@@ -39248,9 +39296,9 @@
                 <p:grpSpPr>
                   <a:xfrm>
                     <a:off x="10870" y="5054"/>
-                    <a:ext cx="2657" cy="2024"/>
+                    <a:ext cx="2657" cy="1993"/>
                     <a:chOff x="3202" y="5108"/>
-                    <a:chExt cx="2657" cy="2024"/>
+                    <a:chExt cx="2657" cy="1993"/>
                   </a:xfrm>
                 </p:grpSpPr>
                 <p:sp>
@@ -39301,7 +39349,7 @@
                   <p:spPr>
                     <a:xfrm>
                       <a:off x="3202" y="5108"/>
-                      <a:ext cx="446" cy="636"/>
+                      <a:ext cx="446" cy="605"/>
                     </a:xfrm>
                     <a:prstGeom prst="rect">
                       <a:avLst/>
@@ -39337,7 +39385,7 @@
                   <p:spPr>
                     <a:xfrm>
                       <a:off x="5413" y="6496"/>
-                      <a:ext cx="446" cy="636"/>
+                      <a:ext cx="446" cy="605"/>
                     </a:xfrm>
                     <a:prstGeom prst="rect">
                       <a:avLst/>
@@ -39376,9 +39424,9 @@
             <p:grpSpPr>
               <a:xfrm>
                 <a:off x="11209" y="2584"/>
-                <a:ext cx="3643" cy="5133"/>
+                <a:ext cx="3643" cy="5102"/>
                 <a:chOff x="11192" y="2584"/>
-                <a:chExt cx="3643" cy="5133"/>
+                <a:chExt cx="3643" cy="5102"/>
               </a:xfrm>
             </p:grpSpPr>
             <p:pic>
@@ -39496,9 +39544,9 @@
               <p:grpSpPr>
                 <a:xfrm>
                   <a:off x="11686" y="5693"/>
-                  <a:ext cx="2657" cy="2024"/>
+                  <a:ext cx="2657" cy="1993"/>
                   <a:chOff x="8290" y="5068"/>
-                  <a:chExt cx="2657" cy="2024"/>
+                  <a:chExt cx="2657" cy="1993"/>
                 </a:xfrm>
               </p:grpSpPr>
               <p:grpSp>
@@ -39510,9 +39558,9 @@
                 <p:grpSpPr>
                   <a:xfrm>
                     <a:off x="8290" y="5068"/>
-                    <a:ext cx="2657" cy="2024"/>
+                    <a:ext cx="2657" cy="1993"/>
                     <a:chOff x="3202" y="5108"/>
-                    <a:chExt cx="2657" cy="2024"/>
+                    <a:chExt cx="2657" cy="1993"/>
                   </a:xfrm>
                 </p:grpSpPr>
                 <p:cxnSp>
@@ -39596,9 +39644,9 @@
                   <p:grpSpPr>
                     <a:xfrm>
                       <a:off x="3202" y="5108"/>
-                      <a:ext cx="2657" cy="2024"/>
+                      <a:ext cx="2657" cy="1993"/>
                       <a:chOff x="3202" y="5108"/>
-                      <a:chExt cx="2657" cy="2024"/>
+                      <a:chExt cx="2657" cy="1993"/>
                     </a:xfrm>
                   </p:grpSpPr>
                   <p:sp>
@@ -39649,7 +39697,7 @@
                     <p:spPr>
                       <a:xfrm>
                         <a:off x="3202" y="5108"/>
-                        <a:ext cx="446" cy="636"/>
+                        <a:ext cx="446" cy="605"/>
                       </a:xfrm>
                       <a:prstGeom prst="rect">
                         <a:avLst/>
@@ -39685,7 +39733,7 @@
                     <p:spPr>
                       <a:xfrm>
                         <a:off x="5413" y="6496"/>
-                        <a:ext cx="446" cy="636"/>
+                        <a:ext cx="446" cy="605"/>
                       </a:xfrm>
                       <a:prstGeom prst="rect">
                         <a:avLst/>
@@ -39806,9 +39854,9 @@
             <p:grpSpPr>
               <a:xfrm>
                 <a:off x="4087" y="2348"/>
-                <a:ext cx="3683" cy="5369"/>
+                <a:ext cx="3683" cy="5338"/>
                 <a:chOff x="4198" y="2348"/>
-                <a:chExt cx="3683" cy="5369"/>
+                <a:chExt cx="3683" cy="5338"/>
               </a:xfrm>
             </p:grpSpPr>
             <p:sp>
@@ -39924,9 +39972,9 @@
               <p:grpSpPr>
                 <a:xfrm>
                   <a:off x="4712" y="5693"/>
-                  <a:ext cx="2657" cy="2024"/>
+                  <a:ext cx="2657" cy="1993"/>
                   <a:chOff x="4673" y="5693"/>
-                  <a:chExt cx="2657" cy="2024"/>
+                  <a:chExt cx="2657" cy="1993"/>
                 </a:xfrm>
               </p:grpSpPr>
               <p:grpSp>
@@ -39938,9 +39986,9 @@
                 <p:grpSpPr>
                   <a:xfrm>
                     <a:off x="4673" y="5693"/>
-                    <a:ext cx="2657" cy="2024"/>
+                    <a:ext cx="2657" cy="1993"/>
                     <a:chOff x="10870" y="5054"/>
-                    <a:chExt cx="2657" cy="2024"/>
+                    <a:chExt cx="2657" cy="1993"/>
                   </a:xfrm>
                 </p:grpSpPr>
                 <p:cxnSp>
@@ -40024,9 +40072,9 @@
                   <p:grpSpPr>
                     <a:xfrm>
                       <a:off x="10870" y="5054"/>
-                      <a:ext cx="2657" cy="2024"/>
+                      <a:ext cx="2657" cy="1993"/>
                       <a:chOff x="3202" y="5108"/>
-                      <a:chExt cx="2657" cy="2024"/>
+                      <a:chExt cx="2657" cy="1993"/>
                     </a:xfrm>
                   </p:grpSpPr>
                   <p:sp>
@@ -40077,7 +40125,7 @@
                     <p:spPr>
                       <a:xfrm>
                         <a:off x="3202" y="5108"/>
-                        <a:ext cx="446" cy="636"/>
+                        <a:ext cx="446" cy="605"/>
                       </a:xfrm>
                       <a:prstGeom prst="rect">
                         <a:avLst/>
@@ -40113,7 +40161,7 @@
                     <p:spPr>
                       <a:xfrm>
                         <a:off x="5413" y="6496"/>
-                        <a:ext cx="446" cy="636"/>
+                        <a:ext cx="446" cy="605"/>
                       </a:xfrm>
                       <a:prstGeom prst="rect">
                         <a:avLst/>
@@ -40305,8 +40353,8 @@
         </p:nvGrpSpPr>
         <p:grpSpPr>
           <a:xfrm>
-            <a:off x="9769283" y="5287934"/>
-            <a:ext cx="5570380" cy="417912"/>
+            <a:off x="12919613" y="5287973"/>
+            <a:ext cx="5570421" cy="417915"/>
             <a:chOff x="1984" y="9408"/>
             <a:chExt cx="15595" cy="1170"/>
           </a:xfrm>
@@ -40825,8 +40873,8 @@
         </p:nvGrpSpPr>
         <p:grpSpPr>
           <a:xfrm>
-            <a:off x="915121" y="5192056"/>
-            <a:ext cx="6587657" cy="3602262"/>
+            <a:off x="4065386" y="5192094"/>
+            <a:ext cx="6587705" cy="3602288"/>
             <a:chOff x="2562" y="774"/>
             <a:chExt cx="18443" cy="10085"/>
           </a:xfrm>
@@ -42138,9 +42186,9 @@
           <p:grpSpPr>
             <a:xfrm>
               <a:off x="10646" y="774"/>
-              <a:ext cx="10359" cy="8317"/>
+              <a:ext cx="10359" cy="8463"/>
               <a:chOff x="10646" y="774"/>
-              <a:chExt cx="10359" cy="8317"/>
+              <a:chExt cx="10359" cy="8463"/>
             </a:xfrm>
           </p:grpSpPr>
           <p:pic>
@@ -42438,9 +42486,9 @@
             <p:grpSpPr>
               <a:xfrm>
                 <a:off x="11207" y="1844"/>
-                <a:ext cx="8319" cy="7247"/>
+                <a:ext cx="8319" cy="7393"/>
                 <a:chOff x="9406" y="1694"/>
-                <a:chExt cx="8319" cy="7247"/>
+                <a:chExt cx="8319" cy="7393"/>
               </a:xfrm>
             </p:grpSpPr>
             <p:sp>
@@ -42610,7 +42658,7 @@
               </p:nvSpPr>
               <p:spPr>
                 <a:xfrm>
-                  <a:off x="14839" y="8428"/>
+                  <a:off x="14812" y="8574"/>
                   <a:ext cx="2741" cy="513"/>
                 </a:xfrm>
                 <a:prstGeom prst="rect">
@@ -42948,8 +42996,8 @@
         </p:nvCxnSpPr>
         <p:spPr>
           <a:xfrm>
-            <a:off x="368977" y="4559115"/>
-            <a:ext cx="7615293" cy="0"/>
+            <a:off x="3519238" y="4559148"/>
+            <a:ext cx="7615349" cy="0"/>
           </a:xfrm>
           <a:prstGeom prst="line">
             <a:avLst/>
@@ -42983,8 +43031,8 @@
         </p:nvGrpSpPr>
         <p:grpSpPr>
           <a:xfrm>
-            <a:off x="8342890" y="4247645"/>
-            <a:ext cx="1544847" cy="513639"/>
+            <a:off x="11493209" y="4247676"/>
+            <a:ext cx="1544858" cy="513643"/>
             <a:chOff x="2166" y="1724"/>
             <a:chExt cx="19159" cy="6372"/>
           </a:xfrm>
@@ -43142,8 +43190,8 @@
         </p:nvGrpSpPr>
         <p:grpSpPr>
           <a:xfrm>
-            <a:off x="8921314" y="6387008"/>
-            <a:ext cx="8195727" cy="1489126"/>
+            <a:off x="12071637" y="6387055"/>
+            <a:ext cx="8195787" cy="1489137"/>
             <a:chOff x="186" y="3371"/>
             <a:chExt cx="22945" cy="4169"/>
           </a:xfrm>
@@ -44353,8 +44401,8 @@
         </p:nvSpPr>
         <p:spPr>
           <a:xfrm>
-            <a:off x="1394113" y="4251217"/>
-            <a:ext cx="5580381" cy="299085"/>
+            <a:off x="4544381" y="4251248"/>
+            <a:ext cx="5580422" cy="299085"/>
           </a:xfrm>
           <a:prstGeom prst="rect">
             <a:avLst/>
@@ -44417,8 +44465,8 @@
         </p:nvSpPr>
         <p:spPr>
           <a:xfrm>
-            <a:off x="405765" y="5311140"/>
-            <a:ext cx="7552055" cy="3522980"/>
+            <a:off x="3556026" y="5311179"/>
+            <a:ext cx="7552110" cy="3523006"/>
           </a:xfrm>
           <a:prstGeom prst="rect">
             <a:avLst/>
@@ -44470,8 +44518,8 @@
         </p:blipFill>
         <p:spPr>
           <a:xfrm>
-            <a:off x="3884930" y="5594350"/>
-            <a:ext cx="3516630" cy="2230755"/>
+            <a:off x="7035217" y="5594391"/>
+            <a:ext cx="3516656" cy="2230771"/>
           </a:xfrm>
           <a:prstGeom prst="rect">
             <a:avLst/>
@@ -44493,8 +44541,8 @@
         </p:blipFill>
         <p:spPr>
           <a:xfrm>
-            <a:off x="405130" y="5618480"/>
-            <a:ext cx="3310890" cy="2169795"/>
+            <a:off x="3555391" y="5618521"/>
+            <a:ext cx="3310914" cy="2169811"/>
           </a:xfrm>
           <a:prstGeom prst="rect">
             <a:avLst/>
@@ -44509,8 +44557,8 @@
         </p:nvSpPr>
         <p:spPr>
           <a:xfrm>
-            <a:off x="4417060" y="7767320"/>
-            <a:ext cx="630555" cy="247650"/>
+            <a:off x="7567350" y="7767377"/>
+            <a:ext cx="630560" cy="247650"/>
           </a:xfrm>
           <a:prstGeom prst="rect">
             <a:avLst/>
@@ -44540,8 +44588,8 @@
         </p:nvSpPr>
         <p:spPr>
           <a:xfrm>
-            <a:off x="5227320" y="7766050"/>
-            <a:ext cx="1116330" cy="403860"/>
+            <a:off x="8377616" y="7766107"/>
+            <a:ext cx="1116338" cy="403860"/>
           </a:xfrm>
           <a:prstGeom prst="rect">
             <a:avLst/>
@@ -44571,8 +44619,8 @@
         </p:nvSpPr>
         <p:spPr>
           <a:xfrm>
-            <a:off x="6381115" y="7767955"/>
-            <a:ext cx="712470" cy="403860"/>
+            <a:off x="9531420" y="7768012"/>
+            <a:ext cx="712475" cy="403860"/>
           </a:xfrm>
           <a:prstGeom prst="rect">
             <a:avLst/>
@@ -44618,8 +44666,8 @@
         </p:nvSpPr>
         <p:spPr>
           <a:xfrm>
-            <a:off x="4364355" y="5594350"/>
-            <a:ext cx="367030" cy="333375"/>
+            <a:off x="7514645" y="5594391"/>
+            <a:ext cx="367033" cy="333375"/>
           </a:xfrm>
           <a:prstGeom prst="rect">
             <a:avLst/>
@@ -44649,8 +44697,8 @@
         </p:nvSpPr>
         <p:spPr>
           <a:xfrm>
-            <a:off x="4747895" y="5594350"/>
-            <a:ext cx="367030" cy="333375"/>
+            <a:off x="7898188" y="5594391"/>
+            <a:ext cx="367033" cy="333375"/>
           </a:xfrm>
           <a:prstGeom prst="rect">
             <a:avLst/>
@@ -44680,8 +44728,8 @@
         </p:nvSpPr>
         <p:spPr>
           <a:xfrm>
-            <a:off x="5347335" y="5594350"/>
-            <a:ext cx="367030" cy="333375"/>
+            <a:off x="8497632" y="5594391"/>
+            <a:ext cx="367033" cy="333375"/>
           </a:xfrm>
           <a:prstGeom prst="rect">
             <a:avLst/>
@@ -44711,8 +44759,8 @@
         </p:nvSpPr>
         <p:spPr>
           <a:xfrm>
-            <a:off x="5730875" y="5594350"/>
-            <a:ext cx="367030" cy="333375"/>
+            <a:off x="8881175" y="5594391"/>
+            <a:ext cx="367033" cy="333375"/>
           </a:xfrm>
           <a:prstGeom prst="rect">
             <a:avLst/>
@@ -44742,8 +44790,8 @@
         </p:nvSpPr>
         <p:spPr>
           <a:xfrm>
-            <a:off x="6366510" y="5594350"/>
-            <a:ext cx="367030" cy="333375"/>
+            <a:off x="9516815" y="5594391"/>
+            <a:ext cx="367033" cy="333375"/>
           </a:xfrm>
           <a:prstGeom prst="rect">
             <a:avLst/>
@@ -44773,8 +44821,8 @@
         </p:nvSpPr>
         <p:spPr>
           <a:xfrm>
-            <a:off x="6750050" y="5594350"/>
-            <a:ext cx="367030" cy="333375"/>
+            <a:off x="9900357" y="5594391"/>
+            <a:ext cx="367033" cy="333375"/>
           </a:xfrm>
           <a:prstGeom prst="rect">
             <a:avLst/>
@@ -44804,8 +44852,8 @@
         </p:nvSpPr>
         <p:spPr>
           <a:xfrm>
-            <a:off x="783590" y="8418830"/>
-            <a:ext cx="263525" cy="158115"/>
+            <a:off x="3933854" y="8418892"/>
+            <a:ext cx="263527" cy="158116"/>
           </a:xfrm>
           <a:prstGeom prst="rect">
             <a:avLst/>
@@ -44850,8 +44898,8 @@
         </p:nvSpPr>
         <p:spPr>
           <a:xfrm>
-            <a:off x="1091565" y="8395970"/>
-            <a:ext cx="1217930" cy="352425"/>
+            <a:off x="4241831" y="8396031"/>
+            <a:ext cx="1217939" cy="352425"/>
           </a:xfrm>
           <a:prstGeom prst="rect">
             <a:avLst/>
@@ -44880,8 +44928,8 @@
         </p:nvSpPr>
         <p:spPr>
           <a:xfrm>
-            <a:off x="783590" y="8615680"/>
-            <a:ext cx="263525" cy="158115"/>
+            <a:off x="3933854" y="8615743"/>
+            <a:ext cx="263527" cy="158116"/>
           </a:xfrm>
           <a:prstGeom prst="rect">
             <a:avLst/>
@@ -44926,8 +44974,8 @@
         </p:nvSpPr>
         <p:spPr>
           <a:xfrm>
-            <a:off x="1091565" y="8592185"/>
-            <a:ext cx="1318260" cy="221615"/>
+            <a:off x="4241831" y="8592248"/>
+            <a:ext cx="1318270" cy="221615"/>
           </a:xfrm>
           <a:prstGeom prst="rect">
             <a:avLst/>
@@ -44956,8 +45004,8 @@
         </p:nvSpPr>
         <p:spPr>
           <a:xfrm>
-            <a:off x="2453005" y="8411210"/>
-            <a:ext cx="263525" cy="158115"/>
+            <a:off x="5603281" y="8411272"/>
+            <a:ext cx="263527" cy="158116"/>
           </a:xfrm>
           <a:prstGeom prst="rect">
             <a:avLst/>
@@ -45002,8 +45050,8 @@
         </p:nvSpPr>
         <p:spPr>
           <a:xfrm>
-            <a:off x="2453005" y="8608060"/>
-            <a:ext cx="263525" cy="158115"/>
+            <a:off x="5603281" y="8608123"/>
+            <a:ext cx="263527" cy="158116"/>
           </a:xfrm>
           <a:prstGeom prst="rect">
             <a:avLst/>
@@ -45048,8 +45096,8 @@
         </p:nvSpPr>
         <p:spPr>
           <a:xfrm>
-            <a:off x="2757805" y="8403590"/>
-            <a:ext cx="1442720" cy="221615"/>
+            <a:off x="5908083" y="8403652"/>
+            <a:ext cx="1442731" cy="221615"/>
           </a:xfrm>
           <a:prstGeom prst="rect">
             <a:avLst/>
@@ -45078,8 +45126,8 @@
         </p:nvSpPr>
         <p:spPr>
           <a:xfrm>
-            <a:off x="2757805" y="8584565"/>
-            <a:ext cx="1442720" cy="352425"/>
+            <a:off x="5908083" y="8584628"/>
+            <a:ext cx="1442731" cy="352425"/>
           </a:xfrm>
           <a:prstGeom prst="rect">
             <a:avLst/>
@@ -45108,8 +45156,8 @@
         </p:nvSpPr>
         <p:spPr>
           <a:xfrm>
-            <a:off x="1456055" y="8214360"/>
-            <a:ext cx="2009140" cy="221615"/>
+            <a:off x="4606324" y="8214420"/>
+            <a:ext cx="2009155" cy="221615"/>
           </a:xfrm>
           <a:prstGeom prst="rect">
             <a:avLst/>
@@ -45145,8 +45193,8 @@
         </p:nvSpPr>
         <p:spPr>
           <a:xfrm>
-            <a:off x="405765" y="5311140"/>
-            <a:ext cx="3310255" cy="299085"/>
+            <a:off x="3556026" y="5311179"/>
+            <a:ext cx="3310279" cy="299085"/>
           </a:xfrm>
           <a:prstGeom prst="rect">
             <a:avLst/>
@@ -45176,8 +45224,8 @@
         </p:nvSpPr>
         <p:spPr>
           <a:xfrm>
-            <a:off x="3813175" y="5311140"/>
-            <a:ext cx="3881755" cy="299085"/>
+            <a:off x="6963461" y="5311179"/>
+            <a:ext cx="3881783" cy="299085"/>
           </a:xfrm>
           <a:prstGeom prst="rect">
             <a:avLst/>
@@ -45207,8 +45255,8 @@
         </p:nvSpPr>
         <p:spPr>
           <a:xfrm>
-            <a:off x="4529455" y="8418830"/>
-            <a:ext cx="263525" cy="158115"/>
+            <a:off x="7679746" y="8418892"/>
+            <a:ext cx="263527" cy="158116"/>
           </a:xfrm>
           <a:prstGeom prst="rect">
             <a:avLst/>
@@ -45253,8 +45301,8 @@
         </p:nvSpPr>
         <p:spPr>
           <a:xfrm>
-            <a:off x="4837430" y="8395970"/>
-            <a:ext cx="2009140" cy="221615"/>
+            <a:off x="7987723" y="8396031"/>
+            <a:ext cx="2009155" cy="221615"/>
           </a:xfrm>
           <a:prstGeom prst="rect">
             <a:avLst/>
@@ -45283,8 +45331,8 @@
         </p:nvSpPr>
         <p:spPr>
           <a:xfrm>
-            <a:off x="4529455" y="8615680"/>
-            <a:ext cx="263525" cy="158115"/>
+            <a:off x="7679746" y="8615743"/>
+            <a:ext cx="263527" cy="158116"/>
           </a:xfrm>
           <a:prstGeom prst="rect">
             <a:avLst/>
@@ -45329,8 +45377,8 @@
         </p:nvSpPr>
         <p:spPr>
           <a:xfrm>
-            <a:off x="4837430" y="8599805"/>
-            <a:ext cx="2009775" cy="221615"/>
+            <a:off x="7987723" y="8599868"/>
+            <a:ext cx="2009790" cy="221615"/>
           </a:xfrm>
           <a:prstGeom prst="rect">
             <a:avLst/>
@@ -45359,8 +45407,8 @@
         </p:nvSpPr>
         <p:spPr>
           <a:xfrm>
-            <a:off x="5798185" y="8411210"/>
-            <a:ext cx="263525" cy="158115"/>
+            <a:off x="8948486" y="8411272"/>
+            <a:ext cx="263527" cy="158116"/>
           </a:xfrm>
           <a:prstGeom prst="rect">
             <a:avLst/>
@@ -45405,8 +45453,8 @@
         </p:nvSpPr>
         <p:spPr>
           <a:xfrm>
-            <a:off x="5798185" y="8608060"/>
-            <a:ext cx="263525" cy="158115"/>
+            <a:off x="8948486" y="8608123"/>
+            <a:ext cx="263527" cy="158116"/>
           </a:xfrm>
           <a:prstGeom prst="rect">
             <a:avLst/>
@@ -45451,8 +45499,8 @@
         </p:nvSpPr>
         <p:spPr>
           <a:xfrm>
-            <a:off x="6102985" y="8403590"/>
-            <a:ext cx="1591310" cy="352425"/>
+            <a:off x="9253288" y="8403652"/>
+            <a:ext cx="1591322" cy="352425"/>
           </a:xfrm>
           <a:prstGeom prst="rect">
             <a:avLst/>
@@ -45481,8 +45529,8 @@
         </p:nvSpPr>
         <p:spPr>
           <a:xfrm>
-            <a:off x="6102985" y="8584565"/>
-            <a:ext cx="1591945" cy="352425"/>
+            <a:off x="9253288" y="8584628"/>
+            <a:ext cx="1591957" cy="352425"/>
           </a:xfrm>
           <a:prstGeom prst="rect">
             <a:avLst/>
@@ -45511,8 +45559,8 @@
         </p:nvSpPr>
         <p:spPr>
           <a:xfrm>
-            <a:off x="5074285" y="8191500"/>
-            <a:ext cx="2009140" cy="221615"/>
+            <a:off x="8224580" y="8191560"/>
+            <a:ext cx="2009155" cy="221615"/>
           </a:xfrm>
           <a:prstGeom prst="rect">
             <a:avLst/>
@@ -45548,10 +45596,10 @@
         </p:nvGrpSpPr>
         <p:grpSpPr>
           <a:xfrm rot="0">
-            <a:off x="848995" y="5600700"/>
-            <a:ext cx="2727325" cy="2600960"/>
+            <a:off x="3999259" y="5600741"/>
+            <a:ext cx="2727345" cy="2569375"/>
             <a:chOff x="3143" y="2576"/>
-            <a:chExt cx="6906" cy="6584"/>
+            <a:chExt cx="6906" cy="6504"/>
           </a:xfrm>
         </p:grpSpPr>
         <p:sp>
@@ -45594,7 +45642,7 @@
           <p:spPr>
             <a:xfrm>
               <a:off x="5187" y="8058"/>
-              <a:ext cx="2769" cy="975"/>
+              <a:ext cx="2769" cy="1022"/>
             </a:xfrm>
             <a:prstGeom prst="rect">
               <a:avLst/>
@@ -45625,7 +45673,7 @@
           <p:spPr>
             <a:xfrm>
               <a:off x="8099" y="8058"/>
-              <a:ext cx="1810" cy="1102"/>
+              <a:ext cx="1810" cy="1022"/>
             </a:xfrm>
             <a:prstGeom prst="rect">
               <a:avLst/>
@@ -45672,7 +45720,7 @@
           <p:spPr>
             <a:xfrm>
               <a:off x="3143" y="2576"/>
-              <a:ext cx="933" cy="910"/>
+              <a:ext cx="933" cy="844"/>
             </a:xfrm>
             <a:prstGeom prst="rect">
               <a:avLst/>
@@ -45703,7 +45751,7 @@
           <p:spPr>
             <a:xfrm>
               <a:off x="4118" y="2576"/>
-              <a:ext cx="933" cy="910"/>
+              <a:ext cx="933" cy="844"/>
             </a:xfrm>
             <a:prstGeom prst="rect">
               <a:avLst/>
@@ -45734,7 +45782,7 @@
           <p:spPr>
             <a:xfrm>
               <a:off x="5642" y="2576"/>
-              <a:ext cx="933" cy="910"/>
+              <a:ext cx="933" cy="844"/>
             </a:xfrm>
             <a:prstGeom prst="rect">
               <a:avLst/>
@@ -45765,7 +45813,7 @@
           <p:spPr>
             <a:xfrm>
               <a:off x="6617" y="2576"/>
-              <a:ext cx="933" cy="910"/>
+              <a:ext cx="933" cy="844"/>
             </a:xfrm>
             <a:prstGeom prst="rect">
               <a:avLst/>
@@ -45796,7 +45844,7 @@
           <p:spPr>
             <a:xfrm>
               <a:off x="8141" y="2576"/>
-              <a:ext cx="933" cy="910"/>
+              <a:ext cx="933" cy="844"/>
             </a:xfrm>
             <a:prstGeom prst="rect">
               <a:avLst/>
@@ -45827,7 +45875,7 @@
           <p:spPr>
             <a:xfrm>
               <a:off x="9116" y="2576"/>
-              <a:ext cx="933" cy="910"/>
+              <a:ext cx="933" cy="844"/>
             </a:xfrm>
             <a:prstGeom prst="rect">
               <a:avLst/>

</xml_diff>